<commit_message>
Final PowerPoint Presentation (Unless otherwise)
Final presentation. If changes are needed, tell me and I'll get on to change it
</commit_message>
<xml_diff>
--- a/RSA Encryption.pptx
+++ b/RSA Encryption.pptx
@@ -40,6 +40,7 @@
     <p:embeddedFont>
       <p:font typeface="Open Sans" panose="020B0606030504020204" pitchFamily="34" charset="0"/>
       <p:regular r:id="rId15"/>
+      <p:boldItalic r:id="rId16"/>
     </p:embeddedFont>
   </p:embeddedFontLst>
   <p:defaultTextStyle>
@@ -336,7 +337,7 @@
             <a:fld id="{1D8BD707-D9CF-40AE-B4C6-C98DA3205C09}" type="datetimeFigureOut">
               <a:rPr lang="en-US" smtClean="0"/>
               <a:pPr/>
-              <a:t>10/12/2026</a:t>
+              <a:t>10/13/2026</a:t>
             </a:fld>
             <a:endParaRPr lang="en-US"/>
           </a:p>
@@ -501,7 +502,7 @@
             <a:fld id="{1D8BD707-D9CF-40AE-B4C6-C98DA3205C09}" type="datetimeFigureOut">
               <a:rPr lang="en-US" smtClean="0"/>
               <a:pPr/>
-              <a:t>10/12/2026</a:t>
+              <a:t>10/13/2026</a:t>
             </a:fld>
             <a:endParaRPr lang="en-US"/>
           </a:p>
@@ -676,7 +677,7 @@
             <a:fld id="{1D8BD707-D9CF-40AE-B4C6-C98DA3205C09}" type="datetimeFigureOut">
               <a:rPr lang="en-US" smtClean="0"/>
               <a:pPr/>
-              <a:t>10/12/2026</a:t>
+              <a:t>10/13/2026</a:t>
             </a:fld>
             <a:endParaRPr lang="en-US"/>
           </a:p>
@@ -841,7 +842,7 @@
             <a:fld id="{1D8BD707-D9CF-40AE-B4C6-C98DA3205C09}" type="datetimeFigureOut">
               <a:rPr lang="en-US" smtClean="0"/>
               <a:pPr/>
-              <a:t>10/12/2026</a:t>
+              <a:t>10/13/2026</a:t>
             </a:fld>
             <a:endParaRPr lang="en-US"/>
           </a:p>
@@ -1083,7 +1084,7 @@
             <a:fld id="{1D8BD707-D9CF-40AE-B4C6-C98DA3205C09}" type="datetimeFigureOut">
               <a:rPr lang="en-US" smtClean="0"/>
               <a:pPr/>
-              <a:t>10/12/2026</a:t>
+              <a:t>10/13/2026</a:t>
             </a:fld>
             <a:endParaRPr lang="en-US"/>
           </a:p>
@@ -1365,7 +1366,7 @@
             <a:fld id="{1D8BD707-D9CF-40AE-B4C6-C98DA3205C09}" type="datetimeFigureOut">
               <a:rPr lang="en-US" smtClean="0"/>
               <a:pPr/>
-              <a:t>10/12/2026</a:t>
+              <a:t>10/13/2026</a:t>
             </a:fld>
             <a:endParaRPr lang="en-US"/>
           </a:p>
@@ -1781,7 +1782,7 @@
             <a:fld id="{1D8BD707-D9CF-40AE-B4C6-C98DA3205C09}" type="datetimeFigureOut">
               <a:rPr lang="en-US" smtClean="0"/>
               <a:pPr/>
-              <a:t>10/12/2026</a:t>
+              <a:t>10/13/2026</a:t>
             </a:fld>
             <a:endParaRPr lang="en-US"/>
           </a:p>
@@ -1895,7 +1896,7 @@
             <a:fld id="{1D8BD707-D9CF-40AE-B4C6-C98DA3205C09}" type="datetimeFigureOut">
               <a:rPr lang="en-US" smtClean="0"/>
               <a:pPr/>
-              <a:t>10/12/2026</a:t>
+              <a:t>10/13/2026</a:t>
             </a:fld>
             <a:endParaRPr lang="en-US"/>
           </a:p>
@@ -1987,7 +1988,7 @@
             <a:fld id="{1D8BD707-D9CF-40AE-B4C6-C98DA3205C09}" type="datetimeFigureOut">
               <a:rPr lang="en-US" smtClean="0"/>
               <a:pPr/>
-              <a:t>10/12/2026</a:t>
+              <a:t>10/13/2026</a:t>
             </a:fld>
             <a:endParaRPr lang="en-US"/>
           </a:p>
@@ -2259,7 +2260,7 @@
             <a:fld id="{1D8BD707-D9CF-40AE-B4C6-C98DA3205C09}" type="datetimeFigureOut">
               <a:rPr lang="en-US" smtClean="0"/>
               <a:pPr/>
-              <a:t>10/12/2026</a:t>
+              <a:t>10/13/2026</a:t>
             </a:fld>
             <a:endParaRPr lang="en-US"/>
           </a:p>
@@ -2508,7 +2509,7 @@
             <a:fld id="{1D8BD707-D9CF-40AE-B4C6-C98DA3205C09}" type="datetimeFigureOut">
               <a:rPr lang="en-US" smtClean="0"/>
               <a:pPr/>
-              <a:t>10/12/2026</a:t>
+              <a:t>10/13/2026</a:t>
             </a:fld>
             <a:endParaRPr lang="en-US"/>
           </a:p>
@@ -2716,7 +2717,7 @@
             <a:fld id="{1D8BD707-D9CF-40AE-B4C6-C98DA3205C09}" type="datetimeFigureOut">
               <a:rPr lang="en-US" smtClean="0"/>
               <a:pPr/>
-              <a:t>10/12/2026</a:t>
+              <a:t>10/13/2026</a:t>
             </a:fld>
             <a:endParaRPr lang="en-US"/>
           </a:p>
@@ -3326,67 +3327,7 @@
       </p:sp>
       <p:sp>
         <p:nvSpPr>
-          <p:cNvPr id="6" name="TextBox 6"/>
-          <p:cNvSpPr txBox="1"/>
-          <p:nvPr/>
-        </p:nvSpPr>
-        <p:spPr>
-          <a:xfrm>
-            <a:off x="2008186" y="2359052"/>
-            <a:ext cx="9879014" cy="4129336"/>
-          </a:xfrm>
-          <a:prstGeom prst="rect">
-            <a:avLst/>
-          </a:prstGeom>
-        </p:spPr>
-        <p:txBody>
-          <a:bodyPr wrap="square" lIns="0" tIns="0" rIns="0" bIns="0" rtlCol="0" anchor="t">
-            <a:spAutoFit/>
-          </a:bodyPr>
-          <a:lstStyle/>
-          <a:p>
-            <a:pPr algn="l">
-              <a:lnSpc>
-                <a:spcPts val="16050"/>
-              </a:lnSpc>
-            </a:pPr>
-            <a:r>
-              <a:rPr lang="en-US" sz="15000" b="1" dirty="0">
-                <a:solidFill>
-                  <a:srgbClr val="000000"/>
-                </a:solidFill>
-                <a:latin typeface="Alegreya Sans SC Bold"/>
-                <a:ea typeface="Alegreya Sans SC Bold"/>
-                <a:cs typeface="Alegreya Sans SC Bold"/>
-                <a:sym typeface="Alegreya Sans SC Bold"/>
-              </a:rPr>
-              <a:t>RSA </a:t>
-            </a:r>
-          </a:p>
-          <a:p>
-            <a:pPr algn="l">
-              <a:lnSpc>
-                <a:spcPts val="16050"/>
-              </a:lnSpc>
-            </a:pPr>
-            <a:r>
-              <a:rPr lang="en-US" sz="15000" b="1" dirty="0">
-                <a:solidFill>
-                  <a:srgbClr val="000000"/>
-                </a:solidFill>
-                <a:latin typeface="Alegreya Sans SC Bold"/>
-                <a:ea typeface="Alegreya Sans SC Bold"/>
-                <a:cs typeface="Alegreya Sans SC Bold"/>
-                <a:sym typeface="Alegreya Sans SC Bold"/>
-              </a:rPr>
-              <a:t>Encryption</a:t>
-            </a:r>
-          </a:p>
-        </p:txBody>
-      </p:sp>
-      <p:sp>
-        <p:nvSpPr>
-          <p:cNvPr id="7" name="Freeform 7"/>
+          <p:cNvPr id="6" name="Freeform 6"/>
           <p:cNvSpPr/>
           <p:nvPr/>
         </p:nvSpPr>
@@ -3446,6 +3387,66 @@
       </p:sp>
       <p:sp>
         <p:nvSpPr>
+          <p:cNvPr id="7" name="TextBox 7"/>
+          <p:cNvSpPr txBox="1"/>
+          <p:nvPr/>
+        </p:nvSpPr>
+        <p:spPr>
+          <a:xfrm>
+            <a:off x="2008186" y="2359052"/>
+            <a:ext cx="9498014" cy="4129336"/>
+          </a:xfrm>
+          <a:prstGeom prst="rect">
+            <a:avLst/>
+          </a:prstGeom>
+        </p:spPr>
+        <p:txBody>
+          <a:bodyPr wrap="square" lIns="0" tIns="0" rIns="0" bIns="0" rtlCol="0" anchor="t">
+            <a:spAutoFit/>
+          </a:bodyPr>
+          <a:lstStyle/>
+          <a:p>
+            <a:pPr algn="l">
+              <a:lnSpc>
+                <a:spcPts val="16050"/>
+              </a:lnSpc>
+            </a:pPr>
+            <a:r>
+              <a:rPr lang="en-US" sz="15000" b="1" dirty="0">
+                <a:solidFill>
+                  <a:srgbClr val="000000"/>
+                </a:solidFill>
+                <a:latin typeface="Alegreya Sans SC Bold"/>
+                <a:ea typeface="Alegreya Sans SC Bold"/>
+                <a:cs typeface="Alegreya Sans SC Bold"/>
+                <a:sym typeface="Alegreya Sans SC Bold"/>
+              </a:rPr>
+              <a:t>RSA </a:t>
+            </a:r>
+          </a:p>
+          <a:p>
+            <a:pPr algn="l">
+              <a:lnSpc>
+                <a:spcPts val="16050"/>
+              </a:lnSpc>
+            </a:pPr>
+            <a:r>
+              <a:rPr lang="en-US" sz="15000" b="1" dirty="0">
+                <a:solidFill>
+                  <a:srgbClr val="000000"/>
+                </a:solidFill>
+                <a:latin typeface="Alegreya Sans SC Bold"/>
+                <a:ea typeface="Alegreya Sans SC Bold"/>
+                <a:cs typeface="Alegreya Sans SC Bold"/>
+                <a:sym typeface="Alegreya Sans SC Bold"/>
+              </a:rPr>
+              <a:t>Encryption</a:t>
+            </a:r>
+          </a:p>
+        </p:txBody>
+      </p:sp>
+      <p:sp>
+        <p:nvSpPr>
           <p:cNvPr id="8" name="TextBox 8"/>
           <p:cNvSpPr txBox="1"/>
           <p:nvPr/>
@@ -3474,7 +3475,7 @@
               </a:spcBef>
             </a:pPr>
             <a:r>
-              <a:rPr lang="en-US" sz="3241" b="1">
+              <a:rPr lang="en-US" sz="3241" b="1" dirty="0">
                 <a:solidFill>
                   <a:srgbClr val="000000"/>
                 </a:solidFill>
@@ -3496,7 +3497,7 @@
               </a:spcBef>
             </a:pPr>
             <a:r>
-              <a:rPr lang="en-US" sz="3241" b="1">
+              <a:rPr lang="en-US" sz="3241" b="1" dirty="0">
                 <a:solidFill>
                   <a:srgbClr val="000000"/>
                 </a:solidFill>
@@ -3518,7 +3519,7 @@
               </a:spcBef>
             </a:pPr>
             <a:r>
-              <a:rPr lang="en-US" sz="3241" b="1">
+              <a:rPr lang="en-US" sz="3241" b="1" dirty="0">
                 <a:solidFill>
                   <a:srgbClr val="000000"/>
                 </a:solidFill>
@@ -3540,7 +3541,7 @@
               </a:spcBef>
             </a:pPr>
             <a:r>
-              <a:rPr lang="en-US" sz="3241" b="1">
+              <a:rPr lang="en-US" sz="3241" b="1" dirty="0">
                 <a:solidFill>
                   <a:srgbClr val="000000"/>
                 </a:solidFill>
@@ -3562,7 +3563,7 @@
               </a:spcBef>
             </a:pPr>
             <a:r>
-              <a:rPr lang="en-US" sz="3241" b="1">
+              <a:rPr lang="en-US" sz="3241" b="1" dirty="0">
                 <a:solidFill>
                   <a:srgbClr val="000000"/>
                 </a:solidFill>
@@ -3656,7 +3657,7 @@
           <a:bodyPr/>
           <a:lstStyle/>
           <a:p>
-            <a:endParaRPr lang="en-CA"/>
+            <a:endParaRPr lang="en-CA" dirty="0"/>
           </a:p>
         </p:txBody>
       </p:sp>
@@ -3906,10 +3907,10 @@
         </p:nvGrpSpPr>
         <p:grpSpPr>
           <a:xfrm>
-            <a:off x="519025" y="3699244"/>
-            <a:ext cx="12129251" cy="6360147"/>
+            <a:off x="271890" y="3699244"/>
+            <a:ext cx="9382528" cy="6360147"/>
             <a:chOff x="0" y="0"/>
-            <a:chExt cx="3194535" cy="1675100"/>
+            <a:chExt cx="2471118" cy="1675100"/>
           </a:xfrm>
         </p:grpSpPr>
         <p:sp>
@@ -3921,7 +3922,7 @@
           <p:spPr>
             <a:xfrm>
               <a:off x="0" y="0"/>
-              <a:ext cx="3194535" cy="1675100"/>
+              <a:ext cx="2471119" cy="1675100"/>
             </a:xfrm>
             <a:custGeom>
               <a:avLst/>
@@ -3930,56 +3931,56 @@
               <a:cxnLst/>
               <a:rect l="l" t="t" r="r" b="b"/>
               <a:pathLst>
-                <a:path w="3194535" h="1675100">
+                <a:path w="2471119" h="1675100">
                   <a:moveTo>
-                    <a:pt x="32553" y="0"/>
+                    <a:pt x="42082" y="0"/>
                   </a:moveTo>
                   <a:lnTo>
-                    <a:pt x="3161983" y="0"/>
+                    <a:pt x="2429036" y="0"/>
                   </a:lnTo>
                   <a:cubicBezTo>
-                    <a:pt x="3170616" y="0"/>
-                    <a:pt x="3178896" y="3430"/>
-                    <a:pt x="3185001" y="9534"/>
+                    <a:pt x="2440197" y="0"/>
+                    <a:pt x="2450901" y="4434"/>
+                    <a:pt x="2458793" y="12326"/>
                   </a:cubicBezTo>
                   <a:cubicBezTo>
-                    <a:pt x="3191106" y="15639"/>
-                    <a:pt x="3194535" y="23919"/>
-                    <a:pt x="3194535" y="32553"/>
+                    <a:pt x="2466685" y="20218"/>
+                    <a:pt x="2471119" y="30921"/>
+                    <a:pt x="2471119" y="42082"/>
                   </a:cubicBezTo>
                   <a:lnTo>
-                    <a:pt x="3194535" y="1642548"/>
+                    <a:pt x="2471119" y="1633018"/>
                   </a:lnTo>
                   <a:cubicBezTo>
-                    <a:pt x="3194535" y="1660526"/>
-                    <a:pt x="3179961" y="1675100"/>
-                    <a:pt x="3161983" y="1675100"/>
+                    <a:pt x="2471119" y="1656260"/>
+                    <a:pt x="2452278" y="1675100"/>
+                    <a:pt x="2429036" y="1675100"/>
                   </a:cubicBezTo>
                   <a:lnTo>
-                    <a:pt x="32553" y="1675100"/>
+                    <a:pt x="42082" y="1675100"/>
                   </a:lnTo>
                   <a:cubicBezTo>
-                    <a:pt x="23919" y="1675100"/>
-                    <a:pt x="15639" y="1671671"/>
-                    <a:pt x="9534" y="1665566"/>
+                    <a:pt x="30921" y="1675100"/>
+                    <a:pt x="20218" y="1670667"/>
+                    <a:pt x="12326" y="1662775"/>
                   </a:cubicBezTo>
                   <a:cubicBezTo>
-                    <a:pt x="3430" y="1659461"/>
-                    <a:pt x="0" y="1651181"/>
-                    <a:pt x="0" y="1642548"/>
+                    <a:pt x="4434" y="1654883"/>
+                    <a:pt x="0" y="1644179"/>
+                    <a:pt x="0" y="1633018"/>
                   </a:cubicBezTo>
                   <a:lnTo>
-                    <a:pt x="0" y="32553"/>
+                    <a:pt x="0" y="42082"/>
                   </a:lnTo>
                   <a:cubicBezTo>
-                    <a:pt x="0" y="23919"/>
-                    <a:pt x="3430" y="15639"/>
-                    <a:pt x="9534" y="9534"/>
+                    <a:pt x="0" y="30921"/>
+                    <a:pt x="4434" y="20218"/>
+                    <a:pt x="12326" y="12326"/>
                   </a:cubicBezTo>
                   <a:cubicBezTo>
-                    <a:pt x="15639" y="3430"/>
-                    <a:pt x="23919" y="0"/>
-                    <a:pt x="32553" y="0"/>
+                    <a:pt x="20218" y="4434"/>
+                    <a:pt x="30921" y="0"/>
+                    <a:pt x="42082" y="0"/>
                   </a:cubicBezTo>
                   <a:close/>
                 </a:path>
@@ -4006,7 +4007,7 @@
           <p:spPr>
             <a:xfrm>
               <a:off x="0" y="-38100"/>
-              <a:ext cx="3194535" cy="1713200"/>
+              <a:ext cx="2471118" cy="1713200"/>
             </a:xfrm>
             <a:prstGeom prst="rect">
               <a:avLst/>
@@ -4031,21 +4032,74 @@
       </p:grpSp>
       <p:sp>
         <p:nvSpPr>
-          <p:cNvPr id="10" name="TextBox 10"/>
+          <p:cNvPr id="10" name="Freeform 10"/>
+          <p:cNvSpPr/>
+          <p:nvPr/>
+        </p:nvSpPr>
+        <p:spPr>
+          <a:xfrm>
+            <a:off x="10109379" y="3907431"/>
+            <a:ext cx="10780569" cy="6214114"/>
+          </a:xfrm>
+          <a:custGeom>
+            <a:avLst/>
+            <a:gdLst/>
+            <a:ahLst/>
+            <a:cxnLst/>
+            <a:rect l="l" t="t" r="r" b="b"/>
+            <a:pathLst>
+              <a:path w="8633582" h="4532631">
+                <a:moveTo>
+                  <a:pt x="0" y="0"/>
+                </a:moveTo>
+                <a:lnTo>
+                  <a:pt x="8633583" y="0"/>
+                </a:lnTo>
+                <a:lnTo>
+                  <a:pt x="8633583" y="4532630"/>
+                </a:lnTo>
+                <a:lnTo>
+                  <a:pt x="0" y="4532630"/>
+                </a:lnTo>
+                <a:lnTo>
+                  <a:pt x="0" y="0"/>
+                </a:lnTo>
+                <a:close/>
+              </a:path>
+            </a:pathLst>
+          </a:custGeom>
+          <a:blipFill>
+            <a:blip r:embed="rId5"/>
+            <a:stretch>
+              <a:fillRect/>
+            </a:stretch>
+          </a:blipFill>
+        </p:spPr>
+        <p:txBody>
+          <a:bodyPr/>
+          <a:lstStyle/>
+          <a:p>
+            <a:endParaRPr lang="en-CA"/>
+          </a:p>
+        </p:txBody>
+      </p:sp>
+      <p:sp>
+        <p:nvSpPr>
+          <p:cNvPr id="11" name="TextBox 11"/>
           <p:cNvSpPr txBox="1"/>
           <p:nvPr/>
         </p:nvSpPr>
         <p:spPr>
           <a:xfrm>
-            <a:off x="1698662" y="1509864"/>
-            <a:ext cx="14166815" cy="2370455"/>
+            <a:off x="2878299" y="700271"/>
+            <a:ext cx="14166815" cy="1102866"/>
           </a:xfrm>
           <a:prstGeom prst="rect">
             <a:avLst/>
           </a:prstGeom>
         </p:spPr>
         <p:txBody>
-          <a:bodyPr lIns="0" tIns="0" rIns="0" bIns="0" rtlCol="0" anchor="t">
+          <a:bodyPr wrap="square" lIns="0" tIns="0" rIns="0" bIns="0" rtlCol="0" anchor="t">
             <a:spAutoFit/>
           </a:bodyPr>
           <a:lstStyle/>
@@ -4056,7 +4110,7 @@
               </a:lnSpc>
             </a:pPr>
             <a:r>
-              <a:rPr lang="en-US" sz="8000" b="1">
+              <a:rPr lang="en-US" sz="8000" b="1" dirty="0">
                 <a:solidFill>
                   <a:srgbClr val="000000"/>
                 </a:solidFill>
@@ -4065,21 +4119,21 @@
                 <a:cs typeface="Alegreya Sans SC Bold"/>
                 <a:sym typeface="Alegreya Sans SC Bold"/>
               </a:rPr>
-              <a:t>RSA Encryption – How They’re Made and Used</a:t>
-            </a:r>
-          </a:p>
-        </p:txBody>
-      </p:sp>
-      <p:sp>
-        <p:nvSpPr>
-          <p:cNvPr id="11" name="TextBox 11"/>
+              <a:t>RSA Encryption</a:t>
+            </a:r>
+          </a:p>
+        </p:txBody>
+      </p:sp>
+      <p:sp>
+        <p:nvSpPr>
+          <p:cNvPr id="12" name="TextBox 12"/>
           <p:cNvSpPr txBox="1"/>
           <p:nvPr/>
         </p:nvSpPr>
         <p:spPr>
           <a:xfrm>
-            <a:off x="939754" y="3966416"/>
-            <a:ext cx="11223251" cy="6039992"/>
+            <a:off x="578153" y="4072886"/>
+            <a:ext cx="9076264" cy="5573267"/>
           </a:xfrm>
           <a:prstGeom prst="rect">
             <a:avLst/>
@@ -4107,6 +4161,25 @@
                 <a:sym typeface="Aileron"/>
               </a:rPr>
               <a:t>RSA Encryption is an asymmetric encryption algorithm that generates a key pair to encrypt and decrypt data.</a:t>
+            </a:r>
+          </a:p>
+          <a:p>
+            <a:pPr algn="l">
+              <a:lnSpc>
+                <a:spcPts val="3696"/>
+              </a:lnSpc>
+            </a:pPr>
+            <a:r>
+              <a:rPr lang="en-US" sz="2400">
+                <a:solidFill>
+                  <a:srgbClr val="000000"/>
+                </a:solidFill>
+                <a:latin typeface="Aileron"/>
+                <a:ea typeface="Aileron"/>
+                <a:cs typeface="Aileron"/>
+                <a:sym typeface="Aileron"/>
+              </a:rPr>
+              <a:t>Most common form of communication is two-way communication.</a:t>
             </a:r>
           </a:p>
           <a:p>
@@ -4141,41 +4214,6 @@
                 <a:cs typeface="Aileron"/>
                 <a:sym typeface="Aileron"/>
               </a:rPr>
-              <a:t>Most common form of communication is two-way communication.</a:t>
-            </a:r>
-          </a:p>
-          <a:p>
-            <a:pPr algn="l">
-              <a:lnSpc>
-                <a:spcPts val="3696"/>
-              </a:lnSpc>
-            </a:pPr>
-            <a:endParaRPr lang="en-US" sz="2400">
-              <a:solidFill>
-                <a:srgbClr val="000000"/>
-              </a:solidFill>
-              <a:latin typeface="Aileron"/>
-              <a:ea typeface="Aileron"/>
-              <a:cs typeface="Aileron"/>
-              <a:sym typeface="Aileron"/>
-            </a:endParaRPr>
-          </a:p>
-          <a:p>
-            <a:pPr algn="l">
-              <a:lnSpc>
-                <a:spcPts val="3696"/>
-              </a:lnSpc>
-            </a:pPr>
-            <a:r>
-              <a:rPr lang="en-US" sz="2400">
-                <a:solidFill>
-                  <a:srgbClr val="000000"/>
-                </a:solidFill>
-                <a:latin typeface="Aileron"/>
-                <a:ea typeface="Aileron"/>
-                <a:cs typeface="Aileron"/>
-                <a:sym typeface="Aileron"/>
-              </a:rPr>
               <a:t>We achieve this by:</a:t>
             </a:r>
           </a:p>
@@ -4261,22 +4299,6 @@
                 <a:spcPts val="3696"/>
               </a:lnSpc>
             </a:pPr>
-            <a:endParaRPr lang="en-US" sz="2400">
-              <a:solidFill>
-                <a:srgbClr val="000000"/>
-              </a:solidFill>
-              <a:latin typeface="Aileron"/>
-              <a:ea typeface="Aileron"/>
-              <a:cs typeface="Aileron"/>
-              <a:sym typeface="Aileron"/>
-            </a:endParaRPr>
-          </a:p>
-          <a:p>
-            <a:pPr algn="l">
-              <a:lnSpc>
-                <a:spcPts val="3696"/>
-              </a:lnSpc>
-            </a:pPr>
             <a:r>
               <a:rPr lang="en-US" sz="2400">
                 <a:solidFill>
@@ -4290,21 +4312,49 @@
               <a:t>This allows two-way secure information by allowing both to send and receive data.</a:t>
             </a:r>
           </a:p>
-          <a:p>
-            <a:pPr algn="l">
+        </p:txBody>
+      </p:sp>
+      <p:sp>
+        <p:nvSpPr>
+          <p:cNvPr id="13" name="TextBox 13"/>
+          <p:cNvSpPr txBox="1"/>
+          <p:nvPr/>
+        </p:nvSpPr>
+        <p:spPr>
+          <a:xfrm>
+            <a:off x="4856821" y="1362849"/>
+            <a:ext cx="10209770" cy="961802"/>
+          </a:xfrm>
+          <a:prstGeom prst="rect">
+            <a:avLst/>
+          </a:prstGeom>
+        </p:spPr>
+        <p:txBody>
+          <a:bodyPr wrap="square" lIns="0" tIns="0" rIns="0" bIns="0" rtlCol="0" anchor="t">
+            <a:spAutoFit/>
+          </a:bodyPr>
+          <a:lstStyle/>
+          <a:p>
+            <a:pPr algn="ctr">
               <a:lnSpc>
-                <a:spcPts val="3696"/>
+                <a:spcPts val="8400"/>
               </a:lnSpc>
+              <a:spcBef>
+                <a:spcPct val="0"/>
+              </a:spcBef>
             </a:pPr>
-            <a:endParaRPr lang="en-US" sz="2400">
-              <a:solidFill>
-                <a:srgbClr val="000000"/>
-              </a:solidFill>
-              <a:latin typeface="Aileron"/>
-              <a:ea typeface="Aileron"/>
-              <a:cs typeface="Aileron"/>
-              <a:sym typeface="Aileron"/>
-            </a:endParaRPr>
+            <a:r>
+              <a:rPr lang="en-US" sz="6000" dirty="0">
+                <a:solidFill>
+                  <a:srgbClr val="545454"/>
+                </a:solidFill>
+                <a:latin typeface="Alegreya Sans SC"/>
+                <a:ea typeface="Alegreya Sans SC"/>
+                <a:cs typeface="Alegreya Sans SC"/>
+                <a:sym typeface="Alegreya Sans SC"/>
+              </a:rPr>
+              <a:t>How They’re Used and Made</a:t>
+            </a:r>
           </a:p>
         </p:txBody>
       </p:sp>
@@ -4400,10 +4450,10 @@
         </p:nvGrpSpPr>
         <p:grpSpPr>
           <a:xfrm>
-            <a:off x="2600498" y="6309922"/>
-            <a:ext cx="6543502" cy="3872037"/>
+            <a:off x="345390" y="6302744"/>
+            <a:ext cx="6543502" cy="3594010"/>
             <a:chOff x="0" y="0"/>
-            <a:chExt cx="1723392" cy="1019796"/>
+            <a:chExt cx="1723392" cy="946571"/>
           </a:xfrm>
         </p:grpSpPr>
         <p:sp>
@@ -4415,7 +4465,7 @@
           <p:spPr>
             <a:xfrm>
               <a:off x="0" y="0"/>
-              <a:ext cx="1723392" cy="1019796"/>
+              <a:ext cx="1723392" cy="946571"/>
             </a:xfrm>
             <a:custGeom>
               <a:avLst/>
@@ -4424,7 +4474,7 @@
               <a:cxnLst/>
               <a:rect l="l" t="t" r="r" b="b"/>
               <a:pathLst>
-                <a:path w="1723392" h="1019796">
+                <a:path w="1723392" h="946571">
                   <a:moveTo>
                     <a:pt x="60340" y="0"/>
                   </a:moveTo>
@@ -4442,25 +4492,25 @@
                     <a:pt x="1723392" y="60340"/>
                   </a:cubicBezTo>
                   <a:lnTo>
-                    <a:pt x="1723392" y="959455"/>
+                    <a:pt x="1723392" y="886230"/>
                   </a:lnTo>
                   <a:cubicBezTo>
-                    <a:pt x="1723392" y="992781"/>
-                    <a:pt x="1696376" y="1019796"/>
-                    <a:pt x="1663051" y="1019796"/>
+                    <a:pt x="1723392" y="919555"/>
+                    <a:pt x="1696376" y="946571"/>
+                    <a:pt x="1663051" y="946571"/>
                   </a:cubicBezTo>
                   <a:lnTo>
-                    <a:pt x="60340" y="1019796"/>
+                    <a:pt x="60340" y="946571"/>
                   </a:lnTo>
                   <a:cubicBezTo>
-                    <a:pt x="44337" y="1019796"/>
-                    <a:pt x="28989" y="1013439"/>
-                    <a:pt x="17673" y="1002123"/>
+                    <a:pt x="44337" y="946571"/>
+                    <a:pt x="28989" y="940213"/>
+                    <a:pt x="17673" y="928897"/>
                   </a:cubicBezTo>
                   <a:cubicBezTo>
-                    <a:pt x="6357" y="990807"/>
-                    <a:pt x="0" y="975459"/>
-                    <a:pt x="0" y="959455"/>
+                    <a:pt x="6357" y="917581"/>
+                    <a:pt x="0" y="902233"/>
+                    <a:pt x="0" y="886230"/>
                   </a:cubicBezTo>
                   <a:lnTo>
                     <a:pt x="0" y="60340"/>
@@ -4500,7 +4550,7 @@
           <p:spPr>
             <a:xfrm>
               <a:off x="0" y="-38100"/>
-              <a:ext cx="1723392" cy="1057896"/>
+              <a:ext cx="1723392" cy="984671"/>
             </a:xfrm>
             <a:prstGeom prst="rect">
               <a:avLst/>
@@ -4649,10 +4699,10 @@
         </p:nvGrpSpPr>
         <p:grpSpPr>
           <a:xfrm>
-            <a:off x="9385461" y="7389248"/>
-            <a:ext cx="5783478" cy="1801022"/>
+            <a:off x="7086203" y="6285341"/>
+            <a:ext cx="5629018" cy="2785546"/>
             <a:chOff x="0" y="0"/>
-            <a:chExt cx="1523221" cy="474343"/>
+            <a:chExt cx="1482540" cy="733642"/>
           </a:xfrm>
         </p:grpSpPr>
         <p:sp>
@@ -4664,7 +4714,7 @@
           <p:spPr>
             <a:xfrm>
               <a:off x="0" y="0"/>
-              <a:ext cx="1523220" cy="474343"/>
+              <a:ext cx="1482540" cy="733642"/>
             </a:xfrm>
             <a:custGeom>
               <a:avLst/>
@@ -4673,46 +4723,46 @@
               <a:cxnLst/>
               <a:rect l="l" t="t" r="r" b="b"/>
               <a:pathLst>
-                <a:path w="1523220" h="474343">
+                <a:path w="1482540" h="733642">
                   <a:moveTo>
-                    <a:pt x="68270" y="0"/>
+                    <a:pt x="70143" y="0"/>
                   </a:moveTo>
                   <a:lnTo>
-                    <a:pt x="1454951" y="0"/>
+                    <a:pt x="1412397" y="0"/>
                   </a:lnTo>
                   <a:cubicBezTo>
-                    <a:pt x="1492655" y="0"/>
-                    <a:pt x="1523220" y="30566"/>
-                    <a:pt x="1523220" y="68270"/>
+                    <a:pt x="1431000" y="0"/>
+                    <a:pt x="1448841" y="7390"/>
+                    <a:pt x="1461995" y="20544"/>
+                  </a:cubicBezTo>
+                  <a:cubicBezTo>
+                    <a:pt x="1475150" y="33699"/>
+                    <a:pt x="1482540" y="51540"/>
+                    <a:pt x="1482540" y="70143"/>
                   </a:cubicBezTo>
                   <a:lnTo>
-                    <a:pt x="1523220" y="406073"/>
+                    <a:pt x="1482540" y="663498"/>
                   </a:lnTo>
                   <a:cubicBezTo>
-                    <a:pt x="1523220" y="424180"/>
-                    <a:pt x="1516028" y="441544"/>
-                    <a:pt x="1503225" y="454347"/>
-                  </a:cubicBezTo>
-                  <a:cubicBezTo>
-                    <a:pt x="1490422" y="467151"/>
-                    <a:pt x="1473057" y="474343"/>
-                    <a:pt x="1454951" y="474343"/>
+                    <a:pt x="1482540" y="702237"/>
+                    <a:pt x="1451136" y="733642"/>
+                    <a:pt x="1412397" y="733642"/>
                   </a:cubicBezTo>
                   <a:lnTo>
-                    <a:pt x="68270" y="474343"/>
+                    <a:pt x="70143" y="733642"/>
                   </a:lnTo>
                   <a:cubicBezTo>
-                    <a:pt x="30566" y="474343"/>
-                    <a:pt x="0" y="443778"/>
-                    <a:pt x="0" y="406073"/>
+                    <a:pt x="31404" y="733642"/>
+                    <a:pt x="0" y="702237"/>
+                    <a:pt x="0" y="663498"/>
                   </a:cubicBezTo>
                   <a:lnTo>
-                    <a:pt x="0" y="68270"/>
+                    <a:pt x="0" y="70143"/>
                   </a:lnTo>
                   <a:cubicBezTo>
-                    <a:pt x="0" y="30566"/>
-                    <a:pt x="30566" y="0"/>
-                    <a:pt x="68270" y="0"/>
+                    <a:pt x="0" y="31404"/>
+                    <a:pt x="31404" y="0"/>
+                    <a:pt x="70143" y="0"/>
                   </a:cubicBezTo>
                   <a:close/>
                 </a:path>
@@ -4739,7 +4789,7 @@
           <p:spPr>
             <a:xfrm>
               <a:off x="0" y="-38100"/>
-              <a:ext cx="1523221" cy="512443"/>
+              <a:ext cx="1482540" cy="771742"/>
             </a:xfrm>
             <a:prstGeom prst="rect">
               <a:avLst/>
@@ -4830,7 +4880,7 @@
         </p:nvGrpSpPr>
         <p:grpSpPr>
           <a:xfrm>
-            <a:off x="2600498" y="3797627"/>
+            <a:off x="345390" y="3790450"/>
             <a:ext cx="12886102" cy="2281105"/>
             <a:chOff x="0" y="0"/>
             <a:chExt cx="3393871" cy="600785"/>
@@ -4955,14 +5005,67 @@
       </p:grpSp>
       <p:sp>
         <p:nvSpPr>
-          <p:cNvPr id="15" name="TextBox 15"/>
+          <p:cNvPr id="15" name="Freeform 15"/>
+          <p:cNvSpPr/>
+          <p:nvPr/>
+        </p:nvSpPr>
+        <p:spPr>
+          <a:xfrm>
+            <a:off x="13350268" y="4151832"/>
+            <a:ext cx="7585267" cy="6012560"/>
+          </a:xfrm>
+          <a:custGeom>
+            <a:avLst/>
+            <a:gdLst/>
+            <a:ahLst/>
+            <a:cxnLst/>
+            <a:rect l="l" t="t" r="r" b="b"/>
+            <a:pathLst>
+              <a:path w="5375467" h="4031600">
+                <a:moveTo>
+                  <a:pt x="0" y="0"/>
+                </a:moveTo>
+                <a:lnTo>
+                  <a:pt x="5375467" y="0"/>
+                </a:lnTo>
+                <a:lnTo>
+                  <a:pt x="5375467" y="4031600"/>
+                </a:lnTo>
+                <a:lnTo>
+                  <a:pt x="0" y="4031600"/>
+                </a:lnTo>
+                <a:lnTo>
+                  <a:pt x="0" y="0"/>
+                </a:lnTo>
+                <a:close/>
+              </a:path>
+            </a:pathLst>
+          </a:custGeom>
+          <a:blipFill>
+            <a:blip r:embed="rId5"/>
+            <a:stretch>
+              <a:fillRect/>
+            </a:stretch>
+          </a:blipFill>
+        </p:spPr>
+        <p:txBody>
+          <a:bodyPr/>
+          <a:lstStyle/>
+          <a:p>
+            <a:endParaRPr lang="en-CA"/>
+          </a:p>
+        </p:txBody>
+      </p:sp>
+      <p:sp>
+        <p:nvSpPr>
+          <p:cNvPr id="16" name="TextBox 16"/>
           <p:cNvSpPr txBox="1"/>
           <p:nvPr/>
         </p:nvSpPr>
         <p:spPr>
           <a:xfrm>
-            <a:off x="3202543" y="1537610"/>
-            <a:ext cx="11882914" cy="2370455"/>
+            <a:off x="3781860" y="724241"/>
+            <a:ext cx="11882914" cy="1284605"/>
           </a:xfrm>
           <a:prstGeom prst="rect">
             <a:avLst/>
@@ -4989,20 +5092,20 @@
                 <a:cs typeface="Alegreya Sans SC Bold"/>
                 <a:sym typeface="Alegreya Sans SC Bold"/>
               </a:rPr>
-              <a:t>RSA Key Generation – Private and Public Keys</a:t>
-            </a:r>
-          </a:p>
-        </p:txBody>
-      </p:sp>
-      <p:sp>
-        <p:nvSpPr>
-          <p:cNvPr id="16" name="TextBox 16"/>
+              <a:t>RSA Key Generation</a:t>
+            </a:r>
+          </a:p>
+        </p:txBody>
+      </p:sp>
+      <p:sp>
+        <p:nvSpPr>
+          <p:cNvPr id="17" name="TextBox 17"/>
           <p:cNvSpPr txBox="1"/>
           <p:nvPr/>
         </p:nvSpPr>
         <p:spPr>
           <a:xfrm>
-            <a:off x="2600498" y="3986325"/>
+            <a:off x="345390" y="3979148"/>
             <a:ext cx="12886102" cy="2306193"/>
           </a:xfrm>
           <a:prstGeom prst="rect">
@@ -5110,13 +5213,13 @@
       </p:sp>
       <p:sp>
         <p:nvSpPr>
-          <p:cNvPr id="17" name="TextBox 17"/>
+          <p:cNvPr id="18" name="TextBox 18"/>
           <p:cNvSpPr txBox="1"/>
           <p:nvPr/>
         </p:nvSpPr>
         <p:spPr>
           <a:xfrm>
-            <a:off x="2750473" y="7356587"/>
+            <a:off x="623191" y="7175515"/>
             <a:ext cx="5762267" cy="2491740"/>
           </a:xfrm>
           <a:prstGeom prst="rect">
@@ -5129,13 +5232,15 @@
           </a:bodyPr>
           <a:lstStyle/>
           <a:p>
-            <a:pPr algn="ctr">
+            <a:pPr marL="518160" lvl="1" indent="-259080" algn="ctr">
               <a:lnSpc>
                 <a:spcPts val="3359"/>
               </a:lnSpc>
               <a:spcBef>
                 <a:spcPct val="0"/>
               </a:spcBef>
+              <a:buFont typeface="Arial"/>
+              <a:buChar char="•"/>
             </a:pPr>
             <a:r>
               <a:rPr lang="en-US" sz="2400">
@@ -5147,17 +5252,19 @@
                 <a:cs typeface="Open Sans"/>
                 <a:sym typeface="Open Sans"/>
               </a:rPr>
-              <a:t>•Can be generated using “Euler’s Totient Function”</a:t>
-            </a:r>
-          </a:p>
-          <a:p>
-            <a:pPr algn="ctr">
+              <a:t>Can be generated using “Euler’s Totient Function”</a:t>
+            </a:r>
+          </a:p>
+          <a:p>
+            <a:pPr marL="518160" lvl="1" indent="-259080" algn="ctr">
               <a:lnSpc>
                 <a:spcPts val="3359"/>
               </a:lnSpc>
               <a:spcBef>
                 <a:spcPct val="0"/>
               </a:spcBef>
+              <a:buFont typeface="Arial"/>
+              <a:buChar char="•"/>
             </a:pPr>
             <a:r>
               <a:rPr lang="en-US" sz="2400">
@@ -5169,17 +5276,19 @@
                 <a:cs typeface="Open Sans"/>
                 <a:sym typeface="Open Sans"/>
               </a:rPr>
-              <a:t>•Public exponent e is selected</a:t>
-            </a:r>
-          </a:p>
-          <a:p>
-            <a:pPr algn="ctr">
+              <a:t>Public exponent e is selected</a:t>
+            </a:r>
+          </a:p>
+          <a:p>
+            <a:pPr marL="518160" lvl="1" indent="-259080" algn="ctr">
               <a:lnSpc>
                 <a:spcPts val="3359"/>
               </a:lnSpc>
               <a:spcBef>
                 <a:spcPct val="0"/>
               </a:spcBef>
+              <a:buFont typeface="Arial"/>
+              <a:buChar char="•"/>
             </a:pPr>
             <a:r>
               <a:rPr lang="en-US" sz="2400">
@@ -5191,17 +5300,19 @@
                 <a:cs typeface="Open Sans"/>
                 <a:sym typeface="Open Sans"/>
               </a:rPr>
-              <a:t>•Exponent generally is 65537</a:t>
-            </a:r>
-          </a:p>
-          <a:p>
-            <a:pPr algn="ctr">
+              <a:t>Exponent generally is 65537</a:t>
+            </a:r>
+          </a:p>
+          <a:p>
+            <a:pPr marL="518160" lvl="1" indent="-259080" algn="ctr">
               <a:lnSpc>
                 <a:spcPts val="3359"/>
               </a:lnSpc>
               <a:spcBef>
                 <a:spcPct val="0"/>
               </a:spcBef>
+              <a:buFont typeface="Arial"/>
+              <a:buChar char="•"/>
             </a:pPr>
             <a:r>
               <a:rPr lang="en-US" sz="2400">
@@ -5213,20 +5324,20 @@
                 <a:cs typeface="Open Sans"/>
                 <a:sym typeface="Open Sans"/>
               </a:rPr>
-              <a:t>•Now you can make public key using e and n (e, n)</a:t>
-            </a:r>
-          </a:p>
-        </p:txBody>
-      </p:sp>
-      <p:sp>
-        <p:nvSpPr>
-          <p:cNvPr id="18" name="TextBox 18"/>
+              <a:t>Now you can make public key using e and n (e, n)</a:t>
+            </a:r>
+          </a:p>
+        </p:txBody>
+      </p:sp>
+      <p:sp>
+        <p:nvSpPr>
+          <p:cNvPr id="19" name="TextBox 19"/>
           <p:cNvSpPr txBox="1"/>
           <p:nvPr/>
         </p:nvSpPr>
         <p:spPr>
           <a:xfrm>
-            <a:off x="4029896" y="6580712"/>
+            <a:off x="2015431" y="6573535"/>
             <a:ext cx="3203420" cy="487680"/>
           </a:xfrm>
           <a:prstGeom prst="rect">
@@ -5261,14 +5372,14 @@
       </p:sp>
       <p:sp>
         <p:nvSpPr>
-          <p:cNvPr id="19" name="TextBox 19"/>
+          <p:cNvPr id="20" name="TextBox 20"/>
           <p:cNvSpPr txBox="1"/>
           <p:nvPr/>
         </p:nvSpPr>
         <p:spPr>
           <a:xfrm>
-            <a:off x="10160641" y="8127022"/>
-            <a:ext cx="4233118" cy="815340"/>
+            <a:off x="7228099" y="7158112"/>
+            <a:ext cx="5221659" cy="1653540"/>
           </a:xfrm>
           <a:prstGeom prst="rect">
             <a:avLst/>
@@ -5280,13 +5391,15 @@
           </a:bodyPr>
           <a:lstStyle/>
           <a:p>
-            <a:pPr algn="ctr">
+            <a:pPr marL="518160" lvl="1" indent="-259080" algn="ctr">
               <a:lnSpc>
                 <a:spcPts val="3359"/>
               </a:lnSpc>
               <a:spcBef>
                 <a:spcPct val="0"/>
               </a:spcBef>
+              <a:buFont typeface="Arial"/>
+              <a:buChar char="•"/>
             </a:pPr>
             <a:r>
               <a:rPr lang="en-US" sz="2400">
@@ -5298,17 +5411,19 @@
                 <a:cs typeface="Open Sans"/>
                 <a:sym typeface="Open Sans"/>
               </a:rPr>
-              <a:t>•Private exponent “d”</a:t>
-            </a:r>
-          </a:p>
-          <a:p>
-            <a:pPr algn="ctr">
+              <a:t>Private exponent “d”</a:t>
+            </a:r>
+          </a:p>
+          <a:p>
+            <a:pPr marL="518160" lvl="1" indent="-259080" algn="ctr">
               <a:lnSpc>
                 <a:spcPts val="3359"/>
               </a:lnSpc>
               <a:spcBef>
                 <a:spcPct val="0"/>
               </a:spcBef>
+              <a:buFont typeface="Arial"/>
+              <a:buChar char="•"/>
             </a:pPr>
             <a:r>
               <a:rPr lang="en-US" sz="2400">
@@ -5320,20 +5435,44 @@
                 <a:cs typeface="Open Sans"/>
                 <a:sym typeface="Open Sans"/>
               </a:rPr>
-              <a:t>•Private key is d and n (d, n)</a:t>
-            </a:r>
-          </a:p>
-        </p:txBody>
-      </p:sp>
-      <p:sp>
-        <p:nvSpPr>
-          <p:cNvPr id="20" name="TextBox 20"/>
+              <a:t>Calculate d as the modular inverse of e</a:t>
+            </a:r>
+          </a:p>
+          <a:p>
+            <a:pPr marL="518160" lvl="1" indent="-259080" algn="ctr">
+              <a:lnSpc>
+                <a:spcPts val="3359"/>
+              </a:lnSpc>
+              <a:spcBef>
+                <a:spcPct val="0"/>
+              </a:spcBef>
+              <a:buFont typeface="Arial"/>
+              <a:buChar char="•"/>
+            </a:pPr>
+            <a:r>
+              <a:rPr lang="en-US" sz="2400">
+                <a:solidFill>
+                  <a:srgbClr val="000000"/>
+                </a:solidFill>
+                <a:latin typeface="Open Sans"/>
+                <a:ea typeface="Open Sans"/>
+                <a:cs typeface="Open Sans"/>
+                <a:sym typeface="Open Sans"/>
+              </a:rPr>
+              <a:t>Private key is d and n (d, n)</a:t>
+            </a:r>
+          </a:p>
+        </p:txBody>
+      </p:sp>
+      <p:sp>
+        <p:nvSpPr>
+          <p:cNvPr id="21" name="TextBox 21"/>
           <p:cNvSpPr txBox="1"/>
           <p:nvPr/>
         </p:nvSpPr>
         <p:spPr>
           <a:xfrm>
-            <a:off x="10675490" y="7525042"/>
+            <a:off x="8299003" y="6556132"/>
             <a:ext cx="3203420" cy="487680"/>
           </a:xfrm>
           <a:prstGeom prst="rect">
@@ -5362,6 +5501,50 @@
                 <a:sym typeface="Alegreya Sans SC Medium"/>
               </a:rPr>
               <a:t>Private Key</a:t>
+            </a:r>
+          </a:p>
+        </p:txBody>
+      </p:sp>
+      <p:sp>
+        <p:nvSpPr>
+          <p:cNvPr id="22" name="TextBox 22"/>
+          <p:cNvSpPr txBox="1"/>
+          <p:nvPr/>
+        </p:nvSpPr>
+        <p:spPr>
+          <a:xfrm>
+            <a:off x="4618432" y="1503691"/>
+            <a:ext cx="10209770" cy="1162050"/>
+          </a:xfrm>
+          <a:prstGeom prst="rect">
+            <a:avLst/>
+          </a:prstGeom>
+        </p:spPr>
+        <p:txBody>
+          <a:bodyPr lIns="0" tIns="0" rIns="0" bIns="0" rtlCol="0" anchor="t">
+            <a:spAutoFit/>
+          </a:bodyPr>
+          <a:lstStyle/>
+          <a:p>
+            <a:pPr algn="ctr">
+              <a:lnSpc>
+                <a:spcPts val="8400"/>
+              </a:lnSpc>
+              <a:spcBef>
+                <a:spcPct val="0"/>
+              </a:spcBef>
+            </a:pPr>
+            <a:r>
+              <a:rPr lang="en-US" sz="6000" dirty="0">
+                <a:solidFill>
+                  <a:srgbClr val="545454"/>
+                </a:solidFill>
+                <a:latin typeface="Alegreya Sans SC"/>
+                <a:ea typeface="Alegreya Sans SC"/>
+                <a:cs typeface="Alegreya Sans SC"/>
+                <a:sym typeface="Alegreya Sans SC"/>
+              </a:rPr>
+              <a:t>Public and Private Keys</a:t>
             </a:r>
           </a:p>
         </p:txBody>
@@ -5696,10 +5879,10 @@
         </p:nvGrpSpPr>
         <p:grpSpPr>
           <a:xfrm>
-            <a:off x="915241" y="4675927"/>
-            <a:ext cx="10649843" cy="4582373"/>
+            <a:off x="1600201" y="3335932"/>
+            <a:ext cx="7180552" cy="5846168"/>
             <a:chOff x="0" y="0"/>
-            <a:chExt cx="2804897" cy="1206880"/>
+            <a:chExt cx="2238372" cy="1281401"/>
           </a:xfrm>
         </p:grpSpPr>
         <p:sp>
@@ -5711,7 +5894,7 @@
           <p:spPr>
             <a:xfrm>
               <a:off x="0" y="0"/>
-              <a:ext cx="2804897" cy="1206880"/>
+              <a:ext cx="2238372" cy="1281401"/>
             </a:xfrm>
             <a:custGeom>
               <a:avLst/>
@@ -5720,41 +5903,46 @@
               <a:cxnLst/>
               <a:rect l="l" t="t" r="r" b="b"/>
               <a:pathLst>
-                <a:path w="2804897" h="1206880">
+                <a:path w="2238372" h="1281401">
                   <a:moveTo>
-                    <a:pt x="37075" y="0"/>
+                    <a:pt x="44792" y="0"/>
                   </a:moveTo>
                   <a:lnTo>
-                    <a:pt x="2767822" y="0"/>
+                    <a:pt x="2193580" y="0"/>
                   </a:lnTo>
                   <a:cubicBezTo>
-                    <a:pt x="2788298" y="0"/>
-                    <a:pt x="2804897" y="16599"/>
-                    <a:pt x="2804897" y="37075"/>
+                    <a:pt x="2218318" y="0"/>
+                    <a:pt x="2238372" y="20054"/>
+                    <a:pt x="2238372" y="44792"/>
                   </a:cubicBezTo>
                   <a:lnTo>
-                    <a:pt x="2804897" y="1169806"/>
+                    <a:pt x="2238372" y="1236609"/>
                   </a:lnTo>
                   <a:cubicBezTo>
-                    <a:pt x="2804897" y="1190281"/>
-                    <a:pt x="2788298" y="1206880"/>
-                    <a:pt x="2767822" y="1206880"/>
+                    <a:pt x="2238372" y="1248489"/>
+                    <a:pt x="2233652" y="1259882"/>
+                    <a:pt x="2225252" y="1268282"/>
+                  </a:cubicBezTo>
+                  <a:cubicBezTo>
+                    <a:pt x="2216852" y="1276682"/>
+                    <a:pt x="2205459" y="1281401"/>
+                    <a:pt x="2193580" y="1281401"/>
                   </a:cubicBezTo>
                   <a:lnTo>
-                    <a:pt x="37075" y="1206880"/>
+                    <a:pt x="44792" y="1281401"/>
                   </a:lnTo>
                   <a:cubicBezTo>
-                    <a:pt x="16599" y="1206880"/>
-                    <a:pt x="0" y="1190281"/>
-                    <a:pt x="0" y="1169806"/>
+                    <a:pt x="20054" y="1281401"/>
+                    <a:pt x="0" y="1261347"/>
+                    <a:pt x="0" y="1236609"/>
                   </a:cubicBezTo>
                   <a:lnTo>
-                    <a:pt x="0" y="37075"/>
+                    <a:pt x="0" y="44792"/>
                   </a:lnTo>
                   <a:cubicBezTo>
-                    <a:pt x="0" y="16599"/>
-                    <a:pt x="16599" y="0"/>
-                    <a:pt x="37075" y="0"/>
+                    <a:pt x="0" y="20054"/>
+                    <a:pt x="20054" y="0"/>
+                    <a:pt x="44792" y="0"/>
                   </a:cubicBezTo>
                   <a:close/>
                 </a:path>
@@ -5781,7 +5969,7 @@
           <p:spPr>
             <a:xfrm>
               <a:off x="0" y="-38100"/>
-              <a:ext cx="2804897" cy="1244980"/>
+              <a:ext cx="2238372" cy="1319501"/>
             </a:xfrm>
             <a:prstGeom prst="rect">
               <a:avLst/>
@@ -5806,14 +5994,67 @@
       </p:grpSp>
       <p:sp>
         <p:nvSpPr>
-          <p:cNvPr id="10" name="TextBox 10"/>
+          <p:cNvPr id="10" name="Freeform 10"/>
+          <p:cNvSpPr/>
+          <p:nvPr/>
+        </p:nvSpPr>
+        <p:spPr>
+          <a:xfrm>
+            <a:off x="9906000" y="2889064"/>
+            <a:ext cx="10637996" cy="6235712"/>
+          </a:xfrm>
+          <a:custGeom>
+            <a:avLst/>
+            <a:gdLst/>
+            <a:ahLst/>
+            <a:cxnLst/>
+            <a:rect l="l" t="t" r="r" b="b"/>
+            <a:pathLst>
+              <a:path w="7668544" h="3834272">
+                <a:moveTo>
+                  <a:pt x="0" y="0"/>
+                </a:moveTo>
+                <a:lnTo>
+                  <a:pt x="7668544" y="0"/>
+                </a:lnTo>
+                <a:lnTo>
+                  <a:pt x="7668544" y="3834272"/>
+                </a:lnTo>
+                <a:lnTo>
+                  <a:pt x="0" y="3834272"/>
+                </a:lnTo>
+                <a:lnTo>
+                  <a:pt x="0" y="0"/>
+                </a:lnTo>
+                <a:close/>
+              </a:path>
+            </a:pathLst>
+          </a:custGeom>
+          <a:blipFill>
+            <a:blip r:embed="rId5"/>
+            <a:stretch>
+              <a:fillRect/>
+            </a:stretch>
+          </a:blipFill>
+        </p:spPr>
+        <p:txBody>
+          <a:bodyPr/>
+          <a:lstStyle/>
+          <a:p>
+            <a:endParaRPr lang="en-CA"/>
+          </a:p>
+        </p:txBody>
+      </p:sp>
+      <p:sp>
+        <p:nvSpPr>
+          <p:cNvPr id="12" name="TextBox 12"/>
           <p:cNvSpPr txBox="1"/>
           <p:nvPr/>
         </p:nvSpPr>
         <p:spPr>
           <a:xfrm>
-            <a:off x="1698662" y="1509864"/>
-            <a:ext cx="13564423" cy="2370455"/>
+            <a:off x="2913310" y="715356"/>
+            <a:ext cx="13564423" cy="1284605"/>
           </a:xfrm>
           <a:prstGeom prst="rect">
             <a:avLst/>
@@ -5831,7 +6072,7 @@
               </a:lnSpc>
             </a:pPr>
             <a:r>
-              <a:rPr lang="en-US" sz="8000" b="1">
+              <a:rPr lang="en-US" sz="8000" b="1" dirty="0">
                 <a:solidFill>
                   <a:srgbClr val="000000"/>
                 </a:solidFill>
@@ -5840,28 +6081,28 @@
                 <a:cs typeface="Alegreya Sans SC Bold"/>
                 <a:sym typeface="Alegreya Sans SC Bold"/>
               </a:rPr>
-              <a:t>RSA Encryption – Practicality in the Real World</a:t>
-            </a:r>
-          </a:p>
-        </p:txBody>
-      </p:sp>
-      <p:sp>
-        <p:nvSpPr>
-          <p:cNvPr id="11" name="TextBox 11"/>
+              <a:t>RSA Encryption</a:t>
+            </a:r>
+          </a:p>
+        </p:txBody>
+      </p:sp>
+      <p:sp>
+        <p:nvSpPr>
+          <p:cNvPr id="13" name="TextBox 13"/>
           <p:cNvSpPr txBox="1"/>
           <p:nvPr/>
         </p:nvSpPr>
         <p:spPr>
           <a:xfrm>
-            <a:off x="1268778" y="4842467"/>
-            <a:ext cx="10066336" cy="4173093"/>
+            <a:off x="2061756" y="3692711"/>
+            <a:ext cx="6214041" cy="5171544"/>
           </a:xfrm>
           <a:prstGeom prst="rect">
             <a:avLst/>
           </a:prstGeom>
         </p:spPr>
         <p:txBody>
-          <a:bodyPr lIns="0" tIns="0" rIns="0" bIns="0" rtlCol="0" anchor="t">
+          <a:bodyPr wrap="square" lIns="0" tIns="0" rIns="0" bIns="0" rtlCol="0" anchor="t">
             <a:spAutoFit/>
           </a:bodyPr>
           <a:lstStyle/>
@@ -5872,7 +6113,7 @@
               </a:lnSpc>
             </a:pPr>
             <a:r>
-              <a:rPr lang="en-US" sz="2400">
+              <a:rPr lang="en-US" sz="2400" dirty="0">
                 <a:solidFill>
                   <a:srgbClr val="000000"/>
                 </a:solidFill>
@@ -5893,7 +6134,7 @@
               <a:buChar char="•"/>
             </a:pPr>
             <a:r>
-              <a:rPr lang="en-US" sz="2400">
+              <a:rPr lang="en-US" sz="2400" dirty="0">
                 <a:solidFill>
                   <a:srgbClr val="000000"/>
                 </a:solidFill>
@@ -5902,7 +6143,7 @@
                 <a:cs typeface="Aileron"/>
                 <a:sym typeface="Aileron"/>
               </a:rPr>
-              <a:t>•Were come up by engineers</a:t>
+              <a:t>Were come up by engineers</a:t>
             </a:r>
           </a:p>
           <a:p>
@@ -5914,7 +6155,7 @@
               <a:buChar char="•"/>
             </a:pPr>
             <a:r>
-              <a:rPr lang="en-US" sz="2400">
+              <a:rPr lang="en-US" sz="2400" dirty="0">
                 <a:solidFill>
                   <a:srgbClr val="000000"/>
                 </a:solidFill>
@@ -5923,7 +6164,7 @@
                 <a:cs typeface="Aileron"/>
                 <a:sym typeface="Aileron"/>
               </a:rPr>
-              <a:t>•Made to counter attackers intercepting public keys and sending/reading data without being a part of the connection</a:t>
+              <a:t>Made to counter attackers intercepting public keys and sending/reading data without being a part of the connection</a:t>
             </a:r>
           </a:p>
           <a:p>
@@ -5935,7 +6176,7 @@
               <a:buChar char="•"/>
             </a:pPr>
             <a:r>
-              <a:rPr lang="en-US" sz="2400">
+              <a:rPr lang="en-US" sz="2400" dirty="0">
                 <a:solidFill>
                   <a:srgbClr val="000000"/>
                 </a:solidFill>
@@ -5944,7 +6185,7 @@
                 <a:cs typeface="Aileron"/>
                 <a:sym typeface="Aileron"/>
               </a:rPr>
-              <a:t>•Are digitally signed by a trusted Certificate Authority</a:t>
+              <a:t>Are digitally signed by a trusted Certificate Authority</a:t>
             </a:r>
           </a:p>
           <a:p>
@@ -5956,7 +6197,7 @@
               <a:buChar char="•"/>
             </a:pPr>
             <a:r>
-              <a:rPr lang="en-US" sz="2400">
+              <a:rPr lang="en-US" sz="2400" dirty="0">
                 <a:solidFill>
                   <a:srgbClr val="000000"/>
                 </a:solidFill>
@@ -5965,7 +6206,7 @@
                 <a:cs typeface="Aileron"/>
                 <a:sym typeface="Aileron"/>
               </a:rPr>
-              <a:t>•Allows the client to verify that the public key actually belongs to the server</a:t>
+              <a:t>Allows the client to verify that the public key actually belongs to the server</a:t>
             </a:r>
           </a:p>
           <a:p>
@@ -5977,7 +6218,7 @@
               <a:buChar char="•"/>
             </a:pPr>
             <a:r>
-              <a:rPr lang="en-US" sz="2400">
+              <a:rPr lang="en-US" sz="2400" dirty="0">
                 <a:solidFill>
                   <a:srgbClr val="000000"/>
                 </a:solidFill>
@@ -5986,7 +6227,51 @@
                 <a:cs typeface="Aileron"/>
                 <a:sym typeface="Aileron"/>
               </a:rPr>
-              <a:t>•Is a binding of the public key to a domain, website, SSH connection or more</a:t>
+              <a:t>Is a binding of the public key to a domain, website, SSH connection or more</a:t>
+            </a:r>
+          </a:p>
+        </p:txBody>
+      </p:sp>
+      <p:sp>
+        <p:nvSpPr>
+          <p:cNvPr id="14" name="TextBox 14"/>
+          <p:cNvSpPr txBox="1"/>
+          <p:nvPr/>
+        </p:nvSpPr>
+        <p:spPr>
+          <a:xfrm>
+            <a:off x="4590636" y="1476181"/>
+            <a:ext cx="10209770" cy="1162050"/>
+          </a:xfrm>
+          <a:prstGeom prst="rect">
+            <a:avLst/>
+          </a:prstGeom>
+        </p:spPr>
+        <p:txBody>
+          <a:bodyPr lIns="0" tIns="0" rIns="0" bIns="0" rtlCol="0" anchor="t">
+            <a:spAutoFit/>
+          </a:bodyPr>
+          <a:lstStyle/>
+          <a:p>
+            <a:pPr algn="ctr">
+              <a:lnSpc>
+                <a:spcPts val="8400"/>
+              </a:lnSpc>
+              <a:spcBef>
+                <a:spcPct val="0"/>
+              </a:spcBef>
+            </a:pPr>
+            <a:r>
+              <a:rPr lang="en-US" sz="6000" dirty="0">
+                <a:solidFill>
+                  <a:srgbClr val="545454"/>
+                </a:solidFill>
+                <a:latin typeface="Alegreya Sans SC"/>
+                <a:ea typeface="Alegreya Sans SC"/>
+                <a:cs typeface="Alegreya Sans SC"/>
+                <a:sym typeface="Alegreya Sans SC"/>
+              </a:rPr>
+              <a:t>Practicality in the Real World</a:t>
             </a:r>
           </a:p>
         </p:txBody>
@@ -6321,10 +6606,10 @@
         </p:nvGrpSpPr>
         <p:grpSpPr>
           <a:xfrm>
-            <a:off x="6444296" y="4274154"/>
-            <a:ext cx="10476535" cy="5138605"/>
+            <a:off x="9372600" y="3800017"/>
+            <a:ext cx="10476535" cy="5451134"/>
             <a:chOff x="0" y="0"/>
-            <a:chExt cx="2759252" cy="1353377"/>
+            <a:chExt cx="2759252" cy="1435690"/>
           </a:xfrm>
         </p:grpSpPr>
         <p:sp>
@@ -6336,7 +6621,7 @@
           <p:spPr>
             <a:xfrm>
               <a:off x="0" y="0"/>
-              <a:ext cx="2759252" cy="1353377"/>
+              <a:ext cx="2759252" cy="1435689"/>
             </a:xfrm>
             <a:custGeom>
               <a:avLst/>
@@ -6345,7 +6630,7 @@
               <a:cxnLst/>
               <a:rect l="l" t="t" r="r" b="b"/>
               <a:pathLst>
-                <a:path w="2759252" h="1353377">
+                <a:path w="2759252" h="1435689">
                   <a:moveTo>
                     <a:pt x="37688" y="0"/>
                   </a:moveTo>
@@ -6358,20 +6643,20 @@
                     <a:pt x="2759252" y="37688"/>
                   </a:cubicBezTo>
                   <a:lnTo>
-                    <a:pt x="2759252" y="1315690"/>
+                    <a:pt x="2759252" y="1398002"/>
                   </a:lnTo>
                   <a:cubicBezTo>
-                    <a:pt x="2759252" y="1336504"/>
-                    <a:pt x="2742379" y="1353377"/>
-                    <a:pt x="2721564" y="1353377"/>
+                    <a:pt x="2759252" y="1418816"/>
+                    <a:pt x="2742379" y="1435689"/>
+                    <a:pt x="2721564" y="1435689"/>
                   </a:cubicBezTo>
                   <a:lnTo>
-                    <a:pt x="37688" y="1353377"/>
+                    <a:pt x="37688" y="1435689"/>
                   </a:lnTo>
                   <a:cubicBezTo>
-                    <a:pt x="16873" y="1353377"/>
-                    <a:pt x="0" y="1336504"/>
-                    <a:pt x="0" y="1315690"/>
+                    <a:pt x="16873" y="1435689"/>
+                    <a:pt x="0" y="1418816"/>
+                    <a:pt x="0" y="1398002"/>
                   </a:cubicBezTo>
                   <a:lnTo>
                     <a:pt x="0" y="37688"/>
@@ -6406,7 +6691,7 @@
           <p:spPr>
             <a:xfrm>
               <a:off x="0" y="-38100"/>
-              <a:ext cx="2759252" cy="1391477"/>
+              <a:ext cx="2759252" cy="1473790"/>
             </a:xfrm>
             <a:prstGeom prst="rect">
               <a:avLst/>
@@ -6431,14 +6716,67 @@
       </p:grpSp>
       <p:sp>
         <p:nvSpPr>
-          <p:cNvPr id="10" name="TextBox 10"/>
+          <p:cNvPr id="10" name="Freeform 10"/>
+          <p:cNvSpPr/>
+          <p:nvPr/>
+        </p:nvSpPr>
+        <p:spPr>
+          <a:xfrm>
+            <a:off x="1175729" y="2749834"/>
+            <a:ext cx="7038181" cy="7038181"/>
+          </a:xfrm>
+          <a:custGeom>
+            <a:avLst/>
+            <a:gdLst/>
+            <a:ahLst/>
+            <a:cxnLst/>
+            <a:rect l="l" t="t" r="r" b="b"/>
+            <a:pathLst>
+              <a:path w="5925271" h="5925271">
+                <a:moveTo>
+                  <a:pt x="0" y="0"/>
+                </a:moveTo>
+                <a:lnTo>
+                  <a:pt x="5925271" y="0"/>
+                </a:lnTo>
+                <a:lnTo>
+                  <a:pt x="5925271" y="5925271"/>
+                </a:lnTo>
+                <a:lnTo>
+                  <a:pt x="0" y="5925271"/>
+                </a:lnTo>
+                <a:lnTo>
+                  <a:pt x="0" y="0"/>
+                </a:lnTo>
+                <a:close/>
+              </a:path>
+            </a:pathLst>
+          </a:custGeom>
+          <a:blipFill>
+            <a:blip r:embed="rId5"/>
+            <a:stretch>
+              <a:fillRect/>
+            </a:stretch>
+          </a:blipFill>
+        </p:spPr>
+        <p:txBody>
+          <a:bodyPr/>
+          <a:lstStyle/>
+          <a:p>
+            <a:endParaRPr lang="en-CA"/>
+          </a:p>
+        </p:txBody>
+      </p:sp>
+      <p:sp>
+        <p:nvSpPr>
+          <p:cNvPr id="11" name="TextBox 11"/>
           <p:cNvSpPr txBox="1"/>
           <p:nvPr/>
         </p:nvSpPr>
         <p:spPr>
           <a:xfrm>
-            <a:off x="1698662" y="1509864"/>
-            <a:ext cx="13548977" cy="2370455"/>
+            <a:off x="2890656" y="885474"/>
+            <a:ext cx="13548977" cy="1284605"/>
           </a:xfrm>
           <a:prstGeom prst="rect">
             <a:avLst/>
@@ -6465,21 +6803,21 @@
                 <a:cs typeface="Alegreya Sans SC Bold"/>
                 <a:sym typeface="Alegreya Sans SC Bold"/>
               </a:rPr>
-              <a:t>How It’s Most Commonly Used (SSH)</a:t>
-            </a:r>
-          </a:p>
-        </p:txBody>
-      </p:sp>
-      <p:sp>
-        <p:nvSpPr>
-          <p:cNvPr id="11" name="TextBox 11"/>
+              <a:t>How RSA Works in the World </a:t>
+            </a:r>
+          </a:p>
+        </p:txBody>
+      </p:sp>
+      <p:sp>
+        <p:nvSpPr>
+          <p:cNvPr id="12" name="TextBox 12"/>
           <p:cNvSpPr txBox="1"/>
           <p:nvPr/>
         </p:nvSpPr>
         <p:spPr>
           <a:xfrm>
-            <a:off x="6850958" y="4485448"/>
-            <a:ext cx="9894900" cy="4639818"/>
+            <a:off x="9779262" y="4011310"/>
+            <a:ext cx="9894900" cy="5573268"/>
           </a:xfrm>
           <a:prstGeom prst="rect">
             <a:avLst/>
@@ -6490,108 +6828,160 @@
             <a:spAutoFit/>
           </a:bodyPr>
           <a:lstStyle/>
+          <a:p>
+            <a:pPr marL="518160" lvl="1" indent="-259080" algn="l">
+              <a:lnSpc>
+                <a:spcPts val="3696"/>
+              </a:lnSpc>
+              <a:buFont typeface="Arial"/>
+              <a:buChar char="•"/>
+            </a:pPr>
+            <a:r>
+              <a:rPr lang="en-US" sz="2400" dirty="0">
+                <a:solidFill>
+                  <a:srgbClr val="000000"/>
+                </a:solidFill>
+                <a:latin typeface="Aileron"/>
+                <a:ea typeface="Aileron"/>
+                <a:cs typeface="Aileron"/>
+                <a:sym typeface="Aileron"/>
+              </a:rPr>
+              <a:t>Asymmetric encryption algorithms can be used anytime a client wants to send or receive data</a:t>
+            </a:r>
+          </a:p>
+          <a:p>
+            <a:pPr marL="518160" lvl="1" indent="-259080" algn="l">
+              <a:lnSpc>
+                <a:spcPts val="3696"/>
+              </a:lnSpc>
+              <a:buFont typeface="Arial"/>
+              <a:buChar char="•"/>
+            </a:pPr>
+            <a:r>
+              <a:rPr lang="en-US" sz="2400" dirty="0">
+                <a:solidFill>
+                  <a:srgbClr val="000000"/>
+                </a:solidFill>
+                <a:latin typeface="Aileron"/>
+                <a:ea typeface="Aileron"/>
+                <a:cs typeface="Aileron"/>
+                <a:sym typeface="Aileron"/>
+              </a:rPr>
+              <a:t>RSA is safer than https over public networks</a:t>
+            </a:r>
+          </a:p>
+          <a:p>
+            <a:pPr marL="518160" lvl="1" indent="-259080" algn="l">
+              <a:lnSpc>
+                <a:spcPts val="3696"/>
+              </a:lnSpc>
+              <a:buFont typeface="Arial"/>
+              <a:buChar char="•"/>
+            </a:pPr>
+            <a:r>
+              <a:rPr lang="en-US" sz="2400" dirty="0">
+                <a:solidFill>
+                  <a:srgbClr val="000000"/>
+                </a:solidFill>
+                <a:latin typeface="Aileron"/>
+                <a:ea typeface="Aileron"/>
+                <a:cs typeface="Aileron"/>
+                <a:sym typeface="Aileron"/>
+              </a:rPr>
+              <a:t>RSA uses a keypair</a:t>
+            </a:r>
+          </a:p>
+          <a:p>
+            <a:pPr marL="518160" lvl="1" indent="-259080" algn="l">
+              <a:lnSpc>
+                <a:spcPts val="3696"/>
+              </a:lnSpc>
+              <a:buFont typeface="Arial"/>
+              <a:buChar char="•"/>
+            </a:pPr>
+            <a:r>
+              <a:rPr lang="en-US" sz="2400" dirty="0">
+                <a:solidFill>
+                  <a:srgbClr val="000000"/>
+                </a:solidFill>
+                <a:latin typeface="Aileron"/>
+                <a:ea typeface="Aileron"/>
+                <a:cs typeface="Aileron"/>
+                <a:sym typeface="Aileron"/>
+              </a:rPr>
+              <a:t>You cannot derive public from private keys</a:t>
+            </a:r>
+          </a:p>
+          <a:p>
+            <a:pPr marL="518160" lvl="1" indent="-259080" algn="l">
+              <a:lnSpc>
+                <a:spcPts val="3696"/>
+              </a:lnSpc>
+              <a:buFont typeface="Arial"/>
+              <a:buChar char="•"/>
+            </a:pPr>
+            <a:r>
+              <a:rPr lang="en-US" sz="2400" dirty="0">
+                <a:solidFill>
+                  <a:srgbClr val="000000"/>
+                </a:solidFill>
+                <a:latin typeface="Aileron"/>
+                <a:ea typeface="Aileron"/>
+                <a:cs typeface="Aileron"/>
+                <a:sym typeface="Aileron"/>
+              </a:rPr>
+              <a:t>RSA over open networks are very secure</a:t>
+            </a:r>
+          </a:p>
+          <a:p>
+            <a:pPr marL="518160" lvl="1" indent="-259080" algn="l">
+              <a:lnSpc>
+                <a:spcPts val="3696"/>
+              </a:lnSpc>
+              <a:buFont typeface="Arial"/>
+              <a:buChar char="•"/>
+            </a:pPr>
+            <a:r>
+              <a:rPr lang="en-US" sz="2400" dirty="0">
+                <a:solidFill>
+                  <a:srgbClr val="000000"/>
+                </a:solidFill>
+                <a:latin typeface="Aileron"/>
+                <a:ea typeface="Aileron"/>
+                <a:cs typeface="Aileron"/>
+                <a:sym typeface="Aileron"/>
+              </a:rPr>
+              <a:t>Https authenticates websites using certificates</a:t>
+            </a:r>
+          </a:p>
+          <a:p>
+            <a:pPr marL="518160" lvl="1" indent="-259080" algn="l">
+              <a:lnSpc>
+                <a:spcPts val="3696"/>
+              </a:lnSpc>
+              <a:buFont typeface="Arial"/>
+              <a:buChar char="•"/>
+            </a:pPr>
+            <a:r>
+              <a:rPr lang="en-US" sz="2400" dirty="0">
+                <a:solidFill>
+                  <a:srgbClr val="000000"/>
+                </a:solidFill>
+                <a:latin typeface="Aileron"/>
+                <a:ea typeface="Aileron"/>
+                <a:cs typeface="Aileron"/>
+                <a:sym typeface="Aileron"/>
+              </a:rPr>
+              <a:t>Establishes a secure session</a:t>
+            </a:r>
+          </a:p>
           <a:p>
             <a:pPr algn="l">
               <a:lnSpc>
                 <a:spcPts val="3696"/>
               </a:lnSpc>
             </a:pPr>
-            <a:r>
-              <a:rPr lang="en-US" sz="2400">
-                <a:solidFill>
-                  <a:srgbClr val="000000"/>
-                </a:solidFill>
-                <a:latin typeface="Aileron"/>
-                <a:ea typeface="Aileron"/>
-                <a:cs typeface="Aileron"/>
-                <a:sym typeface="Aileron"/>
-              </a:rPr>
-              <a:t>•Asymmetric encryption algorithms can be used anytime a client wants to send or receive data</a:t>
-            </a:r>
-          </a:p>
-          <a:p>
-            <a:pPr algn="l">
-              <a:lnSpc>
-                <a:spcPts val="3696"/>
-              </a:lnSpc>
-            </a:pPr>
-            <a:r>
-              <a:rPr lang="en-US" sz="2400">
-                <a:solidFill>
-                  <a:srgbClr val="000000"/>
-                </a:solidFill>
-                <a:latin typeface="Aileron"/>
-                <a:ea typeface="Aileron"/>
-                <a:cs typeface="Aileron"/>
-                <a:sym typeface="Aileron"/>
-              </a:rPr>
-              <a:t>•RSA is safer than https over public networks</a:t>
-            </a:r>
-          </a:p>
-          <a:p>
-            <a:pPr algn="l">
-              <a:lnSpc>
-                <a:spcPts val="3696"/>
-              </a:lnSpc>
-            </a:pPr>
-            <a:r>
-              <a:rPr lang="en-US" sz="2400">
-                <a:solidFill>
-                  <a:srgbClr val="000000"/>
-                </a:solidFill>
-                <a:latin typeface="Aileron"/>
-                <a:ea typeface="Aileron"/>
-                <a:cs typeface="Aileron"/>
-                <a:sym typeface="Aileron"/>
-              </a:rPr>
-              <a:t>•RSA uses a keypair</a:t>
-            </a:r>
-          </a:p>
-          <a:p>
-            <a:pPr algn="l">
-              <a:lnSpc>
-                <a:spcPts val="3696"/>
-              </a:lnSpc>
-            </a:pPr>
-            <a:r>
-              <a:rPr lang="en-US" sz="2400">
-                <a:solidFill>
-                  <a:srgbClr val="000000"/>
-                </a:solidFill>
-                <a:latin typeface="Aileron"/>
-                <a:ea typeface="Aileron"/>
-                <a:cs typeface="Aileron"/>
-                <a:sym typeface="Aileron"/>
-              </a:rPr>
-              <a:t>•You cannot derive public from private keys</a:t>
-            </a:r>
-          </a:p>
-          <a:p>
-            <a:pPr algn="l">
-              <a:lnSpc>
-                <a:spcPts val="3696"/>
-              </a:lnSpc>
-            </a:pPr>
-            <a:r>
-              <a:rPr lang="en-US" sz="2400">
-                <a:solidFill>
-                  <a:srgbClr val="000000"/>
-                </a:solidFill>
-                <a:latin typeface="Aileron"/>
-                <a:ea typeface="Aileron"/>
-                <a:cs typeface="Aileron"/>
-                <a:sym typeface="Aileron"/>
-              </a:rPr>
-              <a:t>•RSA over open networks are very secure</a:t>
-            </a:r>
-          </a:p>
-          <a:p>
-            <a:pPr algn="l">
-              <a:lnSpc>
-                <a:spcPts val="3696"/>
-              </a:lnSpc>
-            </a:pPr>
-            <a:endParaRPr lang="en-US" sz="2400">
+            <a:endParaRPr lang="en-US" sz="2400" dirty="0">
               <a:solidFill>
                 <a:srgbClr val="000000"/>
               </a:solidFill>
@@ -6608,7 +6998,7 @@
               </a:lnSpc>
             </a:pPr>
             <a:r>
-              <a:rPr lang="en-US" sz="2400">
+              <a:rPr lang="en-US" sz="2400" dirty="0">
                 <a:solidFill>
                   <a:srgbClr val="000000"/>
                 </a:solidFill>
@@ -6626,7 +7016,7 @@
                 <a:spcPts val="3696"/>
               </a:lnSpc>
             </a:pPr>
-            <a:endParaRPr lang="en-US" sz="2400">
+            <a:endParaRPr lang="en-US" sz="2400" dirty="0">
               <a:solidFill>
                 <a:srgbClr val="000000"/>
               </a:solidFill>
@@ -6635,6 +7025,50 @@
               <a:cs typeface="Aileron"/>
               <a:sym typeface="Aileron"/>
             </a:endParaRPr>
+          </a:p>
+        </p:txBody>
+      </p:sp>
+      <p:sp>
+        <p:nvSpPr>
+          <p:cNvPr id="13" name="TextBox 13"/>
+          <p:cNvSpPr txBox="1"/>
+          <p:nvPr/>
+        </p:nvSpPr>
+        <p:spPr>
+          <a:xfrm>
+            <a:off x="6646724" y="1576539"/>
+            <a:ext cx="6265075" cy="961802"/>
+          </a:xfrm>
+          <a:prstGeom prst="rect">
+            <a:avLst/>
+          </a:prstGeom>
+        </p:spPr>
+        <p:txBody>
+          <a:bodyPr wrap="square" lIns="0" tIns="0" rIns="0" bIns="0" rtlCol="0" anchor="t">
+            <a:spAutoFit/>
+          </a:bodyPr>
+          <a:lstStyle/>
+          <a:p>
+            <a:pPr algn="ctr">
+              <a:lnSpc>
+                <a:spcPts val="8400"/>
+              </a:lnSpc>
+              <a:spcBef>
+                <a:spcPct val="0"/>
+              </a:spcBef>
+            </a:pPr>
+            <a:r>
+              <a:rPr lang="en-US" sz="6000" dirty="0">
+                <a:solidFill>
+                  <a:srgbClr val="545454"/>
+                </a:solidFill>
+                <a:latin typeface="Alegreya Sans SC"/>
+                <a:ea typeface="Alegreya Sans SC"/>
+                <a:cs typeface="Alegreya Sans SC"/>
+                <a:sym typeface="Alegreya Sans SC"/>
+              </a:rPr>
+              <a:t>Real world Usage</a:t>
+            </a:r>
           </a:p>
         </p:txBody>
       </p:sp>
@@ -6968,10 +7402,10 @@
         </p:nvGrpSpPr>
         <p:grpSpPr>
           <a:xfrm>
-            <a:off x="3200400" y="2794469"/>
-            <a:ext cx="10515599" cy="7053902"/>
+            <a:off x="1519878" y="2746756"/>
+            <a:ext cx="7639795" cy="6591008"/>
             <a:chOff x="0" y="0"/>
-            <a:chExt cx="2637305" cy="1857818"/>
+            <a:chExt cx="2012127" cy="1735903"/>
           </a:xfrm>
         </p:grpSpPr>
         <p:sp>
@@ -6983,7 +7417,7 @@
           <p:spPr>
             <a:xfrm>
               <a:off x="0" y="0"/>
-              <a:ext cx="2637305" cy="1857818"/>
+              <a:ext cx="2012127" cy="1735903"/>
             </a:xfrm>
             <a:custGeom>
               <a:avLst/>
@@ -6992,61 +7426,61 @@
               <a:cxnLst/>
               <a:rect l="l" t="t" r="r" b="b"/>
               <a:pathLst>
-                <a:path w="2637305" h="1857818">
+                <a:path w="2012127" h="1735903">
                   <a:moveTo>
-                    <a:pt x="39430" y="0"/>
+                    <a:pt x="51682" y="0"/>
                   </a:moveTo>
                   <a:lnTo>
-                    <a:pt x="2597874" y="0"/>
+                    <a:pt x="1960445" y="0"/>
                   </a:lnTo>
                   <a:cubicBezTo>
-                    <a:pt x="2608332" y="0"/>
-                    <a:pt x="2618361" y="4154"/>
-                    <a:pt x="2625756" y="11549"/>
+                    <a:pt x="1974152" y="0"/>
+                    <a:pt x="1987298" y="5445"/>
+                    <a:pt x="1996990" y="15137"/>
                   </a:cubicBezTo>
                   <a:cubicBezTo>
-                    <a:pt x="2633151" y="18944"/>
-                    <a:pt x="2637305" y="28973"/>
-                    <a:pt x="2637305" y="39430"/>
+                    <a:pt x="2006682" y="24829"/>
+                    <a:pt x="2012127" y="37975"/>
+                    <a:pt x="2012127" y="51682"/>
                   </a:cubicBezTo>
                   <a:lnTo>
-                    <a:pt x="2637305" y="1818387"/>
+                    <a:pt x="2012127" y="1684222"/>
                   </a:lnTo>
                   <a:cubicBezTo>
-                    <a:pt x="2637305" y="1828845"/>
-                    <a:pt x="2633151" y="1838874"/>
-                    <a:pt x="2625756" y="1846269"/>
+                    <a:pt x="2012127" y="1697929"/>
+                    <a:pt x="2006682" y="1711074"/>
+                    <a:pt x="1996990" y="1720766"/>
                   </a:cubicBezTo>
                   <a:cubicBezTo>
-                    <a:pt x="2618361" y="1853664"/>
-                    <a:pt x="2608332" y="1857818"/>
-                    <a:pt x="2597874" y="1857818"/>
+                    <a:pt x="1987298" y="1730458"/>
+                    <a:pt x="1974152" y="1735903"/>
+                    <a:pt x="1960445" y="1735903"/>
                   </a:cubicBezTo>
                   <a:lnTo>
-                    <a:pt x="39430" y="1857818"/>
+                    <a:pt x="51682" y="1735903"/>
                   </a:lnTo>
                   <a:cubicBezTo>
-                    <a:pt x="28973" y="1857818"/>
-                    <a:pt x="18944" y="1853664"/>
-                    <a:pt x="11549" y="1846269"/>
+                    <a:pt x="37975" y="1735903"/>
+                    <a:pt x="24829" y="1730458"/>
+                    <a:pt x="15137" y="1720766"/>
                   </a:cubicBezTo>
                   <a:cubicBezTo>
-                    <a:pt x="4154" y="1838874"/>
-                    <a:pt x="0" y="1828845"/>
-                    <a:pt x="0" y="1818387"/>
+                    <a:pt x="5445" y="1711074"/>
+                    <a:pt x="0" y="1697929"/>
+                    <a:pt x="0" y="1684222"/>
                   </a:cubicBezTo>
                   <a:lnTo>
-                    <a:pt x="0" y="39430"/>
+                    <a:pt x="0" y="51682"/>
                   </a:lnTo>
                   <a:cubicBezTo>
-                    <a:pt x="0" y="28973"/>
-                    <a:pt x="4154" y="18944"/>
-                    <a:pt x="11549" y="11549"/>
+                    <a:pt x="0" y="37975"/>
+                    <a:pt x="5445" y="24829"/>
+                    <a:pt x="15137" y="15137"/>
                   </a:cubicBezTo>
                   <a:cubicBezTo>
-                    <a:pt x="18944" y="4154"/>
-                    <a:pt x="28973" y="0"/>
-                    <a:pt x="39430" y="0"/>
+                    <a:pt x="24829" y="5445"/>
+                    <a:pt x="37975" y="0"/>
+                    <a:pt x="51682" y="0"/>
                   </a:cubicBezTo>
                   <a:close/>
                 </a:path>
@@ -7073,7 +7507,7 @@
           <p:spPr>
             <a:xfrm>
               <a:off x="0" y="-38100"/>
-              <a:ext cx="2637305" cy="1895918"/>
+              <a:ext cx="2012127" cy="1774003"/>
             </a:xfrm>
             <a:prstGeom prst="rect">
               <a:avLst/>
@@ -7098,13 +7532,71 @@
       </p:grpSp>
       <p:sp>
         <p:nvSpPr>
-          <p:cNvPr id="10" name="TextBox 10"/>
+          <p:cNvPr id="10" name="Freeform 10"/>
+          <p:cNvSpPr/>
+          <p:nvPr/>
+        </p:nvSpPr>
+        <p:spPr>
+          <a:xfrm>
+            <a:off x="10317571" y="2943917"/>
+            <a:ext cx="10209770" cy="6401055"/>
+          </a:xfrm>
+          <a:custGeom>
+            <a:avLst/>
+            <a:gdLst/>
+            <a:ahLst/>
+            <a:cxnLst/>
+            <a:rect l="l" t="t" r="r" b="b"/>
+            <a:pathLst>
+              <a:path w="9893128" h="5564885">
+                <a:moveTo>
+                  <a:pt x="0" y="0"/>
+                </a:moveTo>
+                <a:lnTo>
+                  <a:pt x="9893128" y="0"/>
+                </a:lnTo>
+                <a:lnTo>
+                  <a:pt x="9893128" y="5564884"/>
+                </a:lnTo>
+                <a:lnTo>
+                  <a:pt x="0" y="5564884"/>
+                </a:lnTo>
+                <a:lnTo>
+                  <a:pt x="0" y="0"/>
+                </a:lnTo>
+                <a:close/>
+              </a:path>
+            </a:pathLst>
+          </a:custGeom>
+          <a:blipFill>
+            <a:blip r:embed="rId5"/>
+            <a:stretch>
+              <a:fillRect/>
+            </a:stretch>
+          </a:blipFill>
+          <a:ln cap="sq">
+            <a:noFill/>
+            <a:prstDash val="solid"/>
+            <a:miter/>
+          </a:ln>
+        </p:spPr>
+        <p:txBody>
+          <a:bodyPr/>
+          <a:lstStyle/>
+          <a:p>
+            <a:endParaRPr lang="en-CA"/>
+          </a:p>
+        </p:txBody>
+      </p:sp>
+      <p:sp>
+        <p:nvSpPr>
+          <p:cNvPr id="11" name="TextBox 11"/>
           <p:cNvSpPr txBox="1"/>
           <p:nvPr/>
         </p:nvSpPr>
         <p:spPr>
           <a:xfrm>
-            <a:off x="1495766" y="1509864"/>
+            <a:off x="2514600" y="695855"/>
             <a:ext cx="13798211" cy="1284605"/>
           </a:xfrm>
           <a:prstGeom prst="rect">
@@ -7123,7 +7615,7 @@
               </a:lnSpc>
             </a:pPr>
             <a:r>
-              <a:rPr lang="en-US" sz="8000" b="1">
+              <a:rPr lang="en-US" sz="8000" b="1" dirty="0">
                 <a:solidFill>
                   <a:srgbClr val="000000"/>
                 </a:solidFill>
@@ -7132,21 +7624,21 @@
                 <a:cs typeface="Alegreya Sans SC Bold"/>
                 <a:sym typeface="Alegreya Sans SC Bold"/>
               </a:rPr>
-              <a:t>RSA Encryption – The Future</a:t>
-            </a:r>
-          </a:p>
-        </p:txBody>
-      </p:sp>
-      <p:sp>
-        <p:nvSpPr>
-          <p:cNvPr id="11" name="TextBox 11"/>
+              <a:t>RSA Encryption</a:t>
+            </a:r>
+          </a:p>
+        </p:txBody>
+      </p:sp>
+      <p:sp>
+        <p:nvSpPr>
+          <p:cNvPr id="12" name="TextBox 12"/>
           <p:cNvSpPr txBox="1"/>
           <p:nvPr/>
         </p:nvSpPr>
         <p:spPr>
           <a:xfrm>
-            <a:off x="3388113" y="3058700"/>
-            <a:ext cx="9894900" cy="6973443"/>
+            <a:off x="1828800" y="2989619"/>
+            <a:ext cx="7873345" cy="6496137"/>
           </a:xfrm>
           <a:prstGeom prst="rect">
             <a:avLst/>
@@ -7158,13 +7650,13 @@
           </a:bodyPr>
           <a:lstStyle/>
           <a:p>
-            <a:pPr algn="ctr">
+            <a:pPr algn="l">
               <a:lnSpc>
-                <a:spcPts val="3696"/>
+                <a:spcPts val="3388"/>
               </a:lnSpc>
             </a:pPr>
             <a:r>
-              <a:rPr lang="en-US" sz="2400">
+              <a:rPr lang="en-US" sz="2200" dirty="0">
                 <a:solidFill>
                   <a:srgbClr val="000000"/>
                 </a:solidFill>
@@ -7177,13 +7669,13 @@
             </a:r>
           </a:p>
           <a:p>
-            <a:pPr algn="ctr">
+            <a:pPr algn="l">
               <a:lnSpc>
-                <a:spcPts val="3696"/>
+                <a:spcPts val="3388"/>
               </a:lnSpc>
             </a:pPr>
             <a:r>
-              <a:rPr lang="en-US" sz="2400">
+              <a:rPr lang="en-US" sz="2200" dirty="0">
                 <a:solidFill>
                   <a:srgbClr val="000000"/>
                 </a:solidFill>
@@ -7196,12 +7688,12 @@
             </a:r>
           </a:p>
           <a:p>
-            <a:pPr algn="ctr">
+            <a:pPr algn="l">
               <a:lnSpc>
-                <a:spcPts val="3696"/>
+                <a:spcPts val="3388"/>
               </a:lnSpc>
             </a:pPr>
-            <a:endParaRPr lang="en-US" sz="2400">
+            <a:endParaRPr lang="en-US" sz="2200" dirty="0">
               <a:solidFill>
                 <a:srgbClr val="000000"/>
               </a:solidFill>
@@ -7212,13 +7704,13 @@
             </a:endParaRPr>
           </a:p>
           <a:p>
-            <a:pPr algn="ctr">
+            <a:pPr algn="l">
               <a:lnSpc>
-                <a:spcPts val="3696"/>
+                <a:spcPts val="3388"/>
               </a:lnSpc>
             </a:pPr>
             <a:r>
-              <a:rPr lang="en-US" sz="2400">
+              <a:rPr lang="en-US" sz="2200" dirty="0">
                 <a:solidFill>
                   <a:srgbClr val="000000"/>
                 </a:solidFill>
@@ -7231,13 +7723,13 @@
             </a:r>
           </a:p>
           <a:p>
-            <a:pPr algn="ctr">
+            <a:pPr algn="l">
               <a:lnSpc>
-                <a:spcPts val="3696"/>
+                <a:spcPts val="3388"/>
               </a:lnSpc>
             </a:pPr>
             <a:r>
-              <a:rPr lang="en-US" sz="2400">
+              <a:rPr lang="en-US" sz="2200" dirty="0">
                 <a:solidFill>
                   <a:srgbClr val="000000"/>
                 </a:solidFill>
@@ -7250,13 +7742,13 @@
             </a:r>
           </a:p>
           <a:p>
-            <a:pPr algn="ctr">
+            <a:pPr algn="l">
               <a:lnSpc>
-                <a:spcPts val="3696"/>
+                <a:spcPts val="3388"/>
               </a:lnSpc>
             </a:pPr>
             <a:r>
-              <a:rPr lang="en-US" sz="2400">
+              <a:rPr lang="en-US" sz="2200" dirty="0">
                 <a:solidFill>
                   <a:srgbClr val="000000"/>
                 </a:solidFill>
@@ -7269,12 +7761,12 @@
             </a:r>
           </a:p>
           <a:p>
-            <a:pPr algn="ctr">
+            <a:pPr algn="l">
               <a:lnSpc>
-                <a:spcPts val="3696"/>
+                <a:spcPts val="3388"/>
               </a:lnSpc>
             </a:pPr>
-            <a:endParaRPr lang="en-US" sz="2400">
+            <a:endParaRPr lang="en-US" sz="2200" dirty="0">
               <a:solidFill>
                 <a:srgbClr val="000000"/>
               </a:solidFill>
@@ -7285,13 +7777,13 @@
             </a:endParaRPr>
           </a:p>
           <a:p>
-            <a:pPr algn="ctr">
+            <a:pPr algn="l">
               <a:lnSpc>
-                <a:spcPts val="3696"/>
+                <a:spcPts val="3388"/>
               </a:lnSpc>
             </a:pPr>
             <a:r>
-              <a:rPr lang="en-US" sz="2400">
+              <a:rPr lang="en-US" sz="2200" dirty="0">
                 <a:solidFill>
                   <a:srgbClr val="000000"/>
                 </a:solidFill>
@@ -7300,17 +7792,17 @@
                 <a:cs typeface="Aileron"/>
                 <a:sym typeface="Aileron"/>
               </a:rPr>
-              <a:t>The National Institute of Standards and Technologyis preparing to switch from RSA encryption by 2030.</a:t>
-            </a:r>
-          </a:p>
-          <a:p>
-            <a:pPr algn="ctr">
+              <a:t>The National Institute of Standards and Technology is preparing to switch from RSA encryption by 2030.</a:t>
+            </a:r>
+          </a:p>
+          <a:p>
+            <a:pPr algn="l">
               <a:lnSpc>
-                <a:spcPts val="3696"/>
+                <a:spcPts val="3388"/>
               </a:lnSpc>
             </a:pPr>
             <a:r>
-              <a:rPr lang="en-US" sz="2400">
+              <a:rPr lang="en-US" sz="2200" dirty="0">
                 <a:solidFill>
                   <a:srgbClr val="000000"/>
                 </a:solidFill>
@@ -7323,12 +7815,12 @@
             </a:r>
           </a:p>
           <a:p>
-            <a:pPr algn="ctr">
+            <a:pPr algn="l">
               <a:lnSpc>
-                <a:spcPts val="3696"/>
+                <a:spcPts val="3388"/>
               </a:lnSpc>
             </a:pPr>
-            <a:endParaRPr lang="en-US" sz="2400">
+            <a:endParaRPr lang="en-US" sz="2200" dirty="0">
               <a:solidFill>
                 <a:srgbClr val="000000"/>
               </a:solidFill>
@@ -7339,13 +7831,13 @@
             </a:endParaRPr>
           </a:p>
           <a:p>
-            <a:pPr algn="ctr">
+            <a:pPr algn="l">
               <a:lnSpc>
-                <a:spcPts val="3696"/>
+                <a:spcPts val="3388"/>
               </a:lnSpc>
             </a:pPr>
             <a:r>
-              <a:rPr lang="en-US" sz="2400">
+              <a:rPr lang="en-US" sz="2200" dirty="0">
                 <a:solidFill>
                   <a:srgbClr val="000000"/>
                 </a:solidFill>
@@ -7358,12 +7850,12 @@
             </a:r>
           </a:p>
           <a:p>
-            <a:pPr algn="ctr">
+            <a:pPr algn="l">
               <a:lnSpc>
-                <a:spcPts val="3696"/>
+                <a:spcPts val="3388"/>
               </a:lnSpc>
             </a:pPr>
-            <a:endParaRPr lang="en-US" sz="2400">
+            <a:endParaRPr lang="en-US" sz="2200" dirty="0">
               <a:solidFill>
                 <a:srgbClr val="000000"/>
               </a:solidFill>
@@ -7372,6 +7864,50 @@
               <a:cs typeface="Aileron"/>
               <a:sym typeface="Aileron"/>
             </a:endParaRPr>
+          </a:p>
+        </p:txBody>
+      </p:sp>
+      <p:sp>
+        <p:nvSpPr>
+          <p:cNvPr id="13" name="TextBox 13"/>
+          <p:cNvSpPr txBox="1"/>
+          <p:nvPr/>
+        </p:nvSpPr>
+        <p:spPr>
+          <a:xfrm>
+            <a:off x="4617742" y="1447909"/>
+            <a:ext cx="10209770" cy="1162050"/>
+          </a:xfrm>
+          <a:prstGeom prst="rect">
+            <a:avLst/>
+          </a:prstGeom>
+        </p:spPr>
+        <p:txBody>
+          <a:bodyPr lIns="0" tIns="0" rIns="0" bIns="0" rtlCol="0" anchor="t">
+            <a:spAutoFit/>
+          </a:bodyPr>
+          <a:lstStyle/>
+          <a:p>
+            <a:pPr algn="ctr">
+              <a:lnSpc>
+                <a:spcPts val="8400"/>
+              </a:lnSpc>
+              <a:spcBef>
+                <a:spcPct val="0"/>
+              </a:spcBef>
+            </a:pPr>
+            <a:r>
+              <a:rPr lang="en-US" sz="6000" dirty="0">
+                <a:solidFill>
+                  <a:srgbClr val="545454"/>
+                </a:solidFill>
+                <a:latin typeface="Alegreya Sans SC"/>
+                <a:ea typeface="Alegreya Sans SC"/>
+                <a:cs typeface="Alegreya Sans SC"/>
+                <a:sym typeface="Alegreya Sans SC"/>
+              </a:rPr>
+              <a:t>The Future</a:t>
+            </a:r>
           </a:p>
         </p:txBody>
       </p:sp>
@@ -7705,10 +8241,10 @@
         </p:nvGrpSpPr>
         <p:grpSpPr>
           <a:xfrm>
-            <a:off x="3340254" y="3194621"/>
-            <a:ext cx="10543441" cy="5648144"/>
+            <a:off x="10679784" y="2832309"/>
+            <a:ext cx="8921616" cy="5924665"/>
             <a:chOff x="0" y="0"/>
-            <a:chExt cx="2776873" cy="1487577"/>
+            <a:chExt cx="2349726" cy="1560406"/>
           </a:xfrm>
         </p:grpSpPr>
         <p:sp>
@@ -7720,7 +8256,7 @@
           <p:spPr>
             <a:xfrm>
               <a:off x="0" y="0"/>
-              <a:ext cx="2776873" cy="1487577"/>
+              <a:ext cx="2349726" cy="1560406"/>
             </a:xfrm>
             <a:custGeom>
               <a:avLst/>
@@ -7729,41 +8265,61 @@
               <a:cxnLst/>
               <a:rect l="l" t="t" r="r" b="b"/>
               <a:pathLst>
-                <a:path w="2776873" h="1487577">
+                <a:path w="2349726" h="1560406">
                   <a:moveTo>
-                    <a:pt x="37449" y="0"/>
+                    <a:pt x="44256" y="0"/>
                   </a:moveTo>
                   <a:lnTo>
-                    <a:pt x="2739425" y="0"/>
+                    <a:pt x="2305470" y="0"/>
                   </a:lnTo>
                   <a:cubicBezTo>
-                    <a:pt x="2760107" y="0"/>
-                    <a:pt x="2776873" y="16766"/>
-                    <a:pt x="2776873" y="37449"/>
+                    <a:pt x="2317207" y="0"/>
+                    <a:pt x="2328464" y="4663"/>
+                    <a:pt x="2336764" y="12962"/>
+                  </a:cubicBezTo>
+                  <a:cubicBezTo>
+                    <a:pt x="2345063" y="21262"/>
+                    <a:pt x="2349726" y="32519"/>
+                    <a:pt x="2349726" y="44256"/>
                   </a:cubicBezTo>
                   <a:lnTo>
-                    <a:pt x="2776873" y="1450128"/>
+                    <a:pt x="2349726" y="1516149"/>
                   </a:lnTo>
                   <a:cubicBezTo>
-                    <a:pt x="2776873" y="1470811"/>
-                    <a:pt x="2760107" y="1487577"/>
-                    <a:pt x="2739425" y="1487577"/>
+                    <a:pt x="2349726" y="1527887"/>
+                    <a:pt x="2345063" y="1539144"/>
+                    <a:pt x="2336764" y="1547443"/>
+                  </a:cubicBezTo>
+                  <a:cubicBezTo>
+                    <a:pt x="2328464" y="1555743"/>
+                    <a:pt x="2317207" y="1560406"/>
+                    <a:pt x="2305470" y="1560406"/>
                   </a:cubicBezTo>
                   <a:lnTo>
-                    <a:pt x="37449" y="1487577"/>
+                    <a:pt x="44256" y="1560406"/>
                   </a:lnTo>
                   <a:cubicBezTo>
-                    <a:pt x="16766" y="1487577"/>
-                    <a:pt x="0" y="1470811"/>
-                    <a:pt x="0" y="1450128"/>
+                    <a:pt x="32519" y="1560406"/>
+                    <a:pt x="21262" y="1555743"/>
+                    <a:pt x="12962" y="1547443"/>
+                  </a:cubicBezTo>
+                  <a:cubicBezTo>
+                    <a:pt x="4663" y="1539144"/>
+                    <a:pt x="0" y="1527887"/>
+                    <a:pt x="0" y="1516149"/>
                   </a:cubicBezTo>
                   <a:lnTo>
-                    <a:pt x="0" y="37449"/>
+                    <a:pt x="0" y="44256"/>
                   </a:lnTo>
                   <a:cubicBezTo>
-                    <a:pt x="0" y="16766"/>
-                    <a:pt x="16766" y="0"/>
-                    <a:pt x="37449" y="0"/>
+                    <a:pt x="0" y="32519"/>
+                    <a:pt x="4663" y="21262"/>
+                    <a:pt x="12962" y="12962"/>
+                  </a:cubicBezTo>
+                  <a:cubicBezTo>
+                    <a:pt x="21262" y="4663"/>
+                    <a:pt x="32519" y="0"/>
+                    <a:pt x="44256" y="0"/>
                   </a:cubicBezTo>
                   <a:close/>
                 </a:path>
@@ -7790,7 +8346,7 @@
           <p:spPr>
             <a:xfrm>
               <a:off x="0" y="-38100"/>
-              <a:ext cx="2776873" cy="1525677"/>
+              <a:ext cx="2349726" cy="1598506"/>
             </a:xfrm>
             <a:prstGeom prst="rect">
               <a:avLst/>
@@ -7815,14 +8371,120 @@
       </p:grpSp>
       <p:sp>
         <p:nvSpPr>
-          <p:cNvPr id="10" name="TextBox 10"/>
+          <p:cNvPr id="10" name="Freeform 10"/>
+          <p:cNvSpPr/>
+          <p:nvPr/>
+        </p:nvSpPr>
+        <p:spPr>
+          <a:xfrm>
+            <a:off x="1851841" y="1674865"/>
+            <a:ext cx="6028958" cy="4268098"/>
+          </a:xfrm>
+          <a:custGeom>
+            <a:avLst/>
+            <a:gdLst/>
+            <a:ahLst/>
+            <a:cxnLst/>
+            <a:rect l="l" t="t" r="r" b="b"/>
+            <a:pathLst>
+              <a:path w="5669815" h="3734991">
+                <a:moveTo>
+                  <a:pt x="0" y="0"/>
+                </a:moveTo>
+                <a:lnTo>
+                  <a:pt x="5669815" y="0"/>
+                </a:lnTo>
+                <a:lnTo>
+                  <a:pt x="5669815" y="3734991"/>
+                </a:lnTo>
+                <a:lnTo>
+                  <a:pt x="0" y="3734991"/>
+                </a:lnTo>
+                <a:lnTo>
+                  <a:pt x="0" y="0"/>
+                </a:lnTo>
+                <a:close/>
+              </a:path>
+            </a:pathLst>
+          </a:custGeom>
+          <a:blipFill>
+            <a:blip r:embed="rId5"/>
+            <a:stretch>
+              <a:fillRect/>
+            </a:stretch>
+          </a:blipFill>
+        </p:spPr>
+        <p:txBody>
+          <a:bodyPr/>
+          <a:lstStyle/>
+          <a:p>
+            <a:endParaRPr lang="en-CA" dirty="0"/>
+          </a:p>
+        </p:txBody>
+      </p:sp>
+      <p:sp>
+        <p:nvSpPr>
+          <p:cNvPr id="11" name="Freeform 11"/>
+          <p:cNvSpPr/>
+          <p:nvPr/>
+        </p:nvSpPr>
+        <p:spPr>
+          <a:xfrm>
+            <a:off x="2435871" y="6313276"/>
+            <a:ext cx="7692079" cy="3734991"/>
+          </a:xfrm>
+          <a:custGeom>
+            <a:avLst/>
+            <a:gdLst/>
+            <a:ahLst/>
+            <a:cxnLst/>
+            <a:rect l="l" t="t" r="r" b="b"/>
+            <a:pathLst>
+              <a:path w="5974768" h="2987384">
+                <a:moveTo>
+                  <a:pt x="0" y="0"/>
+                </a:moveTo>
+                <a:lnTo>
+                  <a:pt x="5974768" y="0"/>
+                </a:lnTo>
+                <a:lnTo>
+                  <a:pt x="5974768" y="2987384"/>
+                </a:lnTo>
+                <a:lnTo>
+                  <a:pt x="0" y="2987384"/>
+                </a:lnTo>
+                <a:lnTo>
+                  <a:pt x="0" y="0"/>
+                </a:lnTo>
+                <a:close/>
+              </a:path>
+            </a:pathLst>
+          </a:custGeom>
+          <a:blipFill>
+            <a:blip r:embed="rId6"/>
+            <a:stretch>
+              <a:fillRect/>
+            </a:stretch>
+          </a:blipFill>
+        </p:spPr>
+        <p:txBody>
+          <a:bodyPr/>
+          <a:lstStyle/>
+          <a:p>
+            <a:endParaRPr lang="en-CA"/>
+          </a:p>
+        </p:txBody>
+      </p:sp>
+      <p:sp>
+        <p:nvSpPr>
+          <p:cNvPr id="12" name="TextBox 12"/>
           <p:cNvSpPr txBox="1"/>
           <p:nvPr/>
         </p:nvSpPr>
         <p:spPr>
           <a:xfrm>
-            <a:off x="4878428" y="1509864"/>
-            <a:ext cx="8531143" cy="1284605"/>
+            <a:off x="7616363" y="450697"/>
+            <a:ext cx="5071252" cy="1284605"/>
           </a:xfrm>
           <a:prstGeom prst="rect">
             <a:avLst/>
@@ -7840,7 +8502,7 @@
               </a:lnSpc>
             </a:pPr>
             <a:r>
-              <a:rPr lang="en-US" sz="8000" b="1">
+              <a:rPr lang="en-US" sz="8000" b="1" dirty="0">
                 <a:solidFill>
                   <a:srgbClr val="000000"/>
                 </a:solidFill>
@@ -7856,14 +8518,14 @@
       </p:sp>
       <p:sp>
         <p:nvSpPr>
-          <p:cNvPr id="11" name="TextBox 11"/>
+          <p:cNvPr id="13" name="TextBox 13"/>
           <p:cNvSpPr txBox="1"/>
           <p:nvPr/>
         </p:nvSpPr>
         <p:spPr>
           <a:xfrm>
-            <a:off x="3817359" y="3465545"/>
-            <a:ext cx="10066336" cy="5106543"/>
+            <a:off x="10986984" y="2964219"/>
+            <a:ext cx="8274607" cy="5573268"/>
           </a:xfrm>
           <a:prstGeom prst="rect">
             <a:avLst/>
@@ -7881,7 +8543,7 @@
               </a:lnSpc>
             </a:pPr>
             <a:r>
-              <a:rPr lang="en-US" sz="2400">
+              <a:rPr lang="en-US" sz="2400" dirty="0">
                 <a:solidFill>
                   <a:srgbClr val="000000"/>
                 </a:solidFill>
@@ -7902,7 +8564,7 @@
               <a:buChar char="•"/>
             </a:pPr>
             <a:r>
-              <a:rPr lang="en-US" sz="2400">
+              <a:rPr lang="en-US" sz="2400" dirty="0">
                 <a:solidFill>
                   <a:srgbClr val="000000"/>
                 </a:solidFill>
@@ -7923,7 +8585,7 @@
               <a:buChar char="•"/>
             </a:pPr>
             <a:r>
-              <a:rPr lang="en-US" sz="2400">
+              <a:rPr lang="en-US" sz="2400" dirty="0">
                 <a:solidFill>
                   <a:srgbClr val="000000"/>
                 </a:solidFill>
@@ -7944,7 +8606,7 @@
               <a:buChar char="•"/>
             </a:pPr>
             <a:r>
-              <a:rPr lang="en-US" sz="2400">
+              <a:rPr lang="en-US" sz="2400" dirty="0">
                 <a:solidFill>
                   <a:srgbClr val="000000"/>
                 </a:solidFill>
@@ -7965,7 +8627,7 @@
               <a:buChar char="•"/>
             </a:pPr>
             <a:r>
-              <a:rPr lang="en-US" sz="2400">
+              <a:rPr lang="en-US" sz="2400" dirty="0">
                 <a:solidFill>
                   <a:srgbClr val="000000"/>
                 </a:solidFill>
@@ -7986,7 +8648,7 @@
               <a:buChar char="•"/>
             </a:pPr>
             <a:r>
-              <a:rPr lang="en-US" sz="2400">
+              <a:rPr lang="en-US" sz="2400" dirty="0">
                 <a:solidFill>
                   <a:srgbClr val="000000"/>
                 </a:solidFill>
@@ -8007,7 +8669,7 @@
               <a:buChar char="•"/>
             </a:pPr>
             <a:r>
-              <a:rPr lang="en-US" sz="2400">
+              <a:rPr lang="en-US" sz="2400" dirty="0">
                 <a:solidFill>
                   <a:srgbClr val="000000"/>
                 </a:solidFill>
@@ -8028,7 +8690,7 @@
               <a:buChar char="•"/>
             </a:pPr>
             <a:r>
-              <a:rPr lang="en-US" sz="2400">
+              <a:rPr lang="en-US" sz="2400" dirty="0">
                 <a:solidFill>
                   <a:srgbClr val="000000"/>
                 </a:solidFill>
@@ -8049,7 +8711,7 @@
               <a:buChar char="•"/>
             </a:pPr>
             <a:r>
-              <a:rPr lang="en-US" sz="2400">
+              <a:rPr lang="en-US" sz="2400" dirty="0">
                 <a:solidFill>
                   <a:srgbClr val="000000"/>
                 </a:solidFill>
@@ -8068,7 +8730,7 @@
               </a:lnSpc>
             </a:pPr>
             <a:r>
-              <a:rPr lang="en-US" sz="2400">
+              <a:rPr lang="en-US" sz="2400" dirty="0">
                 <a:solidFill>
                   <a:srgbClr val="000000"/>
                 </a:solidFill>

</xml_diff>

<commit_message>
Applied given feedback to slides
Updated slides according to the feedback
</commit_message>
<xml_diff>
--- a/RSA Encryption.pptx
+++ b/RSA Encryption.pptx
@@ -7,40 +7,35 @@
   <p:sldIdLst>
     <p:sldId id="256" r:id="rId2"/>
     <p:sldId id="257" r:id="rId3"/>
-    <p:sldId id="258" r:id="rId4"/>
-    <p:sldId id="259" r:id="rId5"/>
-    <p:sldId id="260" r:id="rId6"/>
-    <p:sldId id="261" r:id="rId7"/>
-    <p:sldId id="262" r:id="rId8"/>
-    <p:sldId id="263" r:id="rId9"/>
+    <p:sldId id="264" r:id="rId4"/>
+    <p:sldId id="258" r:id="rId5"/>
+    <p:sldId id="259" r:id="rId6"/>
+    <p:sldId id="260" r:id="rId7"/>
+    <p:sldId id="261" r:id="rId8"/>
+    <p:sldId id="262" r:id="rId9"/>
+    <p:sldId id="263" r:id="rId10"/>
   </p:sldIdLst>
   <p:sldSz cx="18288000" cy="10287000"/>
   <p:notesSz cx="6858000" cy="9144000"/>
   <p:embeddedFontLst>
     <p:embeddedFont>
-      <p:font typeface="Aileron" panose="020B0604020202020204" charset="0"/>
-      <p:regular r:id="rId10"/>
-    </p:embeddedFont>
-    <p:embeddedFont>
-      <p:font typeface="Aileron Bold" panose="020B0604020202020204" charset="0"/>
+      <p:font typeface="Alegreya Sans SC" panose="020B0604020202020204" charset="0"/>
       <p:regular r:id="rId11"/>
     </p:embeddedFont>
     <p:embeddedFont>
-      <p:font typeface="Alegreya Sans SC" panose="020B0604020202020204" charset="0"/>
+      <p:font typeface="Alegreya Sans SC Bold" panose="020B0604020202020204" charset="0"/>
       <p:regular r:id="rId12"/>
     </p:embeddedFont>
     <p:embeddedFont>
-      <p:font typeface="Alegreya Sans SC Bold" panose="020B0604020202020204" charset="0"/>
+      <p:font typeface="Alegreya Sans SC Medium" panose="020B0604020202020204" charset="0"/>
       <p:regular r:id="rId13"/>
     </p:embeddedFont>
     <p:embeddedFont>
-      <p:font typeface="Alegreya Sans SC Medium" panose="020B0604020202020204" charset="0"/>
+      <p:font typeface="Candara" panose="020E0502030303020204" pitchFamily="34" charset="0"/>
       <p:regular r:id="rId14"/>
-    </p:embeddedFont>
-    <p:embeddedFont>
-      <p:font typeface="Open Sans" panose="020B0606030504020204" pitchFamily="34" charset="0"/>
-      <p:regular r:id="rId15"/>
-      <p:boldItalic r:id="rId16"/>
+      <p:bold r:id="rId15"/>
+      <p:italic r:id="rId16"/>
+      <p:boldItalic r:id="rId17"/>
     </p:embeddedFont>
   </p:embeddedFontLst>
   <p:defaultTextStyle>
@@ -337,7 +332,7 @@
             <a:fld id="{1D8BD707-D9CF-40AE-B4C6-C98DA3205C09}" type="datetimeFigureOut">
               <a:rPr lang="en-US" smtClean="0"/>
               <a:pPr/>
-              <a:t>10/13/2026</a:t>
+              <a:t>10/14/2026</a:t>
             </a:fld>
             <a:endParaRPr lang="en-US"/>
           </a:p>
@@ -502,7 +497,7 @@
             <a:fld id="{1D8BD707-D9CF-40AE-B4C6-C98DA3205C09}" type="datetimeFigureOut">
               <a:rPr lang="en-US" smtClean="0"/>
               <a:pPr/>
-              <a:t>10/13/2026</a:t>
+              <a:t>10/14/2026</a:t>
             </a:fld>
             <a:endParaRPr lang="en-US"/>
           </a:p>
@@ -677,7 +672,7 @@
             <a:fld id="{1D8BD707-D9CF-40AE-B4C6-C98DA3205C09}" type="datetimeFigureOut">
               <a:rPr lang="en-US" smtClean="0"/>
               <a:pPr/>
-              <a:t>10/13/2026</a:t>
+              <a:t>10/14/2026</a:t>
             </a:fld>
             <a:endParaRPr lang="en-US"/>
           </a:p>
@@ -842,7 +837,7 @@
             <a:fld id="{1D8BD707-D9CF-40AE-B4C6-C98DA3205C09}" type="datetimeFigureOut">
               <a:rPr lang="en-US" smtClean="0"/>
               <a:pPr/>
-              <a:t>10/13/2026</a:t>
+              <a:t>10/14/2026</a:t>
             </a:fld>
             <a:endParaRPr lang="en-US"/>
           </a:p>
@@ -1084,7 +1079,7 @@
             <a:fld id="{1D8BD707-D9CF-40AE-B4C6-C98DA3205C09}" type="datetimeFigureOut">
               <a:rPr lang="en-US" smtClean="0"/>
               <a:pPr/>
-              <a:t>10/13/2026</a:t>
+              <a:t>10/14/2026</a:t>
             </a:fld>
             <a:endParaRPr lang="en-US"/>
           </a:p>
@@ -1366,7 +1361,7 @@
             <a:fld id="{1D8BD707-D9CF-40AE-B4C6-C98DA3205C09}" type="datetimeFigureOut">
               <a:rPr lang="en-US" smtClean="0"/>
               <a:pPr/>
-              <a:t>10/13/2026</a:t>
+              <a:t>10/14/2026</a:t>
             </a:fld>
             <a:endParaRPr lang="en-US"/>
           </a:p>
@@ -1782,7 +1777,7 @@
             <a:fld id="{1D8BD707-D9CF-40AE-B4C6-C98DA3205C09}" type="datetimeFigureOut">
               <a:rPr lang="en-US" smtClean="0"/>
               <a:pPr/>
-              <a:t>10/13/2026</a:t>
+              <a:t>10/14/2026</a:t>
             </a:fld>
             <a:endParaRPr lang="en-US"/>
           </a:p>
@@ -1896,7 +1891,7 @@
             <a:fld id="{1D8BD707-D9CF-40AE-B4C6-C98DA3205C09}" type="datetimeFigureOut">
               <a:rPr lang="en-US" smtClean="0"/>
               <a:pPr/>
-              <a:t>10/13/2026</a:t>
+              <a:t>10/14/2026</a:t>
             </a:fld>
             <a:endParaRPr lang="en-US"/>
           </a:p>
@@ -1988,7 +1983,7 @@
             <a:fld id="{1D8BD707-D9CF-40AE-B4C6-C98DA3205C09}" type="datetimeFigureOut">
               <a:rPr lang="en-US" smtClean="0"/>
               <a:pPr/>
-              <a:t>10/13/2026</a:t>
+              <a:t>10/14/2026</a:t>
             </a:fld>
             <a:endParaRPr lang="en-US"/>
           </a:p>
@@ -2260,7 +2255,7 @@
             <a:fld id="{1D8BD707-D9CF-40AE-B4C6-C98DA3205C09}" type="datetimeFigureOut">
               <a:rPr lang="en-US" smtClean="0"/>
               <a:pPr/>
-              <a:t>10/13/2026</a:t>
+              <a:t>10/14/2026</a:t>
             </a:fld>
             <a:endParaRPr lang="en-US"/>
           </a:p>
@@ -2509,7 +2504,7 @@
             <a:fld id="{1D8BD707-D9CF-40AE-B4C6-C98DA3205C09}" type="datetimeFigureOut">
               <a:rPr lang="en-US" smtClean="0"/>
               <a:pPr/>
-              <a:t>10/13/2026</a:t>
+              <a:t>10/14/2026</a:t>
             </a:fld>
             <a:endParaRPr lang="en-US"/>
           </a:p>
@@ -2717,7 +2712,7 @@
             <a:fld id="{1D8BD707-D9CF-40AE-B4C6-C98DA3205C09}" type="datetimeFigureOut">
               <a:rPr lang="en-US" smtClean="0"/>
               <a:pPr/>
-              <a:t>10/13/2026</a:t>
+              <a:t>10/14/2026</a:t>
             </a:fld>
             <a:endParaRPr lang="en-US"/>
           </a:p>
@@ -3143,7 +3138,7 @@
           <a:bodyPr/>
           <a:lstStyle/>
           <a:p>
-            <a:endParaRPr lang="en-CA"/>
+            <a:endParaRPr lang="en-CA" dirty="0"/>
           </a:p>
         </p:txBody>
       </p:sp>
@@ -3453,15 +3448,214 @@
         </p:nvSpPr>
         <p:spPr>
           <a:xfrm>
-            <a:off x="2332764" y="6928312"/>
-            <a:ext cx="5410855" cy="3129904"/>
+            <a:off x="2398219" y="7443636"/>
+            <a:ext cx="13440636" cy="2636106"/>
           </a:xfrm>
           <a:prstGeom prst="rect">
             <a:avLst/>
           </a:prstGeom>
         </p:spPr>
         <p:txBody>
-          <a:bodyPr lIns="0" tIns="0" rIns="0" bIns="0" rtlCol="0" anchor="t">
+          <a:bodyPr wrap="square" lIns="0" tIns="0" rIns="0" bIns="0" rtlCol="0" anchor="t">
+            <a:spAutoFit/>
+          </a:bodyPr>
+          <a:lstStyle/>
+          <a:p>
+            <a:pPr>
+              <a:lnSpc>
+                <a:spcPts val="4992"/>
+              </a:lnSpc>
+              <a:spcBef>
+                <a:spcPct val="0"/>
+              </a:spcBef>
+            </a:pPr>
+            <a:r>
+              <a:rPr lang="en-US" sz="3240" dirty="0">
+                <a:solidFill>
+                  <a:srgbClr val="000000"/>
+                </a:solidFill>
+                <a:latin typeface="Candara" panose="020E0502030303020204" pitchFamily="34" charset="0"/>
+                <a:ea typeface="Aileron Bold"/>
+                <a:cs typeface="Aileron Bold"/>
+                <a:sym typeface="Aileron Bold"/>
+              </a:rPr>
+              <a:t>Project by: </a:t>
+            </a:r>
+          </a:p>
+          <a:p>
+            <a:pPr>
+              <a:lnSpc>
+                <a:spcPct val="100000"/>
+              </a:lnSpc>
+              <a:spcBef>
+                <a:spcPct val="0"/>
+              </a:spcBef>
+            </a:pPr>
+            <a:r>
+              <a:rPr lang="en-US" sz="3240" dirty="0">
+                <a:solidFill>
+                  <a:srgbClr val="000000"/>
+                </a:solidFill>
+                <a:latin typeface="Candara" panose="020E0502030303020204" pitchFamily="34" charset="0"/>
+                <a:ea typeface="Aileron Bold"/>
+                <a:cs typeface="Aileron Bold"/>
+                <a:sym typeface="Aileron Bold"/>
+              </a:rPr>
+              <a:t>Adrian Stanciu - </a:t>
+            </a:r>
+            <a:r>
+              <a:rPr lang="en-CA" sz="3240" dirty="0">
+                <a:latin typeface="Candara" panose="020E0502030303020204" pitchFamily="34" charset="0"/>
+              </a:rPr>
+              <a:t>Seneca Student ID: 111272266</a:t>
+            </a:r>
+            <a:endParaRPr lang="en-US" sz="3240" dirty="0">
+              <a:solidFill>
+                <a:srgbClr val="000000"/>
+              </a:solidFill>
+              <a:latin typeface="Candara" panose="020E0502030303020204" pitchFamily="34" charset="0"/>
+              <a:ea typeface="Aileron Bold"/>
+              <a:cs typeface="Aileron Bold"/>
+              <a:sym typeface="Aileron Bold"/>
+            </a:endParaRPr>
+          </a:p>
+          <a:p>
+            <a:pPr>
+              <a:lnSpc>
+                <a:spcPct val="100000"/>
+              </a:lnSpc>
+              <a:spcBef>
+                <a:spcPct val="0"/>
+              </a:spcBef>
+            </a:pPr>
+            <a:r>
+              <a:rPr lang="en-US" sz="3240" dirty="0">
+                <a:solidFill>
+                  <a:srgbClr val="000000"/>
+                </a:solidFill>
+                <a:latin typeface="Candara" panose="020E0502030303020204" pitchFamily="34" charset="0"/>
+                <a:ea typeface="Aileron Bold"/>
+                <a:cs typeface="Aileron Bold"/>
+                <a:sym typeface="Aileron Bold"/>
+              </a:rPr>
+              <a:t>Muffin Aybar - </a:t>
+            </a:r>
+            <a:r>
+              <a:rPr lang="en-CA" sz="3240" dirty="0">
+                <a:latin typeface="Candara" panose="020E0502030303020204" pitchFamily="34" charset="0"/>
+              </a:rPr>
+              <a:t>Seneca Student ID: 107362253</a:t>
+            </a:r>
+            <a:endParaRPr lang="en-US" sz="3240" dirty="0">
+              <a:solidFill>
+                <a:srgbClr val="000000"/>
+              </a:solidFill>
+              <a:latin typeface="Candara" panose="020E0502030303020204" pitchFamily="34" charset="0"/>
+              <a:ea typeface="Aileron Bold"/>
+              <a:cs typeface="Aileron Bold"/>
+              <a:sym typeface="Aileron Bold"/>
+            </a:endParaRPr>
+          </a:p>
+          <a:p>
+            <a:pPr>
+              <a:lnSpc>
+                <a:spcPct val="100000"/>
+              </a:lnSpc>
+              <a:spcBef>
+                <a:spcPct val="0"/>
+              </a:spcBef>
+            </a:pPr>
+            <a:r>
+              <a:rPr lang="en-US" sz="3240" dirty="0">
+                <a:solidFill>
+                  <a:srgbClr val="000000"/>
+                </a:solidFill>
+                <a:latin typeface="Candara" panose="020E0502030303020204" pitchFamily="34" charset="0"/>
+                <a:ea typeface="Aileron Bold"/>
+                <a:cs typeface="Aileron Bold"/>
+                <a:sym typeface="Aileron Bold"/>
+              </a:rPr>
+              <a:t>Summer Chang - </a:t>
+            </a:r>
+            <a:r>
+              <a:rPr lang="en-CA" sz="3240" dirty="0">
+                <a:latin typeface="Candara" panose="020E0502030303020204" pitchFamily="34" charset="0"/>
+              </a:rPr>
+              <a:t>Seneca Student ID: 148482243</a:t>
+            </a:r>
+            <a:endParaRPr lang="en-US" sz="3240" dirty="0">
+              <a:solidFill>
+                <a:srgbClr val="000000"/>
+              </a:solidFill>
+              <a:latin typeface="Candara" panose="020E0502030303020204" pitchFamily="34" charset="0"/>
+              <a:ea typeface="Aileron Bold"/>
+              <a:cs typeface="Aileron Bold"/>
+              <a:sym typeface="Aileron Bold"/>
+            </a:endParaRPr>
+          </a:p>
+          <a:p>
+            <a:pPr>
+              <a:lnSpc>
+                <a:spcPct val="100000"/>
+              </a:lnSpc>
+              <a:spcBef>
+                <a:spcPct val="0"/>
+              </a:spcBef>
+            </a:pPr>
+            <a:r>
+              <a:rPr lang="en-US" sz="3240" dirty="0">
+                <a:solidFill>
+                  <a:srgbClr val="000000"/>
+                </a:solidFill>
+                <a:latin typeface="Candara" panose="020E0502030303020204" pitchFamily="34" charset="0"/>
+                <a:ea typeface="Aileron Bold"/>
+                <a:cs typeface="Aileron Bold"/>
+                <a:sym typeface="Aileron Bold"/>
+              </a:rPr>
+              <a:t>Ignacio Morales Hermosilla - </a:t>
+            </a:r>
+            <a:r>
+              <a:rPr lang="en-CA" sz="3240" dirty="0">
+                <a:latin typeface="Candara" panose="020E0502030303020204" pitchFamily="34" charset="0"/>
+              </a:rPr>
+              <a:t>Seneca Student ID: 122079262</a:t>
+            </a:r>
+            <a:endParaRPr lang="en-US" sz="3240" dirty="0">
+              <a:solidFill>
+                <a:srgbClr val="000000"/>
+              </a:solidFill>
+              <a:latin typeface="Candara" panose="020E0502030303020204" pitchFamily="34" charset="0"/>
+              <a:ea typeface="Aileron Bold"/>
+              <a:cs typeface="Aileron Bold"/>
+              <a:sym typeface="Aileron Bold"/>
+            </a:endParaRPr>
+          </a:p>
+        </p:txBody>
+      </p:sp>
+      <p:sp>
+        <p:nvSpPr>
+          <p:cNvPr id="10" name="TextBox 9">
+            <a:extLst>
+              <a:ext uri="{FF2B5EF4-FFF2-40B4-BE49-F238E27FC236}">
+                <a16:creationId xmlns:a16="http://schemas.microsoft.com/office/drawing/2014/main" id="{AC0B0D66-EEEB-3EF4-58A4-DBD95C30DB6C}"/>
+              </a:ext>
+            </a:extLst>
+          </p:cNvPr>
+          <p:cNvSpPr txBox="1"/>
+          <p:nvPr/>
+        </p:nvSpPr>
+        <p:spPr>
+          <a:xfrm>
+            <a:off x="1219200" y="6146916"/>
+            <a:ext cx="4140184" cy="682944"/>
+          </a:xfrm>
+          <a:prstGeom prst="rect">
+            <a:avLst/>
+          </a:prstGeom>
+          <a:noFill/>
+        </p:spPr>
+        <p:txBody>
+          <a:bodyPr wrap="square">
             <a:spAutoFit/>
           </a:bodyPr>
           <a:lstStyle/>
@@ -3475,104 +3669,16 @@
               </a:spcBef>
             </a:pPr>
             <a:r>
-              <a:rPr lang="en-US" sz="3241" b="1" dirty="0">
+              <a:rPr lang="en-US" sz="3241" dirty="0">
                 <a:solidFill>
                   <a:srgbClr val="000000"/>
                 </a:solidFill>
-                <a:latin typeface="Aileron Bold"/>
+                <a:latin typeface="Candara" panose="020E0502030303020204" pitchFamily="34" charset="0"/>
                 <a:ea typeface="Aileron Bold"/>
                 <a:cs typeface="Aileron Bold"/>
                 <a:sym typeface="Aileron Bold"/>
               </a:rPr>
-              <a:t>Project by: </a:t>
-            </a:r>
-          </a:p>
-          <a:p>
-            <a:pPr algn="ctr">
-              <a:lnSpc>
-                <a:spcPts val="4992"/>
-              </a:lnSpc>
-              <a:spcBef>
-                <a:spcPct val="0"/>
-              </a:spcBef>
-            </a:pPr>
-            <a:r>
-              <a:rPr lang="en-US" sz="3241" b="1" dirty="0">
-                <a:solidFill>
-                  <a:srgbClr val="000000"/>
-                </a:solidFill>
-                <a:latin typeface="Aileron Bold"/>
-                <a:ea typeface="Aileron Bold"/>
-                <a:cs typeface="Aileron Bold"/>
-                <a:sym typeface="Aileron Bold"/>
-              </a:rPr>
-              <a:t>Adrian Stanciu</a:t>
-            </a:r>
-          </a:p>
-          <a:p>
-            <a:pPr algn="ctr">
-              <a:lnSpc>
-                <a:spcPts val="4992"/>
-              </a:lnSpc>
-              <a:spcBef>
-                <a:spcPct val="0"/>
-              </a:spcBef>
-            </a:pPr>
-            <a:r>
-              <a:rPr lang="en-US" sz="3241" b="1" dirty="0">
-                <a:solidFill>
-                  <a:srgbClr val="000000"/>
-                </a:solidFill>
-                <a:latin typeface="Aileron Bold"/>
-                <a:ea typeface="Aileron Bold"/>
-                <a:cs typeface="Aileron Bold"/>
-                <a:sym typeface="Aileron Bold"/>
-              </a:rPr>
-              <a:t>Muffin Aybar</a:t>
-            </a:r>
-          </a:p>
-          <a:p>
-            <a:pPr algn="ctr">
-              <a:lnSpc>
-                <a:spcPts val="4992"/>
-              </a:lnSpc>
-              <a:spcBef>
-                <a:spcPct val="0"/>
-              </a:spcBef>
-            </a:pPr>
-            <a:r>
-              <a:rPr lang="en-US" sz="3241" b="1" dirty="0">
-                <a:solidFill>
-                  <a:srgbClr val="000000"/>
-                </a:solidFill>
-                <a:latin typeface="Aileron Bold"/>
-                <a:ea typeface="Aileron Bold"/>
-                <a:cs typeface="Aileron Bold"/>
-                <a:sym typeface="Aileron Bold"/>
-              </a:rPr>
-              <a:t>Summer Chang</a:t>
-            </a:r>
-          </a:p>
-          <a:p>
-            <a:pPr algn="ctr">
-              <a:lnSpc>
-                <a:spcPts val="4992"/>
-              </a:lnSpc>
-              <a:spcBef>
-                <a:spcPct val="0"/>
-              </a:spcBef>
-            </a:pPr>
-            <a:r>
-              <a:rPr lang="en-US" sz="3241" b="1" dirty="0">
-                <a:solidFill>
-                  <a:srgbClr val="000000"/>
-                </a:solidFill>
-                <a:latin typeface="Aileron Bold"/>
-                <a:ea typeface="Aileron Bold"/>
-                <a:cs typeface="Aileron Bold"/>
-                <a:sym typeface="Aileron Bold"/>
-              </a:rPr>
-              <a:t>Ignacio Morales Hermosilla</a:t>
+              <a:t>Course: CEP146 NBB</a:t>
             </a:r>
           </a:p>
         </p:txBody>
@@ -4032,59 +4138,6 @@
       </p:grpSp>
       <p:sp>
         <p:nvSpPr>
-          <p:cNvPr id="10" name="Freeform 10"/>
-          <p:cNvSpPr/>
-          <p:nvPr/>
-        </p:nvSpPr>
-        <p:spPr>
-          <a:xfrm>
-            <a:off x="10109379" y="3907431"/>
-            <a:ext cx="10780569" cy="6214114"/>
-          </a:xfrm>
-          <a:custGeom>
-            <a:avLst/>
-            <a:gdLst/>
-            <a:ahLst/>
-            <a:cxnLst/>
-            <a:rect l="l" t="t" r="r" b="b"/>
-            <a:pathLst>
-              <a:path w="8633582" h="4532631">
-                <a:moveTo>
-                  <a:pt x="0" y="0"/>
-                </a:moveTo>
-                <a:lnTo>
-                  <a:pt x="8633583" y="0"/>
-                </a:lnTo>
-                <a:lnTo>
-                  <a:pt x="8633583" y="4532630"/>
-                </a:lnTo>
-                <a:lnTo>
-                  <a:pt x="0" y="4532630"/>
-                </a:lnTo>
-                <a:lnTo>
-                  <a:pt x="0" y="0"/>
-                </a:lnTo>
-                <a:close/>
-              </a:path>
-            </a:pathLst>
-          </a:custGeom>
-          <a:blipFill>
-            <a:blip r:embed="rId5"/>
-            <a:stretch>
-              <a:fillRect/>
-            </a:stretch>
-          </a:blipFill>
-        </p:spPr>
-        <p:txBody>
-          <a:bodyPr/>
-          <a:lstStyle/>
-          <a:p>
-            <a:endParaRPr lang="en-CA"/>
-          </a:p>
-        </p:txBody>
-      </p:sp>
-      <p:sp>
-        <p:nvSpPr>
           <p:cNvPr id="11" name="TextBox 11"/>
           <p:cNvSpPr txBox="1"/>
           <p:nvPr/>
@@ -4133,14 +4186,14 @@
         <p:spPr>
           <a:xfrm>
             <a:off x="578153" y="4072886"/>
-            <a:ext cx="9076264" cy="5573267"/>
+            <a:ext cx="9076264" cy="5656485"/>
           </a:xfrm>
           <a:prstGeom prst="rect">
             <a:avLst/>
           </a:prstGeom>
         </p:spPr>
         <p:txBody>
-          <a:bodyPr lIns="0" tIns="0" rIns="0" bIns="0" rtlCol="0" anchor="t">
+          <a:bodyPr wrap="square" lIns="0" tIns="0" rIns="0" bIns="0" rtlCol="0" anchor="t">
             <a:spAutoFit/>
           </a:bodyPr>
           <a:lstStyle/>
@@ -4151,16 +4204,16 @@
               </a:lnSpc>
             </a:pPr>
             <a:r>
-              <a:rPr lang="en-US" sz="2400">
+              <a:rPr lang="en-US" sz="2400" dirty="0">
                 <a:solidFill>
                   <a:srgbClr val="000000"/>
                 </a:solidFill>
-                <a:latin typeface="Aileron"/>
+                <a:latin typeface="Candara" panose="020E0502030303020204" pitchFamily="34" charset="0"/>
                 <a:ea typeface="Aileron"/>
                 <a:cs typeface="Aileron"/>
                 <a:sym typeface="Aileron"/>
               </a:rPr>
-              <a:t>RSA Encryption is an asymmetric encryption algorithm that generates a key pair to encrypt and decrypt data.</a:t>
+              <a:t>RSA Encryption is an asymmetric encryption algorithm.</a:t>
             </a:r>
           </a:p>
           <a:p>
@@ -4170,11 +4223,30 @@
               </a:lnSpc>
             </a:pPr>
             <a:r>
-              <a:rPr lang="en-US" sz="2400">
+              <a:rPr lang="en-US" sz="2400" dirty="0">
                 <a:solidFill>
                   <a:srgbClr val="000000"/>
                 </a:solidFill>
-                <a:latin typeface="Aileron"/>
+                <a:latin typeface="Candara" panose="020E0502030303020204" pitchFamily="34" charset="0"/>
+                <a:ea typeface="Aileron"/>
+                <a:cs typeface="Aileron"/>
+                <a:sym typeface="Aileron"/>
+              </a:rPr>
+              <a:t>It generates a key pair to encrypt and decrypt data.</a:t>
+            </a:r>
+          </a:p>
+          <a:p>
+            <a:pPr algn="l">
+              <a:lnSpc>
+                <a:spcPts val="3696"/>
+              </a:lnSpc>
+            </a:pPr>
+            <a:r>
+              <a:rPr lang="en-US" sz="2400" dirty="0">
+                <a:solidFill>
+                  <a:srgbClr val="000000"/>
+                </a:solidFill>
+                <a:latin typeface="Candara" panose="020E0502030303020204" pitchFamily="34" charset="0"/>
                 <a:ea typeface="Aileron"/>
                 <a:cs typeface="Aileron"/>
                 <a:sym typeface="Aileron"/>
@@ -4188,11 +4260,11 @@
                 <a:spcPts val="3696"/>
               </a:lnSpc>
             </a:pPr>
-            <a:endParaRPr lang="en-US" sz="2400">
+            <a:endParaRPr lang="en-US" sz="2400" dirty="0">
               <a:solidFill>
                 <a:srgbClr val="000000"/>
               </a:solidFill>
-              <a:latin typeface="Aileron"/>
+              <a:latin typeface="Candara" panose="020E0502030303020204" pitchFamily="34" charset="0"/>
               <a:ea typeface="Aileron"/>
               <a:cs typeface="Aileron"/>
               <a:sym typeface="Aileron"/>
@@ -4205,11 +4277,11 @@
               </a:lnSpc>
             </a:pPr>
             <a:r>
-              <a:rPr lang="en-US" sz="2400">
+              <a:rPr lang="en-US" sz="2400" dirty="0">
                 <a:solidFill>
                   <a:srgbClr val="000000"/>
                 </a:solidFill>
-                <a:latin typeface="Aileron"/>
+                <a:latin typeface="Candara" panose="020E0502030303020204" pitchFamily="34" charset="0"/>
                 <a:ea typeface="Aileron"/>
                 <a:cs typeface="Aileron"/>
                 <a:sym typeface="Aileron"/>
@@ -4224,16 +4296,16 @@
               </a:lnSpc>
             </a:pPr>
             <a:r>
-              <a:rPr lang="en-US" sz="2400">
+              <a:rPr lang="en-US" sz="2400" dirty="0">
                 <a:solidFill>
                   <a:srgbClr val="000000"/>
                 </a:solidFill>
-                <a:latin typeface="Aileron"/>
+                <a:latin typeface="Candara" panose="020E0502030303020204" pitchFamily="34" charset="0"/>
                 <a:ea typeface="Aileron"/>
                 <a:cs typeface="Aileron"/>
                 <a:sym typeface="Aileron"/>
               </a:rPr>
-              <a:t>1.Make a key pair</a:t>
+              <a:t>1. Make a key pair</a:t>
             </a:r>
           </a:p>
           <a:p>
@@ -4243,16 +4315,16 @@
               </a:lnSpc>
             </a:pPr>
             <a:r>
-              <a:rPr lang="en-US" sz="2400">
+              <a:rPr lang="en-US" sz="2400" dirty="0">
                 <a:solidFill>
                   <a:srgbClr val="000000"/>
                 </a:solidFill>
-                <a:latin typeface="Aileron"/>
+                <a:latin typeface="Candara" panose="020E0502030303020204" pitchFamily="34" charset="0"/>
                 <a:ea typeface="Aileron"/>
                 <a:cs typeface="Aileron"/>
                 <a:sym typeface="Aileron"/>
               </a:rPr>
-              <a:t>2.Send our recipient the public key while keeping the private key</a:t>
+              <a:t>2. Send our recipient the public key while keeping the private key</a:t>
             </a:r>
           </a:p>
           <a:p>
@@ -4262,16 +4334,16 @@
               </a:lnSpc>
             </a:pPr>
             <a:r>
-              <a:rPr lang="en-US" sz="2400">
+              <a:rPr lang="en-US" sz="2400" dirty="0">
                 <a:solidFill>
                   <a:srgbClr val="000000"/>
                 </a:solidFill>
-                <a:latin typeface="Aileron"/>
+                <a:latin typeface="Candara" panose="020E0502030303020204" pitchFamily="34" charset="0"/>
                 <a:ea typeface="Aileron"/>
                 <a:cs typeface="Aileron"/>
                 <a:sym typeface="Aileron"/>
               </a:rPr>
-              <a:t>3.Recipient uses the public key to encrypt and send their own public kye over</a:t>
+              <a:t>3. Recipient uses the public key to encrypt and send their own public key over</a:t>
             </a:r>
           </a:p>
           <a:p>
@@ -4281,16 +4353,16 @@
               </a:lnSpc>
             </a:pPr>
             <a:r>
-              <a:rPr lang="en-US" sz="2400">
+              <a:rPr lang="en-US" sz="2400" dirty="0">
                 <a:solidFill>
                   <a:srgbClr val="000000"/>
                 </a:solidFill>
-                <a:latin typeface="Aileron"/>
+                <a:latin typeface="Candara" panose="020E0502030303020204" pitchFamily="34" charset="0"/>
                 <a:ea typeface="Aileron"/>
                 <a:cs typeface="Aileron"/>
                 <a:sym typeface="Aileron"/>
               </a:rPr>
-              <a:t>4.Use our own private key to decrypt their public key</a:t>
+              <a:t>4. Use our own private key to decrypt their public key</a:t>
             </a:r>
           </a:p>
           <a:p>
@@ -4300,11 +4372,11 @@
               </a:lnSpc>
             </a:pPr>
             <a:r>
-              <a:rPr lang="en-US" sz="2400">
+              <a:rPr lang="en-US" sz="2400" dirty="0">
                 <a:solidFill>
                   <a:srgbClr val="000000"/>
                 </a:solidFill>
-                <a:latin typeface="Aileron"/>
+                <a:latin typeface="Candara" panose="020E0502030303020204" pitchFamily="34" charset="0"/>
                 <a:ea typeface="Aileron"/>
                 <a:cs typeface="Aileron"/>
                 <a:sym typeface="Aileron"/>
@@ -4358,6 +4430,43 @@
           </a:p>
         </p:txBody>
       </p:sp>
+      <p:pic>
+        <p:nvPicPr>
+          <p:cNvPr id="15" name="Picture 14" descr="File:Symmetric encryption.png - Wikimedia Commons">
+            <a:extLst>
+              <a:ext uri="{FF2B5EF4-FFF2-40B4-BE49-F238E27FC236}">
+                <a16:creationId xmlns:a16="http://schemas.microsoft.com/office/drawing/2014/main" id="{2EC436D7-0628-458B-1904-687A8260830D}"/>
+              </a:ext>
+            </a:extLst>
+          </p:cNvPr>
+          <p:cNvPicPr>
+            <a:picLocks noChangeAspect="1"/>
+          </p:cNvPicPr>
+          <p:nvPr/>
+        </p:nvPicPr>
+        <p:blipFill>
+          <a:blip r:embed="rId5"/>
+          <a:stretch>
+            <a:fillRect/>
+          </a:stretch>
+        </p:blipFill>
+        <p:spPr>
+          <a:xfrm>
+            <a:off x="10123745" y="3554583"/>
+            <a:ext cx="9885691" cy="5538695"/>
+          </a:xfrm>
+          <a:prstGeom prst="rect">
+            <a:avLst/>
+          </a:prstGeom>
+          <a:effectLst>
+            <a:outerShdw blurRad="254000" dist="762000" dir="2400000" algn="ctr" rotWithShape="0">
+              <a:srgbClr val="000000">
+                <a:alpha val="40000"/>
+              </a:srgbClr>
+            </a:outerShdw>
+          </a:effectLst>
+        </p:spPr>
+      </p:pic>
     </p:spTree>
   </p:cSld>
   <p:clrMapOvr>
@@ -4367,6 +4476,503 @@
 </file>
 
 <file path=ppt/slides/slide3.xml><?xml version="1.0" encoding="utf-8"?>
+<p:sld xmlns:a="http://schemas.openxmlformats.org/drawingml/2006/main" xmlns:r="http://schemas.openxmlformats.org/officeDocument/2006/relationships" xmlns:p="http://schemas.openxmlformats.org/presentationml/2006/main">
+  <p:cSld>
+    <p:spTree>
+      <p:nvGrpSpPr>
+        <p:cNvPr id="1" name="">
+          <a:extLst>
+            <a:ext uri="{FF2B5EF4-FFF2-40B4-BE49-F238E27FC236}">
+              <a16:creationId xmlns:a16="http://schemas.microsoft.com/office/drawing/2014/main" id="{984EF9FA-5DEC-3D84-6AF4-6378E7F05677}"/>
+            </a:ext>
+          </a:extLst>
+        </p:cNvPr>
+        <p:cNvGrpSpPr/>
+        <p:nvPr/>
+      </p:nvGrpSpPr>
+      <p:grpSpPr>
+        <a:xfrm>
+          <a:off x="0" y="0"/>
+          <a:ext cx="0" cy="0"/>
+          <a:chOff x="0" y="0"/>
+          <a:chExt cx="0" cy="0"/>
+        </a:xfrm>
+      </p:grpSpPr>
+      <p:sp>
+        <p:nvSpPr>
+          <p:cNvPr id="2" name="Freeform 2">
+            <a:extLst>
+              <a:ext uri="{FF2B5EF4-FFF2-40B4-BE49-F238E27FC236}">
+                <a16:creationId xmlns:a16="http://schemas.microsoft.com/office/drawing/2014/main" id="{17C607F6-931B-4F83-1AAD-4D9E900AF928}"/>
+              </a:ext>
+            </a:extLst>
+          </p:cNvPr>
+          <p:cNvSpPr/>
+          <p:nvPr/>
+        </p:nvSpPr>
+        <p:spPr>
+          <a:xfrm rot="-5400000">
+            <a:off x="4557186" y="-5988665"/>
+            <a:ext cx="11718479" cy="20832852"/>
+          </a:xfrm>
+          <a:custGeom>
+            <a:avLst/>
+            <a:gdLst/>
+            <a:ahLst/>
+            <a:cxnLst/>
+            <a:rect l="l" t="t" r="r" b="b"/>
+            <a:pathLst>
+              <a:path w="11718479" h="20832852">
+                <a:moveTo>
+                  <a:pt x="0" y="0"/>
+                </a:moveTo>
+                <a:lnTo>
+                  <a:pt x="11718479" y="0"/>
+                </a:lnTo>
+                <a:lnTo>
+                  <a:pt x="11718479" y="20832851"/>
+                </a:lnTo>
+                <a:lnTo>
+                  <a:pt x="0" y="20832851"/>
+                </a:lnTo>
+                <a:lnTo>
+                  <a:pt x="0" y="0"/>
+                </a:lnTo>
+                <a:close/>
+              </a:path>
+            </a:pathLst>
+          </a:custGeom>
+          <a:blipFill>
+            <a:blip>
+              <a:extLst>
+                <a:ext uri="{96DAC541-7B7A-43D3-8B79-37D633B846F1}">
+                  <asvg:svgBlip xmlns:asvg="http://schemas.microsoft.com/office/drawing/2016/SVG/main" r:embed="rId2"/>
+                </a:ext>
+              </a:extLst>
+            </a:blip>
+            <a:stretch>
+              <a:fillRect/>
+            </a:stretch>
+          </a:blipFill>
+        </p:spPr>
+        <p:txBody>
+          <a:bodyPr/>
+          <a:lstStyle/>
+          <a:p>
+            <a:endParaRPr lang="en-CA" dirty="0"/>
+          </a:p>
+        </p:txBody>
+      </p:sp>
+      <p:sp>
+        <p:nvSpPr>
+          <p:cNvPr id="3" name="Freeform 3">
+            <a:extLst>
+              <a:ext uri="{FF2B5EF4-FFF2-40B4-BE49-F238E27FC236}">
+                <a16:creationId xmlns:a16="http://schemas.microsoft.com/office/drawing/2014/main" id="{0BB91FF3-1A9F-3424-8AFD-6525743E80AA}"/>
+              </a:ext>
+            </a:extLst>
+          </p:cNvPr>
+          <p:cNvSpPr/>
+          <p:nvPr/>
+        </p:nvSpPr>
+        <p:spPr>
+          <a:xfrm flipV="1">
+            <a:off x="519025" y="396902"/>
+            <a:ext cx="2359274" cy="2359274"/>
+          </a:xfrm>
+          <a:custGeom>
+            <a:avLst/>
+            <a:gdLst/>
+            <a:ahLst/>
+            <a:cxnLst/>
+            <a:rect l="l" t="t" r="r" b="b"/>
+            <a:pathLst>
+              <a:path w="2359274" h="2359274">
+                <a:moveTo>
+                  <a:pt x="0" y="2359274"/>
+                </a:moveTo>
+                <a:lnTo>
+                  <a:pt x="2359274" y="2359274"/>
+                </a:lnTo>
+                <a:lnTo>
+                  <a:pt x="2359274" y="0"/>
+                </a:lnTo>
+                <a:lnTo>
+                  <a:pt x="0" y="0"/>
+                </a:lnTo>
+                <a:lnTo>
+                  <a:pt x="0" y="2359274"/>
+                </a:lnTo>
+                <a:close/>
+              </a:path>
+            </a:pathLst>
+          </a:custGeom>
+          <a:blipFill>
+            <a:blip>
+              <a:extLst>
+                <a:ext uri="{96DAC541-7B7A-43D3-8B79-37D633B846F1}">
+                  <asvg:svgBlip xmlns:asvg="http://schemas.microsoft.com/office/drawing/2016/SVG/main" r:embed="rId3"/>
+                </a:ext>
+              </a:extLst>
+            </a:blip>
+            <a:stretch>
+              <a:fillRect/>
+            </a:stretch>
+          </a:blipFill>
+        </p:spPr>
+        <p:txBody>
+          <a:bodyPr/>
+          <a:lstStyle/>
+          <a:p>
+            <a:endParaRPr lang="en-CA"/>
+          </a:p>
+        </p:txBody>
+      </p:sp>
+      <p:sp>
+        <p:nvSpPr>
+          <p:cNvPr id="4" name="Freeform 4">
+            <a:extLst>
+              <a:ext uri="{FF2B5EF4-FFF2-40B4-BE49-F238E27FC236}">
+                <a16:creationId xmlns:a16="http://schemas.microsoft.com/office/drawing/2014/main" id="{8CD3F829-4632-13EE-A775-73F958E4E303}"/>
+              </a:ext>
+            </a:extLst>
+          </p:cNvPr>
+          <p:cNvSpPr/>
+          <p:nvPr/>
+        </p:nvSpPr>
+        <p:spPr>
+          <a:xfrm flipH="1">
+            <a:off x="15486600" y="7366014"/>
+            <a:ext cx="2359274" cy="2359274"/>
+          </a:xfrm>
+          <a:custGeom>
+            <a:avLst/>
+            <a:gdLst/>
+            <a:ahLst/>
+            <a:cxnLst/>
+            <a:rect l="l" t="t" r="r" b="b"/>
+            <a:pathLst>
+              <a:path w="2359274" h="2359274">
+                <a:moveTo>
+                  <a:pt x="2359274" y="0"/>
+                </a:moveTo>
+                <a:lnTo>
+                  <a:pt x="0" y="0"/>
+                </a:lnTo>
+                <a:lnTo>
+                  <a:pt x="0" y="2359274"/>
+                </a:lnTo>
+                <a:lnTo>
+                  <a:pt x="2359274" y="2359274"/>
+                </a:lnTo>
+                <a:lnTo>
+                  <a:pt x="2359274" y="0"/>
+                </a:lnTo>
+                <a:close/>
+              </a:path>
+            </a:pathLst>
+          </a:custGeom>
+          <a:blipFill>
+            <a:blip>
+              <a:extLst>
+                <a:ext uri="{96DAC541-7B7A-43D3-8B79-37D633B846F1}">
+                  <asvg:svgBlip xmlns:asvg="http://schemas.microsoft.com/office/drawing/2016/SVG/main" r:embed="rId3"/>
+                </a:ext>
+              </a:extLst>
+            </a:blip>
+            <a:stretch>
+              <a:fillRect/>
+            </a:stretch>
+          </a:blipFill>
+        </p:spPr>
+        <p:txBody>
+          <a:bodyPr/>
+          <a:lstStyle/>
+          <a:p>
+            <a:endParaRPr lang="en-CA"/>
+          </a:p>
+        </p:txBody>
+      </p:sp>
+      <p:sp>
+        <p:nvSpPr>
+          <p:cNvPr id="5" name="Freeform 5">
+            <a:extLst>
+              <a:ext uri="{FF2B5EF4-FFF2-40B4-BE49-F238E27FC236}">
+                <a16:creationId xmlns:a16="http://schemas.microsoft.com/office/drawing/2014/main" id="{5DE8145F-90C6-1A73-7399-5FC9087E243F}"/>
+              </a:ext>
+            </a:extLst>
+          </p:cNvPr>
+          <p:cNvSpPr/>
+          <p:nvPr/>
+        </p:nvSpPr>
+        <p:spPr>
+          <a:xfrm>
+            <a:off x="15486600" y="396902"/>
+            <a:ext cx="4114800" cy="4114800"/>
+          </a:xfrm>
+          <a:custGeom>
+            <a:avLst/>
+            <a:gdLst/>
+            <a:ahLst/>
+            <a:cxnLst/>
+            <a:rect l="l" t="t" r="r" b="b"/>
+            <a:pathLst>
+              <a:path w="4114800" h="4114800">
+                <a:moveTo>
+                  <a:pt x="0" y="0"/>
+                </a:moveTo>
+                <a:lnTo>
+                  <a:pt x="4114800" y="0"/>
+                </a:lnTo>
+                <a:lnTo>
+                  <a:pt x="4114800" y="4114800"/>
+                </a:lnTo>
+                <a:lnTo>
+                  <a:pt x="0" y="4114800"/>
+                </a:lnTo>
+                <a:lnTo>
+                  <a:pt x="0" y="0"/>
+                </a:lnTo>
+                <a:close/>
+              </a:path>
+            </a:pathLst>
+          </a:custGeom>
+          <a:blipFill>
+            <a:blip>
+              <a:alphaModFix amt="24000"/>
+              <a:extLst>
+                <a:ext uri="{96DAC541-7B7A-43D3-8B79-37D633B846F1}">
+                  <asvg:svgBlip xmlns:asvg="http://schemas.microsoft.com/office/drawing/2016/SVG/main" r:embed="rId4"/>
+                </a:ext>
+              </a:extLst>
+            </a:blip>
+            <a:stretch>
+              <a:fillRect/>
+            </a:stretch>
+          </a:blipFill>
+        </p:spPr>
+        <p:txBody>
+          <a:bodyPr/>
+          <a:lstStyle/>
+          <a:p>
+            <a:endParaRPr lang="en-CA"/>
+          </a:p>
+        </p:txBody>
+      </p:sp>
+      <p:sp>
+        <p:nvSpPr>
+          <p:cNvPr id="6" name="Freeform 6">
+            <a:extLst>
+              <a:ext uri="{FF2B5EF4-FFF2-40B4-BE49-F238E27FC236}">
+                <a16:creationId xmlns:a16="http://schemas.microsoft.com/office/drawing/2014/main" id="{165EF9A0-40A3-EED0-1F32-009AE1855E5C}"/>
+              </a:ext>
+            </a:extLst>
+          </p:cNvPr>
+          <p:cNvSpPr/>
+          <p:nvPr/>
+        </p:nvSpPr>
+        <p:spPr>
+          <a:xfrm>
+            <a:off x="57095" y="7366014"/>
+            <a:ext cx="2693378" cy="2693378"/>
+          </a:xfrm>
+          <a:custGeom>
+            <a:avLst/>
+            <a:gdLst/>
+            <a:ahLst/>
+            <a:cxnLst/>
+            <a:rect l="l" t="t" r="r" b="b"/>
+            <a:pathLst>
+              <a:path w="2693378" h="2693378">
+                <a:moveTo>
+                  <a:pt x="0" y="0"/>
+                </a:moveTo>
+                <a:lnTo>
+                  <a:pt x="2693378" y="0"/>
+                </a:lnTo>
+                <a:lnTo>
+                  <a:pt x="2693378" y="2693378"/>
+                </a:lnTo>
+                <a:lnTo>
+                  <a:pt x="0" y="2693378"/>
+                </a:lnTo>
+                <a:lnTo>
+                  <a:pt x="0" y="0"/>
+                </a:lnTo>
+                <a:close/>
+              </a:path>
+            </a:pathLst>
+          </a:custGeom>
+          <a:blipFill>
+            <a:blip>
+              <a:alphaModFix amt="24000"/>
+              <a:extLst>
+                <a:ext uri="{96DAC541-7B7A-43D3-8B79-37D633B846F1}">
+                  <asvg:svgBlip xmlns:asvg="http://schemas.microsoft.com/office/drawing/2016/SVG/main" r:embed="rId4"/>
+                </a:ext>
+              </a:extLst>
+            </a:blip>
+            <a:stretch>
+              <a:fillRect/>
+            </a:stretch>
+          </a:blipFill>
+        </p:spPr>
+        <p:txBody>
+          <a:bodyPr/>
+          <a:lstStyle/>
+          <a:p>
+            <a:endParaRPr lang="en-CA"/>
+          </a:p>
+        </p:txBody>
+      </p:sp>
+      <p:sp>
+        <p:nvSpPr>
+          <p:cNvPr id="11" name="TextBox 11">
+            <a:extLst>
+              <a:ext uri="{FF2B5EF4-FFF2-40B4-BE49-F238E27FC236}">
+                <a16:creationId xmlns:a16="http://schemas.microsoft.com/office/drawing/2014/main" id="{CB349583-F6FC-C6CE-BEBE-AF80E41F0E04}"/>
+              </a:ext>
+            </a:extLst>
+          </p:cNvPr>
+          <p:cNvSpPr txBox="1"/>
+          <p:nvPr/>
+        </p:nvSpPr>
+        <p:spPr>
+          <a:xfrm>
+            <a:off x="2878299" y="700271"/>
+            <a:ext cx="14166815" cy="1102866"/>
+          </a:xfrm>
+          <a:prstGeom prst="rect">
+            <a:avLst/>
+          </a:prstGeom>
+        </p:spPr>
+        <p:txBody>
+          <a:bodyPr wrap="square" lIns="0" tIns="0" rIns="0" bIns="0" rtlCol="0" anchor="t">
+            <a:spAutoFit/>
+          </a:bodyPr>
+          <a:lstStyle/>
+          <a:p>
+            <a:pPr algn="ctr">
+              <a:lnSpc>
+                <a:spcPts val="8560"/>
+              </a:lnSpc>
+            </a:pPr>
+            <a:r>
+              <a:rPr lang="en-US" sz="8000" b="1" dirty="0">
+                <a:solidFill>
+                  <a:srgbClr val="000000"/>
+                </a:solidFill>
+                <a:latin typeface="Alegreya Sans SC Bold"/>
+                <a:ea typeface="Alegreya Sans SC Bold"/>
+                <a:cs typeface="Alegreya Sans SC Bold"/>
+                <a:sym typeface="Alegreya Sans SC Bold"/>
+              </a:rPr>
+              <a:t>RSA Encryption</a:t>
+            </a:r>
+          </a:p>
+        </p:txBody>
+      </p:sp>
+      <p:sp>
+        <p:nvSpPr>
+          <p:cNvPr id="13" name="TextBox 13">
+            <a:extLst>
+              <a:ext uri="{FF2B5EF4-FFF2-40B4-BE49-F238E27FC236}">
+                <a16:creationId xmlns:a16="http://schemas.microsoft.com/office/drawing/2014/main" id="{E2B51801-940F-AAF0-8CC5-7FD0D5128922}"/>
+              </a:ext>
+            </a:extLst>
+          </p:cNvPr>
+          <p:cNvSpPr txBox="1"/>
+          <p:nvPr/>
+        </p:nvSpPr>
+        <p:spPr>
+          <a:xfrm>
+            <a:off x="4856821" y="1362849"/>
+            <a:ext cx="10209770" cy="961802"/>
+          </a:xfrm>
+          <a:prstGeom prst="rect">
+            <a:avLst/>
+          </a:prstGeom>
+        </p:spPr>
+        <p:txBody>
+          <a:bodyPr wrap="square" lIns="0" tIns="0" rIns="0" bIns="0" rtlCol="0" anchor="t">
+            <a:spAutoFit/>
+          </a:bodyPr>
+          <a:lstStyle/>
+          <a:p>
+            <a:pPr algn="ctr">
+              <a:lnSpc>
+                <a:spcPts val="8400"/>
+              </a:lnSpc>
+              <a:spcBef>
+                <a:spcPct val="0"/>
+              </a:spcBef>
+            </a:pPr>
+            <a:r>
+              <a:rPr lang="en-US" sz="6000" dirty="0">
+                <a:solidFill>
+                  <a:srgbClr val="545454"/>
+                </a:solidFill>
+                <a:latin typeface="Alegreya Sans SC"/>
+                <a:ea typeface="Alegreya Sans SC"/>
+                <a:cs typeface="Alegreya Sans SC"/>
+                <a:sym typeface="Alegreya Sans SC"/>
+              </a:rPr>
+              <a:t>How They’re Used and Made</a:t>
+            </a:r>
+          </a:p>
+        </p:txBody>
+      </p:sp>
+      <p:pic>
+        <p:nvPicPr>
+          <p:cNvPr id="14" name="Picture 13" descr="RSA algorithm structure | Download Scientific Diagram">
+            <a:extLst>
+              <a:ext uri="{FF2B5EF4-FFF2-40B4-BE49-F238E27FC236}">
+                <a16:creationId xmlns:a16="http://schemas.microsoft.com/office/drawing/2014/main" id="{0FEBD21A-36A9-22E1-023F-65F132B73EFA}"/>
+              </a:ext>
+            </a:extLst>
+          </p:cNvPr>
+          <p:cNvPicPr>
+            <a:picLocks noChangeAspect="1"/>
+          </p:cNvPicPr>
+          <p:nvPr/>
+        </p:nvPicPr>
+        <p:blipFill>
+          <a:blip r:embed="rId5"/>
+          <a:stretch>
+            <a:fillRect/>
+          </a:stretch>
+        </p:blipFill>
+        <p:spPr>
+          <a:xfrm>
+            <a:off x="4709855" y="2756176"/>
+            <a:ext cx="11159149" cy="6695676"/>
+          </a:xfrm>
+          <a:prstGeom prst="rect">
+            <a:avLst/>
+          </a:prstGeom>
+          <a:effectLst>
+            <a:outerShdw blurRad="254000" dist="762000" dir="2400000" algn="ctr" rotWithShape="0">
+              <a:srgbClr val="000000">
+                <a:alpha val="40000"/>
+              </a:srgbClr>
+            </a:outerShdw>
+          </a:effectLst>
+        </p:spPr>
+      </p:pic>
+    </p:spTree>
+    <p:extLst>
+      <p:ext uri="{BB962C8B-B14F-4D97-AF65-F5344CB8AC3E}">
+        <p14:creationId xmlns:p14="http://schemas.microsoft.com/office/powerpoint/2010/main" val="2220332165"/>
+      </p:ext>
+    </p:extLst>
+  </p:cSld>
+  <p:clrMapOvr>
+    <a:masterClrMapping/>
+  </p:clrMapOvr>
+</p:sld>
+</file>
+
+<file path=ppt/slides/slide4.xml><?xml version="1.0" encoding="utf-8"?>
 <p:sld xmlns:a="http://schemas.openxmlformats.org/drawingml/2006/main" xmlns:r="http://schemas.openxmlformats.org/officeDocument/2006/relationships" xmlns:p="http://schemas.openxmlformats.org/presentationml/2006/main">
   <p:cSld>
     <p:spTree>
@@ -4881,7 +5487,7 @@
         <p:grpSpPr>
           <a:xfrm>
             <a:off x="345390" y="3790450"/>
-            <a:ext cx="12886102" cy="2281105"/>
+            <a:ext cx="12104368" cy="2281105"/>
             <a:chOff x="0" y="0"/>
             <a:chExt cx="3393871" cy="600785"/>
           </a:xfrm>
@@ -5005,59 +5611,6 @@
       </p:grpSp>
       <p:sp>
         <p:nvSpPr>
-          <p:cNvPr id="15" name="Freeform 15"/>
-          <p:cNvSpPr/>
-          <p:nvPr/>
-        </p:nvSpPr>
-        <p:spPr>
-          <a:xfrm>
-            <a:off x="13350268" y="4151832"/>
-            <a:ext cx="7585267" cy="6012560"/>
-          </a:xfrm>
-          <a:custGeom>
-            <a:avLst/>
-            <a:gdLst/>
-            <a:ahLst/>
-            <a:cxnLst/>
-            <a:rect l="l" t="t" r="r" b="b"/>
-            <a:pathLst>
-              <a:path w="5375467" h="4031600">
-                <a:moveTo>
-                  <a:pt x="0" y="0"/>
-                </a:moveTo>
-                <a:lnTo>
-                  <a:pt x="5375467" y="0"/>
-                </a:lnTo>
-                <a:lnTo>
-                  <a:pt x="5375467" y="4031600"/>
-                </a:lnTo>
-                <a:lnTo>
-                  <a:pt x="0" y="4031600"/>
-                </a:lnTo>
-                <a:lnTo>
-                  <a:pt x="0" y="0"/>
-                </a:lnTo>
-                <a:close/>
-              </a:path>
-            </a:pathLst>
-          </a:custGeom>
-          <a:blipFill>
-            <a:blip r:embed="rId5"/>
-            <a:stretch>
-              <a:fillRect/>
-            </a:stretch>
-          </a:blipFill>
-        </p:spPr>
-        <p:txBody>
-          <a:bodyPr/>
-          <a:lstStyle/>
-          <a:p>
-            <a:endParaRPr lang="en-CA"/>
-          </a:p>
-        </p:txBody>
-      </p:sp>
-      <p:sp>
-        <p:nvSpPr>
           <p:cNvPr id="16" name="TextBox 16"/>
           <p:cNvSpPr txBox="1"/>
           <p:nvPr/>
@@ -5105,8 +5658,8 @@
         </p:nvSpPr>
         <p:spPr>
           <a:xfrm>
-            <a:off x="345390" y="3979148"/>
-            <a:ext cx="12886102" cy="2306193"/>
+            <a:off x="544497" y="3958213"/>
+            <a:ext cx="12886102" cy="2335063"/>
           </a:xfrm>
           <a:prstGeom prst="rect">
             <a:avLst/>
@@ -5118,74 +5671,98 @@
           </a:bodyPr>
           <a:lstStyle/>
           <a:p>
-            <a:pPr algn="ctr">
+            <a:pPr>
               <a:lnSpc>
                 <a:spcPts val="3696"/>
               </a:lnSpc>
             </a:pPr>
             <a:r>
-              <a:rPr lang="en-US" sz="2400">
+              <a:rPr lang="en-US" sz="2400" dirty="0">
                 <a:solidFill>
                   <a:srgbClr val="000000"/>
                 </a:solidFill>
-                <a:latin typeface="Aileron"/>
+                <a:latin typeface="Candara" panose="020E0502030303020204" pitchFamily="34" charset="0"/>
                 <a:ea typeface="Aileron"/>
                 <a:cs typeface="Aileron"/>
                 <a:sym typeface="Aileron"/>
               </a:rPr>
-              <a:t>To start off, you need to take two very large random prime numbers.</a:t>
-            </a:r>
-          </a:p>
-          <a:p>
-            <a:pPr algn="ctr">
+              <a:t>Generating keys involves two very large prime numbers.</a:t>
+            </a:r>
+          </a:p>
+          <a:p>
+            <a:pPr>
               <a:lnSpc>
                 <a:spcPts val="3696"/>
               </a:lnSpc>
             </a:pPr>
             <a:r>
-              <a:rPr lang="en-US" sz="2400">
+              <a:rPr lang="en-US" sz="2400" dirty="0">
                 <a:solidFill>
                   <a:srgbClr val="000000"/>
                 </a:solidFill>
-                <a:latin typeface="Aileron"/>
+                <a:latin typeface="Candara" panose="020E0502030303020204" pitchFamily="34" charset="0"/>
                 <a:ea typeface="Aileron"/>
                 <a:cs typeface="Aileron"/>
                 <a:sym typeface="Aileron"/>
               </a:rPr>
-              <a:t>This is done in UNIX systems by converting the output of /dev/urandom into a hexadecimal.</a:t>
-            </a:r>
-          </a:p>
-          <a:p>
-            <a:pPr algn="ctr">
+              <a:t>This is done in UNIX systems by converting the output into a hexadecimal.</a:t>
+            </a:r>
+          </a:p>
+          <a:p>
+            <a:pPr>
               <a:lnSpc>
                 <a:spcPts val="3696"/>
               </a:lnSpc>
             </a:pPr>
             <a:r>
-              <a:rPr lang="en-US" sz="2400">
+              <a:rPr lang="en-US" sz="2400" dirty="0">
                 <a:solidFill>
                   <a:srgbClr val="000000"/>
                 </a:solidFill>
-                <a:latin typeface="Aileron"/>
+                <a:latin typeface="Candara" panose="020E0502030303020204" pitchFamily="34" charset="0"/>
                 <a:ea typeface="Aileron"/>
                 <a:cs typeface="Aileron"/>
                 <a:sym typeface="Aileron"/>
               </a:rPr>
-              <a:t>How big the number depends on how many bits are received from urandom.</a:t>
-            </a:r>
-          </a:p>
-          <a:p>
-            <a:pPr algn="ctr">
+              <a:t>How big the number depends on how many bits are received from </a:t>
+            </a:r>
+            <a:r>
+              <a:rPr lang="en-US" sz="2400" dirty="0" err="1">
+                <a:solidFill>
+                  <a:srgbClr val="000000"/>
+                </a:solidFill>
+                <a:latin typeface="Candara" panose="020E0502030303020204" pitchFamily="34" charset="0"/>
+                <a:ea typeface="Aileron"/>
+                <a:cs typeface="Aileron"/>
+                <a:sym typeface="Aileron"/>
+              </a:rPr>
+              <a:t>urandom</a:t>
+            </a:r>
+            <a:r>
+              <a:rPr lang="en-US" sz="2400" dirty="0">
+                <a:solidFill>
+                  <a:srgbClr val="000000"/>
+                </a:solidFill>
+                <a:latin typeface="Candara" panose="020E0502030303020204" pitchFamily="34" charset="0"/>
+                <a:ea typeface="Aileron"/>
+                <a:cs typeface="Aileron"/>
+                <a:sym typeface="Aileron"/>
+              </a:rPr>
+              <a:t>.</a:t>
+            </a:r>
+          </a:p>
+          <a:p>
+            <a:pPr>
               <a:lnSpc>
                 <a:spcPts val="3696"/>
               </a:lnSpc>
             </a:pPr>
             <a:r>
-              <a:rPr lang="en-US" sz="2400">
+              <a:rPr lang="en-US" sz="2400" dirty="0">
                 <a:solidFill>
                   <a:srgbClr val="000000"/>
                 </a:solidFill>
-                <a:latin typeface="Aileron"/>
+                <a:latin typeface="Candara" panose="020E0502030303020204" pitchFamily="34" charset="0"/>
                 <a:ea typeface="Aileron"/>
                 <a:cs typeface="Aileron"/>
                 <a:sym typeface="Aileron"/>
@@ -5194,16 +5771,16 @@
             </a:r>
           </a:p>
           <a:p>
-            <a:pPr algn="ctr">
+            <a:pPr>
               <a:lnSpc>
                 <a:spcPts val="3696"/>
               </a:lnSpc>
             </a:pPr>
-            <a:endParaRPr lang="en-US" sz="2400">
+            <a:endParaRPr lang="en-US" sz="2400" dirty="0">
               <a:solidFill>
                 <a:srgbClr val="000000"/>
               </a:solidFill>
-              <a:latin typeface="Aileron"/>
+              <a:latin typeface="Candara" panose="020E0502030303020204" pitchFamily="34" charset="0"/>
               <a:ea typeface="Aileron"/>
               <a:cs typeface="Aileron"/>
               <a:sym typeface="Aileron"/>
@@ -5220,7 +5797,7 @@
         <p:spPr>
           <a:xfrm>
             <a:off x="623191" y="7175515"/>
-            <a:ext cx="5762267" cy="2491740"/>
+            <a:ext cx="5762267" cy="2588337"/>
           </a:xfrm>
           <a:prstGeom prst="rect">
             <a:avLst/>
@@ -5232,7 +5809,7 @@
           </a:bodyPr>
           <a:lstStyle/>
           <a:p>
-            <a:pPr marL="518160" lvl="1" indent="-259080" algn="ctr">
+            <a:pPr marL="518160" lvl="1" indent="-259080">
               <a:lnSpc>
                 <a:spcPts val="3359"/>
               </a:lnSpc>
@@ -5243,11 +5820,11 @@
               <a:buChar char="•"/>
             </a:pPr>
             <a:r>
-              <a:rPr lang="en-US" sz="2400">
+              <a:rPr lang="en-US" sz="2400" dirty="0">
                 <a:solidFill>
                   <a:srgbClr val="000000"/>
                 </a:solidFill>
-                <a:latin typeface="Open Sans"/>
+                <a:latin typeface="Candara" panose="020E0502030303020204" pitchFamily="34" charset="0"/>
                 <a:ea typeface="Open Sans"/>
                 <a:cs typeface="Open Sans"/>
                 <a:sym typeface="Open Sans"/>
@@ -5256,7 +5833,7 @@
             </a:r>
           </a:p>
           <a:p>
-            <a:pPr marL="518160" lvl="1" indent="-259080" algn="ctr">
+            <a:pPr marL="518160" lvl="1" indent="-259080">
               <a:lnSpc>
                 <a:spcPts val="3359"/>
               </a:lnSpc>
@@ -5267,11 +5844,11 @@
               <a:buChar char="•"/>
             </a:pPr>
             <a:r>
-              <a:rPr lang="en-US" sz="2400">
+              <a:rPr lang="en-US" sz="2400" dirty="0">
                 <a:solidFill>
                   <a:srgbClr val="000000"/>
                 </a:solidFill>
-                <a:latin typeface="Open Sans"/>
+                <a:latin typeface="Candara" panose="020E0502030303020204" pitchFamily="34" charset="0"/>
                 <a:ea typeface="Open Sans"/>
                 <a:cs typeface="Open Sans"/>
                 <a:sym typeface="Open Sans"/>
@@ -5280,7 +5857,7 @@
             </a:r>
           </a:p>
           <a:p>
-            <a:pPr marL="518160" lvl="1" indent="-259080" algn="ctr">
+            <a:pPr marL="518160" lvl="1" indent="-259080">
               <a:lnSpc>
                 <a:spcPts val="3359"/>
               </a:lnSpc>
@@ -5291,11 +5868,11 @@
               <a:buChar char="•"/>
             </a:pPr>
             <a:r>
-              <a:rPr lang="en-US" sz="2400">
+              <a:rPr lang="en-US" sz="2400" dirty="0">
                 <a:solidFill>
                   <a:srgbClr val="000000"/>
                 </a:solidFill>
-                <a:latin typeface="Open Sans"/>
+                <a:latin typeface="Candara" panose="020E0502030303020204" pitchFamily="34" charset="0"/>
                 <a:ea typeface="Open Sans"/>
                 <a:cs typeface="Open Sans"/>
                 <a:sym typeface="Open Sans"/>
@@ -5304,7 +5881,7 @@
             </a:r>
           </a:p>
           <a:p>
-            <a:pPr marL="518160" lvl="1" indent="-259080" algn="ctr">
+            <a:pPr marL="518160" lvl="1" indent="-259080">
               <a:lnSpc>
                 <a:spcPts val="3359"/>
               </a:lnSpc>
@@ -5315,11 +5892,11 @@
               <a:buChar char="•"/>
             </a:pPr>
             <a:r>
-              <a:rPr lang="en-US" sz="2400">
+              <a:rPr lang="en-US" sz="2400" dirty="0">
                 <a:solidFill>
                   <a:srgbClr val="000000"/>
                 </a:solidFill>
-                <a:latin typeface="Open Sans"/>
+                <a:latin typeface="Candara" panose="020E0502030303020204" pitchFamily="34" charset="0"/>
                 <a:ea typeface="Open Sans"/>
                 <a:cs typeface="Open Sans"/>
                 <a:sym typeface="Open Sans"/>
@@ -5356,7 +5933,7 @@
               </a:lnSpc>
             </a:pPr>
             <a:r>
-              <a:rPr lang="en-US" sz="3000" b="1">
+              <a:rPr lang="en-US" sz="3000" b="1" dirty="0">
                 <a:solidFill>
                   <a:srgbClr val="000000"/>
                 </a:solidFill>
@@ -5379,7 +5956,7 @@
         <p:spPr>
           <a:xfrm>
             <a:off x="7228099" y="7158112"/>
-            <a:ext cx="5221659" cy="1653540"/>
+            <a:ext cx="5221659" cy="1716304"/>
           </a:xfrm>
           <a:prstGeom prst="rect">
             <a:avLst/>
@@ -5391,7 +5968,7 @@
           </a:bodyPr>
           <a:lstStyle/>
           <a:p>
-            <a:pPr marL="518160" lvl="1" indent="-259080" algn="ctr">
+            <a:pPr marL="518160" lvl="1" indent="-259080">
               <a:lnSpc>
                 <a:spcPts val="3359"/>
               </a:lnSpc>
@@ -5402,11 +5979,11 @@
               <a:buChar char="•"/>
             </a:pPr>
             <a:r>
-              <a:rPr lang="en-US" sz="2400">
+              <a:rPr lang="en-US" sz="2400" dirty="0">
                 <a:solidFill>
                   <a:srgbClr val="000000"/>
                 </a:solidFill>
-                <a:latin typeface="Open Sans"/>
+                <a:latin typeface="Candara" panose="020E0502030303020204" pitchFamily="34" charset="0"/>
                 <a:ea typeface="Open Sans"/>
                 <a:cs typeface="Open Sans"/>
                 <a:sym typeface="Open Sans"/>
@@ -5415,7 +5992,7 @@
             </a:r>
           </a:p>
           <a:p>
-            <a:pPr marL="518160" lvl="1" indent="-259080" algn="ctr">
+            <a:pPr marL="518160" lvl="1" indent="-259080">
               <a:lnSpc>
                 <a:spcPts val="3359"/>
               </a:lnSpc>
@@ -5426,11 +6003,11 @@
               <a:buChar char="•"/>
             </a:pPr>
             <a:r>
-              <a:rPr lang="en-US" sz="2400">
+              <a:rPr lang="en-US" sz="2400" dirty="0">
                 <a:solidFill>
                   <a:srgbClr val="000000"/>
                 </a:solidFill>
-                <a:latin typeface="Open Sans"/>
+                <a:latin typeface="Candara" panose="020E0502030303020204" pitchFamily="34" charset="0"/>
                 <a:ea typeface="Open Sans"/>
                 <a:cs typeface="Open Sans"/>
                 <a:sym typeface="Open Sans"/>
@@ -5439,7 +6016,7 @@
             </a:r>
           </a:p>
           <a:p>
-            <a:pPr marL="518160" lvl="1" indent="-259080" algn="ctr">
+            <a:pPr marL="518160" lvl="1" indent="-259080">
               <a:lnSpc>
                 <a:spcPts val="3359"/>
               </a:lnSpc>
@@ -5450,11 +6027,11 @@
               <a:buChar char="•"/>
             </a:pPr>
             <a:r>
-              <a:rPr lang="en-US" sz="2400">
+              <a:rPr lang="en-US" sz="2400" dirty="0">
                 <a:solidFill>
                   <a:srgbClr val="000000"/>
                 </a:solidFill>
-                <a:latin typeface="Open Sans"/>
+                <a:latin typeface="Candara" panose="020E0502030303020204" pitchFamily="34" charset="0"/>
                 <a:ea typeface="Open Sans"/>
                 <a:cs typeface="Open Sans"/>
                 <a:sym typeface="Open Sans"/>
@@ -5549,6 +6126,44 @@
           </a:p>
         </p:txBody>
       </p:sp>
+      <p:pic>
+        <p:nvPicPr>
+          <p:cNvPr id="26" name="Picture 25">
+            <a:extLst>
+              <a:ext uri="{FF2B5EF4-FFF2-40B4-BE49-F238E27FC236}">
+                <a16:creationId xmlns:a16="http://schemas.microsoft.com/office/drawing/2014/main" id="{F6C15EF3-6EFE-C1F9-C15D-38F80268CD88}"/>
+              </a:ext>
+            </a:extLst>
+          </p:cNvPr>
+          <p:cNvPicPr>
+            <a:picLocks noChangeAspect="1"/>
+          </p:cNvPicPr>
+          <p:nvPr/>
+        </p:nvPicPr>
+        <p:blipFill>
+          <a:blip r:embed="rId5"/>
+          <a:srcRect t="7715"/>
+          <a:stretch>
+            <a:fillRect/>
+          </a:stretch>
+        </p:blipFill>
+        <p:spPr>
+          <a:xfrm>
+            <a:off x="14068609" y="1606056"/>
+            <a:ext cx="6126232" cy="8426840"/>
+          </a:xfrm>
+          <a:prstGeom prst="rect">
+            <a:avLst/>
+          </a:prstGeom>
+          <a:effectLst>
+            <a:outerShdw blurRad="254000" dist="381000" dir="3000000" algn="ctr" rotWithShape="0">
+              <a:srgbClr val="000000">
+                <a:alpha val="43137"/>
+              </a:srgbClr>
+            </a:outerShdw>
+          </a:effectLst>
+        </p:spPr>
+      </p:pic>
     </p:spTree>
   </p:cSld>
   <p:clrMapOvr>
@@ -5557,7 +6172,7 @@
 </p:sld>
 </file>
 
-<file path=ppt/slides/slide4.xml><?xml version="1.0" encoding="utf-8"?>
+<file path=ppt/slides/slide5.xml><?xml version="1.0" encoding="utf-8"?>
 <p:sld xmlns:a="http://schemas.openxmlformats.org/drawingml/2006/main" xmlns:r="http://schemas.openxmlformats.org/officeDocument/2006/relationships" xmlns:p="http://schemas.openxmlformats.org/presentationml/2006/main">
   <p:cSld>
     <p:spTree>
@@ -5879,8 +6494,8 @@
         </p:nvGrpSpPr>
         <p:grpSpPr>
           <a:xfrm>
-            <a:off x="1600201" y="3335932"/>
-            <a:ext cx="7180552" cy="5846168"/>
+            <a:off x="715008" y="3854792"/>
+            <a:ext cx="8229600" cy="4855568"/>
             <a:chOff x="0" y="0"/>
             <a:chExt cx="2238372" cy="1281401"/>
           </a:xfrm>
@@ -5994,59 +6609,6 @@
       </p:grpSp>
       <p:sp>
         <p:nvSpPr>
-          <p:cNvPr id="10" name="Freeform 10"/>
-          <p:cNvSpPr/>
-          <p:nvPr/>
-        </p:nvSpPr>
-        <p:spPr>
-          <a:xfrm>
-            <a:off x="9906000" y="2889064"/>
-            <a:ext cx="10637996" cy="6235712"/>
-          </a:xfrm>
-          <a:custGeom>
-            <a:avLst/>
-            <a:gdLst/>
-            <a:ahLst/>
-            <a:cxnLst/>
-            <a:rect l="l" t="t" r="r" b="b"/>
-            <a:pathLst>
-              <a:path w="7668544" h="3834272">
-                <a:moveTo>
-                  <a:pt x="0" y="0"/>
-                </a:moveTo>
-                <a:lnTo>
-                  <a:pt x="7668544" y="0"/>
-                </a:lnTo>
-                <a:lnTo>
-                  <a:pt x="7668544" y="3834272"/>
-                </a:lnTo>
-                <a:lnTo>
-                  <a:pt x="0" y="3834272"/>
-                </a:lnTo>
-                <a:lnTo>
-                  <a:pt x="0" y="0"/>
-                </a:lnTo>
-                <a:close/>
-              </a:path>
-            </a:pathLst>
-          </a:custGeom>
-          <a:blipFill>
-            <a:blip r:embed="rId5"/>
-            <a:stretch>
-              <a:fillRect/>
-            </a:stretch>
-          </a:blipFill>
-        </p:spPr>
-        <p:txBody>
-          <a:bodyPr/>
-          <a:lstStyle/>
-          <a:p>
-            <a:endParaRPr lang="en-CA"/>
-          </a:p>
-        </p:txBody>
-      </p:sp>
-      <p:sp>
-        <p:nvSpPr>
           <p:cNvPr id="12" name="TextBox 12"/>
           <p:cNvSpPr txBox="1"/>
           <p:nvPr/>
@@ -6094,8 +6656,8 @@
         </p:nvSpPr>
         <p:spPr>
           <a:xfrm>
-            <a:off x="2061756" y="3692711"/>
-            <a:ext cx="6214041" cy="5171544"/>
+            <a:off x="1096008" y="4211571"/>
+            <a:ext cx="8118707" cy="4233018"/>
           </a:xfrm>
           <a:prstGeom prst="rect">
             <a:avLst/>
@@ -6117,7 +6679,7 @@
                 <a:solidFill>
                   <a:srgbClr val="000000"/>
                 </a:solidFill>
-                <a:latin typeface="Aileron"/>
+                <a:latin typeface="Candara" panose="020E0502030303020204" pitchFamily="34" charset="0"/>
                 <a:ea typeface="Aileron"/>
                 <a:cs typeface="Aileron"/>
                 <a:sym typeface="Aileron"/>
@@ -6138,7 +6700,7 @@
                 <a:solidFill>
                   <a:srgbClr val="000000"/>
                 </a:solidFill>
-                <a:latin typeface="Aileron"/>
+                <a:latin typeface="Candara" panose="020E0502030303020204" pitchFamily="34" charset="0"/>
                 <a:ea typeface="Aileron"/>
                 <a:cs typeface="Aileron"/>
                 <a:sym typeface="Aileron"/>
@@ -6159,12 +6721,12 @@
                 <a:solidFill>
                   <a:srgbClr val="000000"/>
                 </a:solidFill>
-                <a:latin typeface="Aileron"/>
+                <a:latin typeface="Candara" panose="020E0502030303020204" pitchFamily="34" charset="0"/>
                 <a:ea typeface="Aileron"/>
                 <a:cs typeface="Aileron"/>
                 <a:sym typeface="Aileron"/>
               </a:rPr>
-              <a:t>Made to counter attackers intercepting public keys and sending/reading data without being a part of the connection</a:t>
+              <a:t>Made to counter attackers intercepting public keys and sending/reading data</a:t>
             </a:r>
           </a:p>
           <a:p>
@@ -6180,7 +6742,7 @@
                 <a:solidFill>
                   <a:srgbClr val="000000"/>
                 </a:solidFill>
-                <a:latin typeface="Aileron"/>
+                <a:latin typeface="Candara" panose="020E0502030303020204" pitchFamily="34" charset="0"/>
                 <a:ea typeface="Aileron"/>
                 <a:cs typeface="Aileron"/>
                 <a:sym typeface="Aileron"/>
@@ -6201,7 +6763,7 @@
                 <a:solidFill>
                   <a:srgbClr val="000000"/>
                 </a:solidFill>
-                <a:latin typeface="Aileron"/>
+                <a:latin typeface="Candara" panose="020E0502030303020204" pitchFamily="34" charset="0"/>
                 <a:ea typeface="Aileron"/>
                 <a:cs typeface="Aileron"/>
                 <a:sym typeface="Aileron"/>
@@ -6222,7 +6784,7 @@
                 <a:solidFill>
                   <a:srgbClr val="000000"/>
                 </a:solidFill>
-                <a:latin typeface="Aileron"/>
+                <a:latin typeface="Candara" panose="020E0502030303020204" pitchFamily="34" charset="0"/>
                 <a:ea typeface="Aileron"/>
                 <a:cs typeface="Aileron"/>
                 <a:sym typeface="Aileron"/>
@@ -6276,6 +6838,43 @@
           </a:p>
         </p:txBody>
       </p:sp>
+      <p:pic>
+        <p:nvPicPr>
+          <p:cNvPr id="15" name="Picture 14" descr="Avoiding man-in-the-middle (MITM) attacks">
+            <a:extLst>
+              <a:ext uri="{FF2B5EF4-FFF2-40B4-BE49-F238E27FC236}">
+                <a16:creationId xmlns:a16="http://schemas.microsoft.com/office/drawing/2014/main" id="{4DCE26C5-E2AE-51F1-E93A-0BE7635D8E46}"/>
+              </a:ext>
+            </a:extLst>
+          </p:cNvPr>
+          <p:cNvPicPr>
+            <a:picLocks noChangeAspect="1"/>
+          </p:cNvPicPr>
+          <p:nvPr/>
+        </p:nvPicPr>
+        <p:blipFill>
+          <a:blip r:embed="rId5"/>
+          <a:stretch>
+            <a:fillRect/>
+          </a:stretch>
+        </p:blipFill>
+        <p:spPr>
+          <a:xfrm>
+            <a:off x="9865556" y="3621309"/>
+            <a:ext cx="9882493" cy="5189510"/>
+          </a:xfrm>
+          <a:prstGeom prst="rect">
+            <a:avLst/>
+          </a:prstGeom>
+          <a:effectLst>
+            <a:outerShdw blurRad="254000" dist="635000" dir="2400000" algn="ctr" rotWithShape="0">
+              <a:srgbClr val="000000">
+                <a:alpha val="40000"/>
+              </a:srgbClr>
+            </a:outerShdw>
+          </a:effectLst>
+        </p:spPr>
+      </p:pic>
     </p:spTree>
   </p:cSld>
   <p:clrMapOvr>
@@ -6284,7 +6883,7 @@
 </p:sld>
 </file>
 
-<file path=ppt/slides/slide5.xml><?xml version="1.0" encoding="utf-8"?>
+<file path=ppt/slides/slide6.xml><?xml version="1.0" encoding="utf-8"?>
 <p:sld xmlns:a="http://schemas.openxmlformats.org/drawingml/2006/main" xmlns:r="http://schemas.openxmlformats.org/officeDocument/2006/relationships" xmlns:p="http://schemas.openxmlformats.org/presentationml/2006/main">
   <p:cSld>
     <p:spTree>
@@ -6817,7 +7416,7 @@
         <p:spPr>
           <a:xfrm>
             <a:off x="9779262" y="4011310"/>
-            <a:ext cx="9894900" cy="5573268"/>
+            <a:ext cx="9894900" cy="5181996"/>
           </a:xfrm>
           <a:prstGeom prst="rect">
             <a:avLst/>
@@ -6828,6 +7427,27 @@
             <a:spAutoFit/>
           </a:bodyPr>
           <a:lstStyle/>
+          <a:p>
+            <a:pPr marL="601980" lvl="1" indent="-342900" algn="l">
+              <a:lnSpc>
+                <a:spcPts val="3696"/>
+              </a:lnSpc>
+              <a:buFont typeface="Arial" panose="020B0604020202020204" pitchFamily="34" charset="0"/>
+              <a:buChar char="•"/>
+            </a:pPr>
+            <a:r>
+              <a:rPr lang="en-US" sz="2400" dirty="0">
+                <a:solidFill>
+                  <a:srgbClr val="000000"/>
+                </a:solidFill>
+                <a:latin typeface="Candara" panose="020E0502030303020204" pitchFamily="34" charset="0"/>
+                <a:ea typeface="Aileron"/>
+                <a:cs typeface="Aileron"/>
+                <a:sym typeface="Aileron"/>
+              </a:rPr>
+              <a:t>Send or receive data</a:t>
+            </a:r>
+          </a:p>
           <a:p>
             <a:pPr marL="518160" lvl="1" indent="-259080" algn="l">
               <a:lnSpc>
@@ -6841,12 +7461,12 @@
                 <a:solidFill>
                   <a:srgbClr val="000000"/>
                 </a:solidFill>
-                <a:latin typeface="Aileron"/>
+                <a:latin typeface="Candara" panose="020E0502030303020204" pitchFamily="34" charset="0"/>
                 <a:ea typeface="Aileron"/>
                 <a:cs typeface="Aileron"/>
                 <a:sym typeface="Aileron"/>
               </a:rPr>
-              <a:t>Asymmetric encryption algorithms can be used anytime a client wants to send or receive data</a:t>
+              <a:t>RSA is safer than https over public networks</a:t>
             </a:r>
           </a:p>
           <a:p>
@@ -6862,12 +7482,12 @@
                 <a:solidFill>
                   <a:srgbClr val="000000"/>
                 </a:solidFill>
-                <a:latin typeface="Aileron"/>
+                <a:latin typeface="Candara" panose="020E0502030303020204" pitchFamily="34" charset="0"/>
                 <a:ea typeface="Aileron"/>
                 <a:cs typeface="Aileron"/>
                 <a:sym typeface="Aileron"/>
               </a:rPr>
-              <a:t>RSA is safer than https over public networks</a:t>
+              <a:t>RSA uses a keypair</a:t>
             </a:r>
           </a:p>
           <a:p>
@@ -6883,12 +7503,12 @@
                 <a:solidFill>
                   <a:srgbClr val="000000"/>
                 </a:solidFill>
-                <a:latin typeface="Aileron"/>
+                <a:latin typeface="Candara" panose="020E0502030303020204" pitchFamily="34" charset="0"/>
                 <a:ea typeface="Aileron"/>
                 <a:cs typeface="Aileron"/>
                 <a:sym typeface="Aileron"/>
               </a:rPr>
-              <a:t>RSA uses a keypair</a:t>
+              <a:t>You cannot derive public from private keys</a:t>
             </a:r>
           </a:p>
           <a:p>
@@ -6904,12 +7524,12 @@
                 <a:solidFill>
                   <a:srgbClr val="000000"/>
                 </a:solidFill>
-                <a:latin typeface="Aileron"/>
+                <a:latin typeface="Candara" panose="020E0502030303020204" pitchFamily="34" charset="0"/>
                 <a:ea typeface="Aileron"/>
                 <a:cs typeface="Aileron"/>
                 <a:sym typeface="Aileron"/>
               </a:rPr>
-              <a:t>You cannot derive public from private keys</a:t>
+              <a:t>RSA over open networks are very secure</a:t>
             </a:r>
           </a:p>
           <a:p>
@@ -6925,12 +7545,12 @@
                 <a:solidFill>
                   <a:srgbClr val="000000"/>
                 </a:solidFill>
-                <a:latin typeface="Aileron"/>
+                <a:latin typeface="Candara" panose="020E0502030303020204" pitchFamily="34" charset="0"/>
                 <a:ea typeface="Aileron"/>
                 <a:cs typeface="Aileron"/>
                 <a:sym typeface="Aileron"/>
               </a:rPr>
-              <a:t>RSA over open networks are very secure</a:t>
+              <a:t>Https authenticates websites using certificates</a:t>
             </a:r>
           </a:p>
           <a:p>
@@ -6946,28 +7566,7 @@
                 <a:solidFill>
                   <a:srgbClr val="000000"/>
                 </a:solidFill>
-                <a:latin typeface="Aileron"/>
-                <a:ea typeface="Aileron"/>
-                <a:cs typeface="Aileron"/>
-                <a:sym typeface="Aileron"/>
-              </a:rPr>
-              <a:t>Https authenticates websites using certificates</a:t>
-            </a:r>
-          </a:p>
-          <a:p>
-            <a:pPr marL="518160" lvl="1" indent="-259080" algn="l">
-              <a:lnSpc>
-                <a:spcPts val="3696"/>
-              </a:lnSpc>
-              <a:buFont typeface="Arial"/>
-              <a:buChar char="•"/>
-            </a:pPr>
-            <a:r>
-              <a:rPr lang="en-US" sz="2400" dirty="0">
-                <a:solidFill>
-                  <a:srgbClr val="000000"/>
-                </a:solidFill>
-                <a:latin typeface="Aileron"/>
+                <a:latin typeface="Candara" panose="020E0502030303020204" pitchFamily="34" charset="0"/>
                 <a:ea typeface="Aileron"/>
                 <a:cs typeface="Aileron"/>
                 <a:sym typeface="Aileron"/>
@@ -6985,7 +7584,7 @@
               <a:solidFill>
                 <a:srgbClr val="000000"/>
               </a:solidFill>
-              <a:latin typeface="Aileron"/>
+              <a:latin typeface="Candara" panose="020E0502030303020204" pitchFamily="34" charset="0"/>
               <a:ea typeface="Aileron"/>
               <a:cs typeface="Aileron"/>
               <a:sym typeface="Aileron"/>
@@ -7002,12 +7601,31 @@
                 <a:solidFill>
                   <a:srgbClr val="000000"/>
                 </a:solidFill>
-                <a:latin typeface="Aileron"/>
+                <a:latin typeface="Candara" panose="020E0502030303020204" pitchFamily="34" charset="0"/>
                 <a:ea typeface="Aileron"/>
                 <a:cs typeface="Aileron"/>
                 <a:sym typeface="Aileron"/>
               </a:rPr>
-              <a:t>Another specific use is OpenSSH's ssh program. It connects to a virtual terminal. </a:t>
+              <a:t>Another use is OpenSSH's ssh program. </a:t>
+            </a:r>
+          </a:p>
+          <a:p>
+            <a:pPr algn="l">
+              <a:lnSpc>
+                <a:spcPts val="3696"/>
+              </a:lnSpc>
+            </a:pPr>
+            <a:r>
+              <a:rPr lang="en-US" sz="2400" dirty="0">
+                <a:solidFill>
+                  <a:srgbClr val="000000"/>
+                </a:solidFill>
+                <a:latin typeface="Candara" panose="020E0502030303020204" pitchFamily="34" charset="0"/>
+                <a:ea typeface="Aileron"/>
+                <a:cs typeface="Aileron"/>
+                <a:sym typeface="Aileron"/>
+              </a:rPr>
+              <a:t>It connects to a virtual terminal. </a:t>
             </a:r>
           </a:p>
           <a:p>
@@ -7020,7 +7638,7 @@
               <a:solidFill>
                 <a:srgbClr val="000000"/>
               </a:solidFill>
-              <a:latin typeface="Aileron"/>
+              <a:latin typeface="Candara" panose="020E0502030303020204" pitchFamily="34" charset="0"/>
               <a:ea typeface="Aileron"/>
               <a:cs typeface="Aileron"/>
               <a:sym typeface="Aileron"/>
@@ -7068,845 +7686,6 @@
                 <a:sym typeface="Alegreya Sans SC"/>
               </a:rPr>
               <a:t>Real world Usage</a:t>
-            </a:r>
-          </a:p>
-        </p:txBody>
-      </p:sp>
-    </p:spTree>
-  </p:cSld>
-  <p:clrMapOvr>
-    <a:masterClrMapping/>
-  </p:clrMapOvr>
-</p:sld>
-</file>
-
-<file path=ppt/slides/slide6.xml><?xml version="1.0" encoding="utf-8"?>
-<p:sld xmlns:a="http://schemas.openxmlformats.org/drawingml/2006/main" xmlns:r="http://schemas.openxmlformats.org/officeDocument/2006/relationships" xmlns:p="http://schemas.openxmlformats.org/presentationml/2006/main">
-  <p:cSld>
-    <p:spTree>
-      <p:nvGrpSpPr>
-        <p:cNvPr id="1" name=""/>
-        <p:cNvGrpSpPr/>
-        <p:nvPr/>
-      </p:nvGrpSpPr>
-      <p:grpSpPr>
-        <a:xfrm>
-          <a:off x="0" y="0"/>
-          <a:ext cx="0" cy="0"/>
-          <a:chOff x="0" y="0"/>
-          <a:chExt cx="0" cy="0"/>
-        </a:xfrm>
-      </p:grpSpPr>
-      <p:sp>
-        <p:nvSpPr>
-          <p:cNvPr id="2" name="Freeform 2"/>
-          <p:cNvSpPr/>
-          <p:nvPr/>
-        </p:nvSpPr>
-        <p:spPr>
-          <a:xfrm rot="-5400000">
-            <a:off x="4557186" y="-5988665"/>
-            <a:ext cx="11718479" cy="20832852"/>
-          </a:xfrm>
-          <a:custGeom>
-            <a:avLst/>
-            <a:gdLst/>
-            <a:ahLst/>
-            <a:cxnLst/>
-            <a:rect l="l" t="t" r="r" b="b"/>
-            <a:pathLst>
-              <a:path w="11718479" h="20832852">
-                <a:moveTo>
-                  <a:pt x="0" y="0"/>
-                </a:moveTo>
-                <a:lnTo>
-                  <a:pt x="11718479" y="0"/>
-                </a:lnTo>
-                <a:lnTo>
-                  <a:pt x="11718479" y="20832851"/>
-                </a:lnTo>
-                <a:lnTo>
-                  <a:pt x="0" y="20832851"/>
-                </a:lnTo>
-                <a:lnTo>
-                  <a:pt x="0" y="0"/>
-                </a:lnTo>
-                <a:close/>
-              </a:path>
-            </a:pathLst>
-          </a:custGeom>
-          <a:blipFill>
-            <a:blip>
-              <a:extLst>
-                <a:ext uri="{96DAC541-7B7A-43D3-8B79-37D633B846F1}">
-                  <asvg:svgBlip xmlns:asvg="http://schemas.microsoft.com/office/drawing/2016/SVG/main" r:embed="rId2"/>
-                </a:ext>
-              </a:extLst>
-            </a:blip>
-            <a:stretch>
-              <a:fillRect/>
-            </a:stretch>
-          </a:blipFill>
-        </p:spPr>
-        <p:txBody>
-          <a:bodyPr/>
-          <a:lstStyle/>
-          <a:p>
-            <a:endParaRPr lang="en-CA"/>
-          </a:p>
-        </p:txBody>
-      </p:sp>
-      <p:sp>
-        <p:nvSpPr>
-          <p:cNvPr id="3" name="Freeform 3"/>
-          <p:cNvSpPr/>
-          <p:nvPr/>
-        </p:nvSpPr>
-        <p:spPr>
-          <a:xfrm flipV="1">
-            <a:off x="519025" y="396902"/>
-            <a:ext cx="2359274" cy="2359274"/>
-          </a:xfrm>
-          <a:custGeom>
-            <a:avLst/>
-            <a:gdLst/>
-            <a:ahLst/>
-            <a:cxnLst/>
-            <a:rect l="l" t="t" r="r" b="b"/>
-            <a:pathLst>
-              <a:path w="2359274" h="2359274">
-                <a:moveTo>
-                  <a:pt x="0" y="2359274"/>
-                </a:moveTo>
-                <a:lnTo>
-                  <a:pt x="2359274" y="2359274"/>
-                </a:lnTo>
-                <a:lnTo>
-                  <a:pt x="2359274" y="0"/>
-                </a:lnTo>
-                <a:lnTo>
-                  <a:pt x="0" y="0"/>
-                </a:lnTo>
-                <a:lnTo>
-                  <a:pt x="0" y="2359274"/>
-                </a:lnTo>
-                <a:close/>
-              </a:path>
-            </a:pathLst>
-          </a:custGeom>
-          <a:blipFill>
-            <a:blip>
-              <a:extLst>
-                <a:ext uri="{96DAC541-7B7A-43D3-8B79-37D633B846F1}">
-                  <asvg:svgBlip xmlns:asvg="http://schemas.microsoft.com/office/drawing/2016/SVG/main" r:embed="rId3"/>
-                </a:ext>
-              </a:extLst>
-            </a:blip>
-            <a:stretch>
-              <a:fillRect/>
-            </a:stretch>
-          </a:blipFill>
-        </p:spPr>
-        <p:txBody>
-          <a:bodyPr/>
-          <a:lstStyle/>
-          <a:p>
-            <a:endParaRPr lang="en-CA"/>
-          </a:p>
-        </p:txBody>
-      </p:sp>
-      <p:sp>
-        <p:nvSpPr>
-          <p:cNvPr id="4" name="Freeform 4"/>
-          <p:cNvSpPr/>
-          <p:nvPr/>
-        </p:nvSpPr>
-        <p:spPr>
-          <a:xfrm flipH="1">
-            <a:off x="15486600" y="7366014"/>
-            <a:ext cx="2359274" cy="2359274"/>
-          </a:xfrm>
-          <a:custGeom>
-            <a:avLst/>
-            <a:gdLst/>
-            <a:ahLst/>
-            <a:cxnLst/>
-            <a:rect l="l" t="t" r="r" b="b"/>
-            <a:pathLst>
-              <a:path w="2359274" h="2359274">
-                <a:moveTo>
-                  <a:pt x="2359274" y="0"/>
-                </a:moveTo>
-                <a:lnTo>
-                  <a:pt x="0" y="0"/>
-                </a:lnTo>
-                <a:lnTo>
-                  <a:pt x="0" y="2359274"/>
-                </a:lnTo>
-                <a:lnTo>
-                  <a:pt x="2359274" y="2359274"/>
-                </a:lnTo>
-                <a:lnTo>
-                  <a:pt x="2359274" y="0"/>
-                </a:lnTo>
-                <a:close/>
-              </a:path>
-            </a:pathLst>
-          </a:custGeom>
-          <a:blipFill>
-            <a:blip>
-              <a:extLst>
-                <a:ext uri="{96DAC541-7B7A-43D3-8B79-37D633B846F1}">
-                  <asvg:svgBlip xmlns:asvg="http://schemas.microsoft.com/office/drawing/2016/SVG/main" r:embed="rId3"/>
-                </a:ext>
-              </a:extLst>
-            </a:blip>
-            <a:stretch>
-              <a:fillRect/>
-            </a:stretch>
-          </a:blipFill>
-        </p:spPr>
-        <p:txBody>
-          <a:bodyPr/>
-          <a:lstStyle/>
-          <a:p>
-            <a:endParaRPr lang="en-CA"/>
-          </a:p>
-        </p:txBody>
-      </p:sp>
-      <p:sp>
-        <p:nvSpPr>
-          <p:cNvPr id="5" name="Freeform 5"/>
-          <p:cNvSpPr/>
-          <p:nvPr/>
-        </p:nvSpPr>
-        <p:spPr>
-          <a:xfrm>
-            <a:off x="15486600" y="396902"/>
-            <a:ext cx="4114800" cy="4114800"/>
-          </a:xfrm>
-          <a:custGeom>
-            <a:avLst/>
-            <a:gdLst/>
-            <a:ahLst/>
-            <a:cxnLst/>
-            <a:rect l="l" t="t" r="r" b="b"/>
-            <a:pathLst>
-              <a:path w="4114800" h="4114800">
-                <a:moveTo>
-                  <a:pt x="0" y="0"/>
-                </a:moveTo>
-                <a:lnTo>
-                  <a:pt x="4114800" y="0"/>
-                </a:lnTo>
-                <a:lnTo>
-                  <a:pt x="4114800" y="4114800"/>
-                </a:lnTo>
-                <a:lnTo>
-                  <a:pt x="0" y="4114800"/>
-                </a:lnTo>
-                <a:lnTo>
-                  <a:pt x="0" y="0"/>
-                </a:lnTo>
-                <a:close/>
-              </a:path>
-            </a:pathLst>
-          </a:custGeom>
-          <a:blipFill>
-            <a:blip>
-              <a:alphaModFix amt="24000"/>
-              <a:extLst>
-                <a:ext uri="{96DAC541-7B7A-43D3-8B79-37D633B846F1}">
-                  <asvg:svgBlip xmlns:asvg="http://schemas.microsoft.com/office/drawing/2016/SVG/main" r:embed="rId4"/>
-                </a:ext>
-              </a:extLst>
-            </a:blip>
-            <a:stretch>
-              <a:fillRect/>
-            </a:stretch>
-          </a:blipFill>
-        </p:spPr>
-        <p:txBody>
-          <a:bodyPr/>
-          <a:lstStyle/>
-          <a:p>
-            <a:endParaRPr lang="en-CA"/>
-          </a:p>
-        </p:txBody>
-      </p:sp>
-      <p:sp>
-        <p:nvSpPr>
-          <p:cNvPr id="6" name="Freeform 6"/>
-          <p:cNvSpPr/>
-          <p:nvPr/>
-        </p:nvSpPr>
-        <p:spPr>
-          <a:xfrm>
-            <a:off x="57095" y="7366014"/>
-            <a:ext cx="2693378" cy="2693378"/>
-          </a:xfrm>
-          <a:custGeom>
-            <a:avLst/>
-            <a:gdLst/>
-            <a:ahLst/>
-            <a:cxnLst/>
-            <a:rect l="l" t="t" r="r" b="b"/>
-            <a:pathLst>
-              <a:path w="2693378" h="2693378">
-                <a:moveTo>
-                  <a:pt x="0" y="0"/>
-                </a:moveTo>
-                <a:lnTo>
-                  <a:pt x="2693378" y="0"/>
-                </a:lnTo>
-                <a:lnTo>
-                  <a:pt x="2693378" y="2693378"/>
-                </a:lnTo>
-                <a:lnTo>
-                  <a:pt x="0" y="2693378"/>
-                </a:lnTo>
-                <a:lnTo>
-                  <a:pt x="0" y="0"/>
-                </a:lnTo>
-                <a:close/>
-              </a:path>
-            </a:pathLst>
-          </a:custGeom>
-          <a:blipFill>
-            <a:blip>
-              <a:alphaModFix amt="24000"/>
-              <a:extLst>
-                <a:ext uri="{96DAC541-7B7A-43D3-8B79-37D633B846F1}">
-                  <asvg:svgBlip xmlns:asvg="http://schemas.microsoft.com/office/drawing/2016/SVG/main" r:embed="rId4"/>
-                </a:ext>
-              </a:extLst>
-            </a:blip>
-            <a:stretch>
-              <a:fillRect/>
-            </a:stretch>
-          </a:blipFill>
-        </p:spPr>
-        <p:txBody>
-          <a:bodyPr/>
-          <a:lstStyle/>
-          <a:p>
-            <a:endParaRPr lang="en-CA"/>
-          </a:p>
-        </p:txBody>
-      </p:sp>
-      <p:grpSp>
-        <p:nvGrpSpPr>
-          <p:cNvPr id="7" name="Group 7"/>
-          <p:cNvGrpSpPr/>
-          <p:nvPr/>
-        </p:nvGrpSpPr>
-        <p:grpSpPr>
-          <a:xfrm>
-            <a:off x="1519878" y="2746756"/>
-            <a:ext cx="7639795" cy="6591008"/>
-            <a:chOff x="0" y="0"/>
-            <a:chExt cx="2012127" cy="1735903"/>
-          </a:xfrm>
-        </p:grpSpPr>
-        <p:sp>
-          <p:nvSpPr>
-            <p:cNvPr id="8" name="Freeform 8"/>
-            <p:cNvSpPr/>
-            <p:nvPr/>
-          </p:nvSpPr>
-          <p:spPr>
-            <a:xfrm>
-              <a:off x="0" y="0"/>
-              <a:ext cx="2012127" cy="1735903"/>
-            </a:xfrm>
-            <a:custGeom>
-              <a:avLst/>
-              <a:gdLst/>
-              <a:ahLst/>
-              <a:cxnLst/>
-              <a:rect l="l" t="t" r="r" b="b"/>
-              <a:pathLst>
-                <a:path w="2012127" h="1735903">
-                  <a:moveTo>
-                    <a:pt x="51682" y="0"/>
-                  </a:moveTo>
-                  <a:lnTo>
-                    <a:pt x="1960445" y="0"/>
-                  </a:lnTo>
-                  <a:cubicBezTo>
-                    <a:pt x="1974152" y="0"/>
-                    <a:pt x="1987298" y="5445"/>
-                    <a:pt x="1996990" y="15137"/>
-                  </a:cubicBezTo>
-                  <a:cubicBezTo>
-                    <a:pt x="2006682" y="24829"/>
-                    <a:pt x="2012127" y="37975"/>
-                    <a:pt x="2012127" y="51682"/>
-                  </a:cubicBezTo>
-                  <a:lnTo>
-                    <a:pt x="2012127" y="1684222"/>
-                  </a:lnTo>
-                  <a:cubicBezTo>
-                    <a:pt x="2012127" y="1697929"/>
-                    <a:pt x="2006682" y="1711074"/>
-                    <a:pt x="1996990" y="1720766"/>
-                  </a:cubicBezTo>
-                  <a:cubicBezTo>
-                    <a:pt x="1987298" y="1730458"/>
-                    <a:pt x="1974152" y="1735903"/>
-                    <a:pt x="1960445" y="1735903"/>
-                  </a:cubicBezTo>
-                  <a:lnTo>
-                    <a:pt x="51682" y="1735903"/>
-                  </a:lnTo>
-                  <a:cubicBezTo>
-                    <a:pt x="37975" y="1735903"/>
-                    <a:pt x="24829" y="1730458"/>
-                    <a:pt x="15137" y="1720766"/>
-                  </a:cubicBezTo>
-                  <a:cubicBezTo>
-                    <a:pt x="5445" y="1711074"/>
-                    <a:pt x="0" y="1697929"/>
-                    <a:pt x="0" y="1684222"/>
-                  </a:cubicBezTo>
-                  <a:lnTo>
-                    <a:pt x="0" y="51682"/>
-                  </a:lnTo>
-                  <a:cubicBezTo>
-                    <a:pt x="0" y="37975"/>
-                    <a:pt x="5445" y="24829"/>
-                    <a:pt x="15137" y="15137"/>
-                  </a:cubicBezTo>
-                  <a:cubicBezTo>
-                    <a:pt x="24829" y="5445"/>
-                    <a:pt x="37975" y="0"/>
-                    <a:pt x="51682" y="0"/>
-                  </a:cubicBezTo>
-                  <a:close/>
-                </a:path>
-              </a:pathLst>
-            </a:custGeom>
-            <a:solidFill>
-              <a:srgbClr val="DBE0ED"/>
-            </a:solidFill>
-          </p:spPr>
-          <p:txBody>
-            <a:bodyPr/>
-            <a:lstStyle/>
-            <a:p>
-              <a:endParaRPr lang="en-CA"/>
-            </a:p>
-          </p:txBody>
-        </p:sp>
-        <p:sp>
-          <p:nvSpPr>
-            <p:cNvPr id="9" name="TextBox 9"/>
-            <p:cNvSpPr txBox="1"/>
-            <p:nvPr/>
-          </p:nvSpPr>
-          <p:spPr>
-            <a:xfrm>
-              <a:off x="0" y="-38100"/>
-              <a:ext cx="2012127" cy="1774003"/>
-            </a:xfrm>
-            <a:prstGeom prst="rect">
-              <a:avLst/>
-            </a:prstGeom>
-          </p:spPr>
-          <p:txBody>
-            <a:bodyPr lIns="50800" tIns="50800" rIns="50800" bIns="50800" rtlCol="0" anchor="ctr"/>
-            <a:lstStyle/>
-            <a:p>
-              <a:pPr algn="ctr">
-                <a:lnSpc>
-                  <a:spcPts val="2659"/>
-                </a:lnSpc>
-                <a:spcBef>
-                  <a:spcPct val="0"/>
-                </a:spcBef>
-              </a:pPr>
-              <a:endParaRPr/>
-            </a:p>
-          </p:txBody>
-        </p:sp>
-      </p:grpSp>
-      <p:sp>
-        <p:nvSpPr>
-          <p:cNvPr id="10" name="Freeform 10"/>
-          <p:cNvSpPr/>
-          <p:nvPr/>
-        </p:nvSpPr>
-        <p:spPr>
-          <a:xfrm>
-            <a:off x="10317571" y="2943917"/>
-            <a:ext cx="10209770" cy="6401055"/>
-          </a:xfrm>
-          <a:custGeom>
-            <a:avLst/>
-            <a:gdLst/>
-            <a:ahLst/>
-            <a:cxnLst/>
-            <a:rect l="l" t="t" r="r" b="b"/>
-            <a:pathLst>
-              <a:path w="9893128" h="5564885">
-                <a:moveTo>
-                  <a:pt x="0" y="0"/>
-                </a:moveTo>
-                <a:lnTo>
-                  <a:pt x="9893128" y="0"/>
-                </a:lnTo>
-                <a:lnTo>
-                  <a:pt x="9893128" y="5564884"/>
-                </a:lnTo>
-                <a:lnTo>
-                  <a:pt x="0" y="5564884"/>
-                </a:lnTo>
-                <a:lnTo>
-                  <a:pt x="0" y="0"/>
-                </a:lnTo>
-                <a:close/>
-              </a:path>
-            </a:pathLst>
-          </a:custGeom>
-          <a:blipFill>
-            <a:blip r:embed="rId5"/>
-            <a:stretch>
-              <a:fillRect/>
-            </a:stretch>
-          </a:blipFill>
-          <a:ln cap="sq">
-            <a:noFill/>
-            <a:prstDash val="solid"/>
-            <a:miter/>
-          </a:ln>
-        </p:spPr>
-        <p:txBody>
-          <a:bodyPr/>
-          <a:lstStyle/>
-          <a:p>
-            <a:endParaRPr lang="en-CA"/>
-          </a:p>
-        </p:txBody>
-      </p:sp>
-      <p:sp>
-        <p:nvSpPr>
-          <p:cNvPr id="11" name="TextBox 11"/>
-          <p:cNvSpPr txBox="1"/>
-          <p:nvPr/>
-        </p:nvSpPr>
-        <p:spPr>
-          <a:xfrm>
-            <a:off x="2514600" y="695855"/>
-            <a:ext cx="13798211" cy="1284605"/>
-          </a:xfrm>
-          <a:prstGeom prst="rect">
-            <a:avLst/>
-          </a:prstGeom>
-        </p:spPr>
-        <p:txBody>
-          <a:bodyPr lIns="0" tIns="0" rIns="0" bIns="0" rtlCol="0" anchor="t">
-            <a:spAutoFit/>
-          </a:bodyPr>
-          <a:lstStyle/>
-          <a:p>
-            <a:pPr algn="ctr">
-              <a:lnSpc>
-                <a:spcPts val="8560"/>
-              </a:lnSpc>
-            </a:pPr>
-            <a:r>
-              <a:rPr lang="en-US" sz="8000" b="1" dirty="0">
-                <a:solidFill>
-                  <a:srgbClr val="000000"/>
-                </a:solidFill>
-                <a:latin typeface="Alegreya Sans SC Bold"/>
-                <a:ea typeface="Alegreya Sans SC Bold"/>
-                <a:cs typeface="Alegreya Sans SC Bold"/>
-                <a:sym typeface="Alegreya Sans SC Bold"/>
-              </a:rPr>
-              <a:t>RSA Encryption</a:t>
-            </a:r>
-          </a:p>
-        </p:txBody>
-      </p:sp>
-      <p:sp>
-        <p:nvSpPr>
-          <p:cNvPr id="12" name="TextBox 12"/>
-          <p:cNvSpPr txBox="1"/>
-          <p:nvPr/>
-        </p:nvSpPr>
-        <p:spPr>
-          <a:xfrm>
-            <a:off x="1828800" y="2989619"/>
-            <a:ext cx="7873345" cy="6496137"/>
-          </a:xfrm>
-          <a:prstGeom prst="rect">
-            <a:avLst/>
-          </a:prstGeom>
-        </p:spPr>
-        <p:txBody>
-          <a:bodyPr lIns="0" tIns="0" rIns="0" bIns="0" rtlCol="0" anchor="t">
-            <a:spAutoFit/>
-          </a:bodyPr>
-          <a:lstStyle/>
-          <a:p>
-            <a:pPr algn="l">
-              <a:lnSpc>
-                <a:spcPts val="3388"/>
-              </a:lnSpc>
-            </a:pPr>
-            <a:r>
-              <a:rPr lang="en-US" sz="2200" dirty="0">
-                <a:solidFill>
-                  <a:srgbClr val="000000"/>
-                </a:solidFill>
-                <a:latin typeface="Aileron"/>
-                <a:ea typeface="Aileron"/>
-                <a:cs typeface="Aileron"/>
-                <a:sym typeface="Aileron"/>
-              </a:rPr>
-              <a:t>RSA encryption is still wildly used across the internet.</a:t>
-            </a:r>
-          </a:p>
-          <a:p>
-            <a:pPr algn="l">
-              <a:lnSpc>
-                <a:spcPts val="3388"/>
-              </a:lnSpc>
-            </a:pPr>
-            <a:r>
-              <a:rPr lang="en-US" sz="2200" dirty="0">
-                <a:solidFill>
-                  <a:srgbClr val="000000"/>
-                </a:solidFill>
-                <a:latin typeface="Aileron"/>
-                <a:ea typeface="Aileron"/>
-                <a:cs typeface="Aileron"/>
-                <a:sym typeface="Aileron"/>
-              </a:rPr>
-              <a:t>Specially in TLS/SSL, and SSH certificates.</a:t>
-            </a:r>
-          </a:p>
-          <a:p>
-            <a:pPr algn="l">
-              <a:lnSpc>
-                <a:spcPts val="3388"/>
-              </a:lnSpc>
-            </a:pPr>
-            <a:endParaRPr lang="en-US" sz="2200" dirty="0">
-              <a:solidFill>
-                <a:srgbClr val="000000"/>
-              </a:solidFill>
-              <a:latin typeface="Aileron"/>
-              <a:ea typeface="Aileron"/>
-              <a:cs typeface="Aileron"/>
-              <a:sym typeface="Aileron"/>
-            </a:endParaRPr>
-          </a:p>
-          <a:p>
-            <a:pPr algn="l">
-              <a:lnSpc>
-                <a:spcPts val="3388"/>
-              </a:lnSpc>
-            </a:pPr>
-            <a:r>
-              <a:rPr lang="en-US" sz="2200" dirty="0">
-                <a:solidFill>
-                  <a:srgbClr val="000000"/>
-                </a:solidFill>
-                <a:latin typeface="Aileron"/>
-                <a:ea typeface="Aileron"/>
-                <a:cs typeface="Aileron"/>
-                <a:sym typeface="Aileron"/>
-              </a:rPr>
-              <a:t>They:</a:t>
-            </a:r>
-          </a:p>
-          <a:p>
-            <a:pPr algn="l">
-              <a:lnSpc>
-                <a:spcPts val="3388"/>
-              </a:lnSpc>
-            </a:pPr>
-            <a:r>
-              <a:rPr lang="en-US" sz="2200" dirty="0">
-                <a:solidFill>
-                  <a:srgbClr val="000000"/>
-                </a:solidFill>
-                <a:latin typeface="Aileron"/>
-                <a:ea typeface="Aileron"/>
-                <a:cs typeface="Aileron"/>
-                <a:sym typeface="Aileron"/>
-              </a:rPr>
-              <a:t>•Offer secure connection between client and server</a:t>
-            </a:r>
-          </a:p>
-          <a:p>
-            <a:pPr algn="l">
-              <a:lnSpc>
-                <a:spcPts val="3388"/>
-              </a:lnSpc>
-            </a:pPr>
-            <a:r>
-              <a:rPr lang="en-US" sz="2200" dirty="0">
-                <a:solidFill>
-                  <a:srgbClr val="000000"/>
-                </a:solidFill>
-                <a:latin typeface="Aileron"/>
-                <a:ea typeface="Aileron"/>
-                <a:cs typeface="Aileron"/>
-                <a:sym typeface="Aileron"/>
-              </a:rPr>
-              <a:t>•Still considered secure by today’s standards</a:t>
-            </a:r>
-          </a:p>
-          <a:p>
-            <a:pPr algn="l">
-              <a:lnSpc>
-                <a:spcPts val="3388"/>
-              </a:lnSpc>
-            </a:pPr>
-            <a:endParaRPr lang="en-US" sz="2200" dirty="0">
-              <a:solidFill>
-                <a:srgbClr val="000000"/>
-              </a:solidFill>
-              <a:latin typeface="Aileron"/>
-              <a:ea typeface="Aileron"/>
-              <a:cs typeface="Aileron"/>
-              <a:sym typeface="Aileron"/>
-            </a:endParaRPr>
-          </a:p>
-          <a:p>
-            <a:pPr algn="l">
-              <a:lnSpc>
-                <a:spcPts val="3388"/>
-              </a:lnSpc>
-            </a:pPr>
-            <a:r>
-              <a:rPr lang="en-US" sz="2200" dirty="0">
-                <a:solidFill>
-                  <a:srgbClr val="000000"/>
-                </a:solidFill>
-                <a:latin typeface="Aileron"/>
-                <a:ea typeface="Aileron"/>
-                <a:cs typeface="Aileron"/>
-                <a:sym typeface="Aileron"/>
-              </a:rPr>
-              <a:t>The National Institute of Standards and Technology is preparing to switch from RSA encryption by 2030.</a:t>
-            </a:r>
-          </a:p>
-          <a:p>
-            <a:pPr algn="l">
-              <a:lnSpc>
-                <a:spcPts val="3388"/>
-              </a:lnSpc>
-            </a:pPr>
-            <a:r>
-              <a:rPr lang="en-US" sz="2200" dirty="0">
-                <a:solidFill>
-                  <a:srgbClr val="000000"/>
-                </a:solidFill>
-                <a:latin typeface="Aileron"/>
-                <a:ea typeface="Aileron"/>
-                <a:cs typeface="Aileron"/>
-                <a:sym typeface="Aileron"/>
-              </a:rPr>
-              <a:t>The main concern is quantum computers cracking RSA’s algorithm easily.</a:t>
-            </a:r>
-          </a:p>
-          <a:p>
-            <a:pPr algn="l">
-              <a:lnSpc>
-                <a:spcPts val="3388"/>
-              </a:lnSpc>
-            </a:pPr>
-            <a:endParaRPr lang="en-US" sz="2200" dirty="0">
-              <a:solidFill>
-                <a:srgbClr val="000000"/>
-              </a:solidFill>
-              <a:latin typeface="Aileron"/>
-              <a:ea typeface="Aileron"/>
-              <a:cs typeface="Aileron"/>
-              <a:sym typeface="Aileron"/>
-            </a:endParaRPr>
-          </a:p>
-          <a:p>
-            <a:pPr algn="l">
-              <a:lnSpc>
-                <a:spcPts val="3388"/>
-              </a:lnSpc>
-            </a:pPr>
-            <a:r>
-              <a:rPr lang="en-US" sz="2200" dirty="0">
-                <a:solidFill>
-                  <a:srgbClr val="000000"/>
-                </a:solidFill>
-                <a:latin typeface="Aileron"/>
-                <a:ea typeface="Aileron"/>
-                <a:cs typeface="Aileron"/>
-                <a:sym typeface="Aileron"/>
-              </a:rPr>
-              <a:t>Companies are already switching towards post-quantum cryptography to stay ahead of bad actors.</a:t>
-            </a:r>
-          </a:p>
-          <a:p>
-            <a:pPr algn="l">
-              <a:lnSpc>
-                <a:spcPts val="3388"/>
-              </a:lnSpc>
-            </a:pPr>
-            <a:endParaRPr lang="en-US" sz="2200" dirty="0">
-              <a:solidFill>
-                <a:srgbClr val="000000"/>
-              </a:solidFill>
-              <a:latin typeface="Aileron"/>
-              <a:ea typeface="Aileron"/>
-              <a:cs typeface="Aileron"/>
-              <a:sym typeface="Aileron"/>
-            </a:endParaRPr>
-          </a:p>
-        </p:txBody>
-      </p:sp>
-      <p:sp>
-        <p:nvSpPr>
-          <p:cNvPr id="13" name="TextBox 13"/>
-          <p:cNvSpPr txBox="1"/>
-          <p:nvPr/>
-        </p:nvSpPr>
-        <p:spPr>
-          <a:xfrm>
-            <a:off x="4617742" y="1447909"/>
-            <a:ext cx="10209770" cy="1162050"/>
-          </a:xfrm>
-          <a:prstGeom prst="rect">
-            <a:avLst/>
-          </a:prstGeom>
-        </p:spPr>
-        <p:txBody>
-          <a:bodyPr lIns="0" tIns="0" rIns="0" bIns="0" rtlCol="0" anchor="t">
-            <a:spAutoFit/>
-          </a:bodyPr>
-          <a:lstStyle/>
-          <a:p>
-            <a:pPr algn="ctr">
-              <a:lnSpc>
-                <a:spcPts val="8400"/>
-              </a:lnSpc>
-              <a:spcBef>
-                <a:spcPct val="0"/>
-              </a:spcBef>
-            </a:pPr>
-            <a:r>
-              <a:rPr lang="en-US" sz="6000" dirty="0">
-                <a:solidFill>
-                  <a:srgbClr val="545454"/>
-                </a:solidFill>
-                <a:latin typeface="Alegreya Sans SC"/>
-                <a:ea typeface="Alegreya Sans SC"/>
-                <a:cs typeface="Alegreya Sans SC"/>
-                <a:sym typeface="Alegreya Sans SC"/>
-              </a:rPr>
-              <a:t>The Future</a:t>
             </a:r>
           </a:p>
         </p:txBody>
@@ -8233,258 +8012,16 @@
           </a:p>
         </p:txBody>
       </p:sp>
-      <p:grpSp>
-        <p:nvGrpSpPr>
-          <p:cNvPr id="7" name="Group 7"/>
-          <p:cNvGrpSpPr/>
-          <p:nvPr/>
-        </p:nvGrpSpPr>
-        <p:grpSpPr>
-          <a:xfrm>
-            <a:off x="10679784" y="2832309"/>
-            <a:ext cx="8921616" cy="5924665"/>
-            <a:chOff x="0" y="0"/>
-            <a:chExt cx="2349726" cy="1560406"/>
-          </a:xfrm>
-        </p:grpSpPr>
-        <p:sp>
-          <p:nvSpPr>
-            <p:cNvPr id="8" name="Freeform 8"/>
-            <p:cNvSpPr/>
-            <p:nvPr/>
-          </p:nvSpPr>
-          <p:spPr>
-            <a:xfrm>
-              <a:off x="0" y="0"/>
-              <a:ext cx="2349726" cy="1560406"/>
-            </a:xfrm>
-            <a:custGeom>
-              <a:avLst/>
-              <a:gdLst/>
-              <a:ahLst/>
-              <a:cxnLst/>
-              <a:rect l="l" t="t" r="r" b="b"/>
-              <a:pathLst>
-                <a:path w="2349726" h="1560406">
-                  <a:moveTo>
-                    <a:pt x="44256" y="0"/>
-                  </a:moveTo>
-                  <a:lnTo>
-                    <a:pt x="2305470" y="0"/>
-                  </a:lnTo>
-                  <a:cubicBezTo>
-                    <a:pt x="2317207" y="0"/>
-                    <a:pt x="2328464" y="4663"/>
-                    <a:pt x="2336764" y="12962"/>
-                  </a:cubicBezTo>
-                  <a:cubicBezTo>
-                    <a:pt x="2345063" y="21262"/>
-                    <a:pt x="2349726" y="32519"/>
-                    <a:pt x="2349726" y="44256"/>
-                  </a:cubicBezTo>
-                  <a:lnTo>
-                    <a:pt x="2349726" y="1516149"/>
-                  </a:lnTo>
-                  <a:cubicBezTo>
-                    <a:pt x="2349726" y="1527887"/>
-                    <a:pt x="2345063" y="1539144"/>
-                    <a:pt x="2336764" y="1547443"/>
-                  </a:cubicBezTo>
-                  <a:cubicBezTo>
-                    <a:pt x="2328464" y="1555743"/>
-                    <a:pt x="2317207" y="1560406"/>
-                    <a:pt x="2305470" y="1560406"/>
-                  </a:cubicBezTo>
-                  <a:lnTo>
-                    <a:pt x="44256" y="1560406"/>
-                  </a:lnTo>
-                  <a:cubicBezTo>
-                    <a:pt x="32519" y="1560406"/>
-                    <a:pt x="21262" y="1555743"/>
-                    <a:pt x="12962" y="1547443"/>
-                  </a:cubicBezTo>
-                  <a:cubicBezTo>
-                    <a:pt x="4663" y="1539144"/>
-                    <a:pt x="0" y="1527887"/>
-                    <a:pt x="0" y="1516149"/>
-                  </a:cubicBezTo>
-                  <a:lnTo>
-                    <a:pt x="0" y="44256"/>
-                  </a:lnTo>
-                  <a:cubicBezTo>
-                    <a:pt x="0" y="32519"/>
-                    <a:pt x="4663" y="21262"/>
-                    <a:pt x="12962" y="12962"/>
-                  </a:cubicBezTo>
-                  <a:cubicBezTo>
-                    <a:pt x="21262" y="4663"/>
-                    <a:pt x="32519" y="0"/>
-                    <a:pt x="44256" y="0"/>
-                  </a:cubicBezTo>
-                  <a:close/>
-                </a:path>
-              </a:pathLst>
-            </a:custGeom>
-            <a:solidFill>
-              <a:srgbClr val="DBE0ED"/>
-            </a:solidFill>
-          </p:spPr>
-          <p:txBody>
-            <a:bodyPr/>
-            <a:lstStyle/>
-            <a:p>
-              <a:endParaRPr lang="en-CA"/>
-            </a:p>
-          </p:txBody>
-        </p:sp>
-        <p:sp>
-          <p:nvSpPr>
-            <p:cNvPr id="9" name="TextBox 9"/>
-            <p:cNvSpPr txBox="1"/>
-            <p:nvPr/>
-          </p:nvSpPr>
-          <p:spPr>
-            <a:xfrm>
-              <a:off x="0" y="-38100"/>
-              <a:ext cx="2349726" cy="1598506"/>
-            </a:xfrm>
-            <a:prstGeom prst="rect">
-              <a:avLst/>
-            </a:prstGeom>
-          </p:spPr>
-          <p:txBody>
-            <a:bodyPr lIns="50800" tIns="50800" rIns="50800" bIns="50800" rtlCol="0" anchor="ctr"/>
-            <a:lstStyle/>
-            <a:p>
-              <a:pPr algn="ctr">
-                <a:lnSpc>
-                  <a:spcPts val="2659"/>
-                </a:lnSpc>
-                <a:spcBef>
-                  <a:spcPct val="0"/>
-                </a:spcBef>
-              </a:pPr>
-              <a:endParaRPr/>
-            </a:p>
-          </p:txBody>
-        </p:sp>
-      </p:grpSp>
-      <p:sp>
-        <p:nvSpPr>
-          <p:cNvPr id="10" name="Freeform 10"/>
-          <p:cNvSpPr/>
-          <p:nvPr/>
-        </p:nvSpPr>
-        <p:spPr>
-          <a:xfrm>
-            <a:off x="1851841" y="1674865"/>
-            <a:ext cx="6028958" cy="4268098"/>
-          </a:xfrm>
-          <a:custGeom>
-            <a:avLst/>
-            <a:gdLst/>
-            <a:ahLst/>
-            <a:cxnLst/>
-            <a:rect l="l" t="t" r="r" b="b"/>
-            <a:pathLst>
-              <a:path w="5669815" h="3734991">
-                <a:moveTo>
-                  <a:pt x="0" y="0"/>
-                </a:moveTo>
-                <a:lnTo>
-                  <a:pt x="5669815" y="0"/>
-                </a:lnTo>
-                <a:lnTo>
-                  <a:pt x="5669815" y="3734991"/>
-                </a:lnTo>
-                <a:lnTo>
-                  <a:pt x="0" y="3734991"/>
-                </a:lnTo>
-                <a:lnTo>
-                  <a:pt x="0" y="0"/>
-                </a:lnTo>
-                <a:close/>
-              </a:path>
-            </a:pathLst>
-          </a:custGeom>
-          <a:blipFill>
-            <a:blip r:embed="rId5"/>
-            <a:stretch>
-              <a:fillRect/>
-            </a:stretch>
-          </a:blipFill>
-        </p:spPr>
-        <p:txBody>
-          <a:bodyPr/>
-          <a:lstStyle/>
-          <a:p>
-            <a:endParaRPr lang="en-CA" dirty="0"/>
-          </a:p>
-        </p:txBody>
-      </p:sp>
-      <p:sp>
-        <p:nvSpPr>
-          <p:cNvPr id="11" name="Freeform 11"/>
-          <p:cNvSpPr/>
-          <p:nvPr/>
-        </p:nvSpPr>
-        <p:spPr>
-          <a:xfrm>
-            <a:off x="2435871" y="6313276"/>
-            <a:ext cx="7692079" cy="3734991"/>
-          </a:xfrm>
-          <a:custGeom>
-            <a:avLst/>
-            <a:gdLst/>
-            <a:ahLst/>
-            <a:cxnLst/>
-            <a:rect l="l" t="t" r="r" b="b"/>
-            <a:pathLst>
-              <a:path w="5974768" h="2987384">
-                <a:moveTo>
-                  <a:pt x="0" y="0"/>
-                </a:moveTo>
-                <a:lnTo>
-                  <a:pt x="5974768" y="0"/>
-                </a:lnTo>
-                <a:lnTo>
-                  <a:pt x="5974768" y="2987384"/>
-                </a:lnTo>
-                <a:lnTo>
-                  <a:pt x="0" y="2987384"/>
-                </a:lnTo>
-                <a:lnTo>
-                  <a:pt x="0" y="0"/>
-                </a:lnTo>
-                <a:close/>
-              </a:path>
-            </a:pathLst>
-          </a:custGeom>
-          <a:blipFill>
-            <a:blip r:embed="rId6"/>
-            <a:stretch>
-              <a:fillRect/>
-            </a:stretch>
-          </a:blipFill>
-        </p:spPr>
-        <p:txBody>
-          <a:bodyPr/>
-          <a:lstStyle/>
-          <a:p>
-            <a:endParaRPr lang="en-CA"/>
-          </a:p>
-        </p:txBody>
-      </p:sp>
-      <p:sp>
-        <p:nvSpPr>
-          <p:cNvPr id="12" name="TextBox 12"/>
+      <p:sp>
+        <p:nvSpPr>
+          <p:cNvPr id="11" name="TextBox 11"/>
           <p:cNvSpPr txBox="1"/>
           <p:nvPr/>
         </p:nvSpPr>
         <p:spPr>
           <a:xfrm>
-            <a:off x="7616363" y="450697"/>
-            <a:ext cx="5071252" cy="1284605"/>
+            <a:off x="2514600" y="695855"/>
+            <a:ext cx="13798211" cy="1284605"/>
           </a:xfrm>
           <a:prstGeom prst="rect">
             <a:avLst/>
@@ -8496,7 +8033,7 @@
           </a:bodyPr>
           <a:lstStyle/>
           <a:p>
-            <a:pPr algn="l">
+            <a:pPr algn="ctr">
               <a:lnSpc>
                 <a:spcPts val="8560"/>
               </a:lnSpc>
@@ -8511,7 +8048,7 @@
                 <a:cs typeface="Alegreya Sans SC Bold"/>
                 <a:sym typeface="Alegreya Sans SC Bold"/>
               </a:rPr>
-              <a:t>Closing Off</a:t>
+              <a:t>RSA Encryption</a:t>
             </a:r>
           </a:p>
         </p:txBody>
@@ -8524,8 +8061,8 @@
         </p:nvSpPr>
         <p:spPr>
           <a:xfrm>
-            <a:off x="10986984" y="2964219"/>
-            <a:ext cx="8274607" cy="5573268"/>
+            <a:off x="4617742" y="1447909"/>
+            <a:ext cx="10209770" cy="1162050"/>
           </a:xfrm>
           <a:prstGeom prst="rect">
             <a:avLst/>
@@ -8537,213 +8074,66 @@
           </a:bodyPr>
           <a:lstStyle/>
           <a:p>
-            <a:pPr algn="l">
+            <a:pPr algn="ctr">
               <a:lnSpc>
-                <a:spcPts val="3696"/>
+                <a:spcPts val="8400"/>
               </a:lnSpc>
+              <a:spcBef>
+                <a:spcPct val="0"/>
+              </a:spcBef>
             </a:pPr>
             <a:r>
-              <a:rPr lang="en-US" sz="2400" dirty="0">
-                <a:solidFill>
-                  <a:srgbClr val="000000"/>
-                </a:solidFill>
-                <a:latin typeface="Aileron"/>
-                <a:ea typeface="Aileron"/>
-                <a:cs typeface="Aileron"/>
-                <a:sym typeface="Aileron"/>
+              <a:rPr lang="en-US" sz="6000" dirty="0">
+                <a:solidFill>
+                  <a:srgbClr val="545454"/>
+                </a:solidFill>
+                <a:latin typeface="Alegreya Sans SC"/>
+                <a:ea typeface="Alegreya Sans SC"/>
+                <a:cs typeface="Alegreya Sans SC"/>
+                <a:sym typeface="Alegreya Sans SC"/>
               </a:rPr>
-              <a:t>This presentation was a quick run through of RSA encryption including:</a:t>
-            </a:r>
-          </a:p>
-          <a:p>
-            <a:pPr marL="518160" lvl="1" indent="-259080" algn="l">
-              <a:lnSpc>
-                <a:spcPts val="3696"/>
-              </a:lnSpc>
-              <a:buFont typeface="Arial"/>
-              <a:buChar char="•"/>
-            </a:pPr>
-            <a:r>
-              <a:rPr lang="en-US" sz="2400" dirty="0">
-                <a:solidFill>
-                  <a:srgbClr val="000000"/>
-                </a:solidFill>
-                <a:latin typeface="Aileron"/>
-                <a:ea typeface="Aileron"/>
-                <a:cs typeface="Aileron"/>
-                <a:sym typeface="Aileron"/>
-              </a:rPr>
-              <a:t>How they are made</a:t>
-            </a:r>
-          </a:p>
-          <a:p>
-            <a:pPr marL="518160" lvl="1" indent="-259080" algn="l">
-              <a:lnSpc>
-                <a:spcPts val="3696"/>
-              </a:lnSpc>
-              <a:buFont typeface="Arial"/>
-              <a:buChar char="•"/>
-            </a:pPr>
-            <a:r>
-              <a:rPr lang="en-US" sz="2400" dirty="0">
-                <a:solidFill>
-                  <a:srgbClr val="000000"/>
-                </a:solidFill>
-                <a:latin typeface="Aileron"/>
-                <a:ea typeface="Aileron"/>
-                <a:cs typeface="Aileron"/>
-                <a:sym typeface="Aileron"/>
-              </a:rPr>
-              <a:t>How they are used</a:t>
-            </a:r>
-          </a:p>
-          <a:p>
-            <a:pPr marL="518160" lvl="1" indent="-259080" algn="l">
-              <a:lnSpc>
-                <a:spcPts val="3696"/>
-              </a:lnSpc>
-              <a:buFont typeface="Arial"/>
-              <a:buChar char="•"/>
-            </a:pPr>
-            <a:r>
-              <a:rPr lang="en-US" sz="2400" dirty="0">
-                <a:solidFill>
-                  <a:srgbClr val="000000"/>
-                </a:solidFill>
-                <a:latin typeface="Aileron"/>
-                <a:ea typeface="Aileron"/>
-                <a:cs typeface="Aileron"/>
-                <a:sym typeface="Aileron"/>
-              </a:rPr>
-              <a:t>How it theoretically works</a:t>
-            </a:r>
-          </a:p>
-          <a:p>
-            <a:pPr marL="518160" lvl="1" indent="-259080" algn="l">
-              <a:lnSpc>
-                <a:spcPts val="3696"/>
-              </a:lnSpc>
-              <a:buFont typeface="Arial"/>
-              <a:buChar char="•"/>
-            </a:pPr>
-            <a:r>
-              <a:rPr lang="en-US" sz="2400" dirty="0">
-                <a:solidFill>
-                  <a:srgbClr val="000000"/>
-                </a:solidFill>
-                <a:latin typeface="Aileron"/>
-                <a:ea typeface="Aileron"/>
-                <a:cs typeface="Aileron"/>
-                <a:sym typeface="Aileron"/>
-              </a:rPr>
-              <a:t>RSA key generation</a:t>
-            </a:r>
-          </a:p>
-          <a:p>
-            <a:pPr marL="518160" lvl="1" indent="-259080" algn="l">
-              <a:lnSpc>
-                <a:spcPts val="3696"/>
-              </a:lnSpc>
-              <a:buFont typeface="Arial"/>
-              <a:buChar char="•"/>
-            </a:pPr>
-            <a:r>
-              <a:rPr lang="en-US" sz="2400" dirty="0">
-                <a:solidFill>
-                  <a:srgbClr val="000000"/>
-                </a:solidFill>
-                <a:latin typeface="Aileron"/>
-                <a:ea typeface="Aileron"/>
-                <a:cs typeface="Aileron"/>
-                <a:sym typeface="Aileron"/>
-              </a:rPr>
-              <a:t>Differences between public and private keys</a:t>
-            </a:r>
-          </a:p>
-          <a:p>
-            <a:pPr marL="518160" lvl="1" indent="-259080" algn="l">
-              <a:lnSpc>
-                <a:spcPts val="3696"/>
-              </a:lnSpc>
-              <a:buFont typeface="Arial"/>
-              <a:buChar char="•"/>
-            </a:pPr>
-            <a:r>
-              <a:rPr lang="en-US" sz="2400" dirty="0">
-                <a:solidFill>
-                  <a:srgbClr val="000000"/>
-                </a:solidFill>
-                <a:latin typeface="Aileron"/>
-                <a:ea typeface="Aileron"/>
-                <a:cs typeface="Aileron"/>
-                <a:sym typeface="Aileron"/>
-              </a:rPr>
-              <a:t>Practicality in the real world</a:t>
-            </a:r>
-          </a:p>
-          <a:p>
-            <a:pPr marL="518160" lvl="1" indent="-259080" algn="l">
-              <a:lnSpc>
-                <a:spcPts val="3696"/>
-              </a:lnSpc>
-              <a:buFont typeface="Arial"/>
-              <a:buChar char="•"/>
-            </a:pPr>
-            <a:r>
-              <a:rPr lang="en-US" sz="2400" dirty="0">
-                <a:solidFill>
-                  <a:srgbClr val="000000"/>
-                </a:solidFill>
-                <a:latin typeface="Aileron"/>
-                <a:ea typeface="Aileron"/>
-                <a:cs typeface="Aileron"/>
-                <a:sym typeface="Aileron"/>
-              </a:rPr>
-              <a:t>Where and how its most commonly used</a:t>
-            </a:r>
-          </a:p>
-          <a:p>
-            <a:pPr marL="518160" lvl="1" indent="-259080" algn="l">
-              <a:lnSpc>
-                <a:spcPts val="3696"/>
-              </a:lnSpc>
-              <a:buFont typeface="Arial"/>
-              <a:buChar char="•"/>
-            </a:pPr>
-            <a:r>
-              <a:rPr lang="en-US" sz="2400" dirty="0">
-                <a:solidFill>
-                  <a:srgbClr val="000000"/>
-                </a:solidFill>
-                <a:latin typeface="Aileron"/>
-                <a:ea typeface="Aileron"/>
-                <a:cs typeface="Aileron"/>
-                <a:sym typeface="Aileron"/>
-              </a:rPr>
-              <a:t>The future</a:t>
-            </a:r>
-          </a:p>
-          <a:p>
-            <a:pPr algn="l">
-              <a:lnSpc>
-                <a:spcPts val="3696"/>
-              </a:lnSpc>
-            </a:pPr>
-            <a:r>
-              <a:rPr lang="en-US" sz="2400" dirty="0">
-                <a:solidFill>
-                  <a:srgbClr val="000000"/>
-                </a:solidFill>
-                <a:latin typeface="Aileron"/>
-                <a:ea typeface="Aileron"/>
-                <a:cs typeface="Aileron"/>
-                <a:sym typeface="Aileron"/>
-              </a:rPr>
-              <a:t>Without these algorithms, any information would be easily interceptable for malicious usage no-matter the place.</a:t>
-            </a:r>
-          </a:p>
-        </p:txBody>
-      </p:sp>
+              <a:t>The Future</a:t>
+            </a:r>
+          </a:p>
+        </p:txBody>
+      </p:sp>
+      <p:pic>
+        <p:nvPicPr>
+          <p:cNvPr id="14" name="Picture 13" descr="Post-Quantum Cryptography Set to Replace RSA, ECC">
+            <a:extLst>
+              <a:ext uri="{FF2B5EF4-FFF2-40B4-BE49-F238E27FC236}">
+                <a16:creationId xmlns:a16="http://schemas.microsoft.com/office/drawing/2014/main" id="{F8385719-0BAB-FCB6-91E6-2CE2F67D8DA1}"/>
+              </a:ext>
+            </a:extLst>
+          </p:cNvPr>
+          <p:cNvPicPr>
+            <a:picLocks noChangeAspect="1"/>
+          </p:cNvPicPr>
+          <p:nvPr/>
+        </p:nvPicPr>
+        <p:blipFill>
+          <a:blip r:embed="rId5"/>
+          <a:stretch>
+            <a:fillRect/>
+          </a:stretch>
+        </p:blipFill>
+        <p:spPr>
+          <a:xfrm>
+            <a:off x="2060703" y="2544915"/>
+            <a:ext cx="16702175" cy="7046230"/>
+          </a:xfrm>
+          <a:prstGeom prst="rect">
+            <a:avLst/>
+          </a:prstGeom>
+          <a:effectLst>
+            <a:outerShdw blurRad="254000" dist="762000" dir="2400000" algn="ctr" rotWithShape="0">
+              <a:srgbClr val="000000">
+                <a:alpha val="40000"/>
+              </a:srgbClr>
+            </a:outerShdw>
+          </a:effectLst>
+        </p:spPr>
+      </p:pic>
     </p:spTree>
   </p:cSld>
   <p:clrMapOvr>
@@ -8776,6 +8166,406 @@
           <p:nvPr/>
         </p:nvSpPr>
         <p:spPr>
+          <a:xfrm rot="-5400000">
+            <a:off x="4557186" y="-5988665"/>
+            <a:ext cx="11718479" cy="20832852"/>
+          </a:xfrm>
+          <a:custGeom>
+            <a:avLst/>
+            <a:gdLst/>
+            <a:ahLst/>
+            <a:cxnLst/>
+            <a:rect l="l" t="t" r="r" b="b"/>
+            <a:pathLst>
+              <a:path w="11718479" h="20832852">
+                <a:moveTo>
+                  <a:pt x="0" y="0"/>
+                </a:moveTo>
+                <a:lnTo>
+                  <a:pt x="11718479" y="0"/>
+                </a:lnTo>
+                <a:lnTo>
+                  <a:pt x="11718479" y="20832851"/>
+                </a:lnTo>
+                <a:lnTo>
+                  <a:pt x="0" y="20832851"/>
+                </a:lnTo>
+                <a:lnTo>
+                  <a:pt x="0" y="0"/>
+                </a:lnTo>
+                <a:close/>
+              </a:path>
+            </a:pathLst>
+          </a:custGeom>
+          <a:blipFill>
+            <a:blip>
+              <a:extLst>
+                <a:ext uri="{96DAC541-7B7A-43D3-8B79-37D633B846F1}">
+                  <asvg:svgBlip xmlns:asvg="http://schemas.microsoft.com/office/drawing/2016/SVG/main" r:embed="rId2"/>
+                </a:ext>
+              </a:extLst>
+            </a:blip>
+            <a:stretch>
+              <a:fillRect/>
+            </a:stretch>
+          </a:blipFill>
+        </p:spPr>
+        <p:txBody>
+          <a:bodyPr/>
+          <a:lstStyle/>
+          <a:p>
+            <a:endParaRPr lang="en-CA"/>
+          </a:p>
+        </p:txBody>
+      </p:sp>
+      <p:sp>
+        <p:nvSpPr>
+          <p:cNvPr id="3" name="Freeform 3"/>
+          <p:cNvSpPr/>
+          <p:nvPr/>
+        </p:nvSpPr>
+        <p:spPr>
+          <a:xfrm flipV="1">
+            <a:off x="519025" y="396902"/>
+            <a:ext cx="2359274" cy="2359274"/>
+          </a:xfrm>
+          <a:custGeom>
+            <a:avLst/>
+            <a:gdLst/>
+            <a:ahLst/>
+            <a:cxnLst/>
+            <a:rect l="l" t="t" r="r" b="b"/>
+            <a:pathLst>
+              <a:path w="2359274" h="2359274">
+                <a:moveTo>
+                  <a:pt x="0" y="2359274"/>
+                </a:moveTo>
+                <a:lnTo>
+                  <a:pt x="2359274" y="2359274"/>
+                </a:lnTo>
+                <a:lnTo>
+                  <a:pt x="2359274" y="0"/>
+                </a:lnTo>
+                <a:lnTo>
+                  <a:pt x="0" y="0"/>
+                </a:lnTo>
+                <a:lnTo>
+                  <a:pt x="0" y="2359274"/>
+                </a:lnTo>
+                <a:close/>
+              </a:path>
+            </a:pathLst>
+          </a:custGeom>
+          <a:blipFill>
+            <a:blip>
+              <a:extLst>
+                <a:ext uri="{96DAC541-7B7A-43D3-8B79-37D633B846F1}">
+                  <asvg:svgBlip xmlns:asvg="http://schemas.microsoft.com/office/drawing/2016/SVG/main" r:embed="rId3"/>
+                </a:ext>
+              </a:extLst>
+            </a:blip>
+            <a:stretch>
+              <a:fillRect/>
+            </a:stretch>
+          </a:blipFill>
+        </p:spPr>
+        <p:txBody>
+          <a:bodyPr/>
+          <a:lstStyle/>
+          <a:p>
+            <a:endParaRPr lang="en-CA"/>
+          </a:p>
+        </p:txBody>
+      </p:sp>
+      <p:sp>
+        <p:nvSpPr>
+          <p:cNvPr id="4" name="Freeform 4"/>
+          <p:cNvSpPr/>
+          <p:nvPr/>
+        </p:nvSpPr>
+        <p:spPr>
+          <a:xfrm flipH="1">
+            <a:off x="15486600" y="7366014"/>
+            <a:ext cx="2359274" cy="2359274"/>
+          </a:xfrm>
+          <a:custGeom>
+            <a:avLst/>
+            <a:gdLst/>
+            <a:ahLst/>
+            <a:cxnLst/>
+            <a:rect l="l" t="t" r="r" b="b"/>
+            <a:pathLst>
+              <a:path w="2359274" h="2359274">
+                <a:moveTo>
+                  <a:pt x="2359274" y="0"/>
+                </a:moveTo>
+                <a:lnTo>
+                  <a:pt x="0" y="0"/>
+                </a:lnTo>
+                <a:lnTo>
+                  <a:pt x="0" y="2359274"/>
+                </a:lnTo>
+                <a:lnTo>
+                  <a:pt x="2359274" y="2359274"/>
+                </a:lnTo>
+                <a:lnTo>
+                  <a:pt x="2359274" y="0"/>
+                </a:lnTo>
+                <a:close/>
+              </a:path>
+            </a:pathLst>
+          </a:custGeom>
+          <a:blipFill>
+            <a:blip>
+              <a:extLst>
+                <a:ext uri="{96DAC541-7B7A-43D3-8B79-37D633B846F1}">
+                  <asvg:svgBlip xmlns:asvg="http://schemas.microsoft.com/office/drawing/2016/SVG/main" r:embed="rId3"/>
+                </a:ext>
+              </a:extLst>
+            </a:blip>
+            <a:stretch>
+              <a:fillRect/>
+            </a:stretch>
+          </a:blipFill>
+        </p:spPr>
+        <p:txBody>
+          <a:bodyPr/>
+          <a:lstStyle/>
+          <a:p>
+            <a:endParaRPr lang="en-CA"/>
+          </a:p>
+        </p:txBody>
+      </p:sp>
+      <p:sp>
+        <p:nvSpPr>
+          <p:cNvPr id="5" name="Freeform 5"/>
+          <p:cNvSpPr/>
+          <p:nvPr/>
+        </p:nvSpPr>
+        <p:spPr>
+          <a:xfrm>
+            <a:off x="15486600" y="396902"/>
+            <a:ext cx="4114800" cy="4114800"/>
+          </a:xfrm>
+          <a:custGeom>
+            <a:avLst/>
+            <a:gdLst/>
+            <a:ahLst/>
+            <a:cxnLst/>
+            <a:rect l="l" t="t" r="r" b="b"/>
+            <a:pathLst>
+              <a:path w="4114800" h="4114800">
+                <a:moveTo>
+                  <a:pt x="0" y="0"/>
+                </a:moveTo>
+                <a:lnTo>
+                  <a:pt x="4114800" y="0"/>
+                </a:lnTo>
+                <a:lnTo>
+                  <a:pt x="4114800" y="4114800"/>
+                </a:lnTo>
+                <a:lnTo>
+                  <a:pt x="0" y="4114800"/>
+                </a:lnTo>
+                <a:lnTo>
+                  <a:pt x="0" y="0"/>
+                </a:lnTo>
+                <a:close/>
+              </a:path>
+            </a:pathLst>
+          </a:custGeom>
+          <a:blipFill>
+            <a:blip>
+              <a:alphaModFix amt="24000"/>
+              <a:extLst>
+                <a:ext uri="{96DAC541-7B7A-43D3-8B79-37D633B846F1}">
+                  <asvg:svgBlip xmlns:asvg="http://schemas.microsoft.com/office/drawing/2016/SVG/main" r:embed="rId4"/>
+                </a:ext>
+              </a:extLst>
+            </a:blip>
+            <a:stretch>
+              <a:fillRect/>
+            </a:stretch>
+          </a:blipFill>
+        </p:spPr>
+        <p:txBody>
+          <a:bodyPr/>
+          <a:lstStyle/>
+          <a:p>
+            <a:endParaRPr lang="en-CA"/>
+          </a:p>
+        </p:txBody>
+      </p:sp>
+      <p:sp>
+        <p:nvSpPr>
+          <p:cNvPr id="6" name="Freeform 6"/>
+          <p:cNvSpPr/>
+          <p:nvPr/>
+        </p:nvSpPr>
+        <p:spPr>
+          <a:xfrm>
+            <a:off x="57095" y="7366014"/>
+            <a:ext cx="2693378" cy="2693378"/>
+          </a:xfrm>
+          <a:custGeom>
+            <a:avLst/>
+            <a:gdLst/>
+            <a:ahLst/>
+            <a:cxnLst/>
+            <a:rect l="l" t="t" r="r" b="b"/>
+            <a:pathLst>
+              <a:path w="2693378" h="2693378">
+                <a:moveTo>
+                  <a:pt x="0" y="0"/>
+                </a:moveTo>
+                <a:lnTo>
+                  <a:pt x="2693378" y="0"/>
+                </a:lnTo>
+                <a:lnTo>
+                  <a:pt x="2693378" y="2693378"/>
+                </a:lnTo>
+                <a:lnTo>
+                  <a:pt x="0" y="2693378"/>
+                </a:lnTo>
+                <a:lnTo>
+                  <a:pt x="0" y="0"/>
+                </a:lnTo>
+                <a:close/>
+              </a:path>
+            </a:pathLst>
+          </a:custGeom>
+          <a:blipFill>
+            <a:blip>
+              <a:alphaModFix amt="24000"/>
+              <a:extLst>
+                <a:ext uri="{96DAC541-7B7A-43D3-8B79-37D633B846F1}">
+                  <asvg:svgBlip xmlns:asvg="http://schemas.microsoft.com/office/drawing/2016/SVG/main" r:embed="rId4"/>
+                </a:ext>
+              </a:extLst>
+            </a:blip>
+            <a:stretch>
+              <a:fillRect/>
+            </a:stretch>
+          </a:blipFill>
+        </p:spPr>
+        <p:txBody>
+          <a:bodyPr/>
+          <a:lstStyle/>
+          <a:p>
+            <a:endParaRPr lang="en-CA"/>
+          </a:p>
+        </p:txBody>
+      </p:sp>
+      <p:sp>
+        <p:nvSpPr>
+          <p:cNvPr id="12" name="TextBox 12"/>
+          <p:cNvSpPr txBox="1"/>
+          <p:nvPr/>
+        </p:nvSpPr>
+        <p:spPr>
+          <a:xfrm>
+            <a:off x="7616363" y="450697"/>
+            <a:ext cx="5071252" cy="1284605"/>
+          </a:xfrm>
+          <a:prstGeom prst="rect">
+            <a:avLst/>
+          </a:prstGeom>
+        </p:spPr>
+        <p:txBody>
+          <a:bodyPr lIns="0" tIns="0" rIns="0" bIns="0" rtlCol="0" anchor="t">
+            <a:spAutoFit/>
+          </a:bodyPr>
+          <a:lstStyle/>
+          <a:p>
+            <a:pPr algn="l">
+              <a:lnSpc>
+                <a:spcPts val="8560"/>
+              </a:lnSpc>
+            </a:pPr>
+            <a:r>
+              <a:rPr lang="en-US" sz="8000" b="1" dirty="0">
+                <a:solidFill>
+                  <a:srgbClr val="000000"/>
+                </a:solidFill>
+                <a:latin typeface="Alegreya Sans SC Bold"/>
+                <a:ea typeface="Alegreya Sans SC Bold"/>
+                <a:cs typeface="Alegreya Sans SC Bold"/>
+                <a:sym typeface="Alegreya Sans SC Bold"/>
+              </a:rPr>
+              <a:t>Closing Off</a:t>
+            </a:r>
+          </a:p>
+        </p:txBody>
+      </p:sp>
+      <p:pic>
+        <p:nvPicPr>
+          <p:cNvPr id="14" name="Picture 13" descr="RSA Algorithm: Secure Your Data with Public-Key Encryption">
+            <a:extLst>
+              <a:ext uri="{FF2B5EF4-FFF2-40B4-BE49-F238E27FC236}">
+                <a16:creationId xmlns:a16="http://schemas.microsoft.com/office/drawing/2014/main" id="{CF3BE0D3-B24B-E4A8-A55E-68A7C7F69638}"/>
+              </a:ext>
+            </a:extLst>
+          </p:cNvPr>
+          <p:cNvPicPr>
+            <a:picLocks noChangeAspect="1"/>
+          </p:cNvPicPr>
+          <p:nvPr/>
+        </p:nvPicPr>
+        <p:blipFill>
+          <a:blip r:embed="rId5"/>
+          <a:stretch>
+            <a:fillRect/>
+          </a:stretch>
+        </p:blipFill>
+        <p:spPr>
+          <a:xfrm>
+            <a:off x="2310876" y="1997086"/>
+            <a:ext cx="16211098" cy="7226803"/>
+          </a:xfrm>
+          <a:prstGeom prst="rect">
+            <a:avLst/>
+          </a:prstGeom>
+          <a:effectLst>
+            <a:outerShdw blurRad="254000" dist="889000" dir="2400000" algn="ctr" rotWithShape="0">
+              <a:srgbClr val="000000">
+                <a:alpha val="40000"/>
+              </a:srgbClr>
+            </a:outerShdw>
+          </a:effectLst>
+        </p:spPr>
+      </p:pic>
+    </p:spTree>
+  </p:cSld>
+  <p:clrMapOvr>
+    <a:masterClrMapping/>
+  </p:clrMapOvr>
+</p:sld>
+</file>
+
+<file path=ppt/slides/slide9.xml><?xml version="1.0" encoding="utf-8"?>
+<p:sld xmlns:a="http://schemas.openxmlformats.org/drawingml/2006/main" xmlns:r="http://schemas.openxmlformats.org/officeDocument/2006/relationships" xmlns:p="http://schemas.openxmlformats.org/presentationml/2006/main">
+  <p:cSld>
+    <p:spTree>
+      <p:nvGrpSpPr>
+        <p:cNvPr id="1" name=""/>
+        <p:cNvGrpSpPr/>
+        <p:nvPr/>
+      </p:nvGrpSpPr>
+      <p:grpSpPr>
+        <a:xfrm>
+          <a:off x="0" y="0"/>
+          <a:ext cx="0" cy="0"/>
+          <a:chOff x="0" y="0"/>
+          <a:chExt cx="0" cy="0"/>
+        </a:xfrm>
+      </p:grpSpPr>
+      <p:sp>
+        <p:nvSpPr>
+          <p:cNvPr id="2" name="Freeform 2"/>
+          <p:cNvSpPr/>
+          <p:nvPr/>
+        </p:nvSpPr>
+        <p:spPr>
           <a:xfrm flipV="1">
             <a:off x="519025" y="396902"/>
             <a:ext cx="2359274" cy="2359274"/>
@@ -8996,57 +8786,20 @@
         </p:nvSpPr>
         <p:spPr>
           <a:xfrm>
-            <a:off x="259595" y="3878705"/>
-            <a:ext cx="14929577" cy="6211824"/>
+            <a:off x="689425" y="3564037"/>
+            <a:ext cx="14797175" cy="6001643"/>
           </a:xfrm>
           <a:prstGeom prst="rect">
             <a:avLst/>
           </a:prstGeom>
         </p:spPr>
         <p:txBody>
-          <a:bodyPr lIns="0" tIns="0" rIns="0" bIns="0" rtlCol="0" anchor="t">
+          <a:bodyPr wrap="square" lIns="0" tIns="0" rIns="0" bIns="0" rtlCol="0" anchor="t">
             <a:spAutoFit/>
           </a:bodyPr>
           <a:lstStyle/>
           <a:p>
-            <a:pPr marL="518160" lvl="1" indent="-259080" algn="l">
-              <a:lnSpc>
-                <a:spcPts val="2568"/>
-              </a:lnSpc>
-              <a:spcBef>
-                <a:spcPct val="0"/>
-              </a:spcBef>
-              <a:buFont typeface="Arial"/>
-              <a:buChar char="•"/>
-            </a:pPr>
-            <a:r>
-              <a:rPr lang="en-US" sz="2400">
-                <a:solidFill>
-                  <a:srgbClr val="000000"/>
-                </a:solidFill>
-                <a:latin typeface="Alegreya Sans SC"/>
-                <a:ea typeface="Alegreya Sans SC"/>
-                <a:cs typeface="Alegreya Sans SC"/>
-                <a:sym typeface="Alegreya Sans SC"/>
-              </a:rPr>
-              <a:t>•David Ireland, DI Management Services Pty Limited, Australia, www.di-mgt.com.au. (n.d.). RSA Algorithm. Copyright (C) 2002-25 DI Management Services Pty Limited ABN 78 083 210 584 All Rights Reserved. </a:t>
-            </a:r>
-            <a:r>
-              <a:rPr lang="en-US" sz="2400" u="sng">
-                <a:solidFill>
-                  <a:srgbClr val="1800AD"/>
-                </a:solidFill>
-                <a:latin typeface="Alegreya Sans SC"/>
-                <a:ea typeface="Alegreya Sans SC"/>
-                <a:cs typeface="Alegreya Sans SC"/>
-                <a:sym typeface="Alegreya Sans SC"/>
-                <a:hlinkClick r:id="rId4" tooltip="https://di-mgt.com.au/rsa_alg.html"/>
-              </a:rPr>
-              <a:t>https://di-mgt.com.au/rsa_alg.html</a:t>
-            </a:r>
-          </a:p>
-          <a:p>
-            <a:pPr algn="l">
+            <a:pPr marL="259080" lvl="1" indent="-457200" algn="l">
               <a:lnSpc>
                 <a:spcPts val="2568"/>
               </a:lnSpc>
@@ -9054,56 +8807,34 @@
                 <a:spcPct val="0"/>
               </a:spcBef>
             </a:pPr>
-            <a:endParaRPr lang="en-US" sz="2400" u="sng">
-              <a:solidFill>
-                <a:srgbClr val="1800AD"/>
-              </a:solidFill>
-              <a:latin typeface="Alegreya Sans SC"/>
-              <a:ea typeface="Alegreya Sans SC"/>
-              <a:cs typeface="Alegreya Sans SC"/>
-              <a:sym typeface="Alegreya Sans SC"/>
-              <a:hlinkClick r:id="rId4" tooltip="https://di-mgt.com.au/rsa_alg.html"/>
-            </a:endParaRPr>
-          </a:p>
-          <a:p>
-            <a:pPr marL="518160" lvl="1" indent="-259080" algn="l">
-              <a:lnSpc>
-                <a:spcPts val="2568"/>
-              </a:lnSpc>
-              <a:spcBef>
-                <a:spcPct val="0"/>
-              </a:spcBef>
-              <a:buFont typeface="Arial"/>
-              <a:buChar char="•"/>
-            </a:pPr>
-            <a:r>
-              <a:rPr lang="en-US" sz="2400">
+            <a:r>
+              <a:rPr lang="en-US" sz="2400" dirty="0">
                 <a:solidFill>
                   <a:srgbClr val="000000"/>
                 </a:solidFill>
-                <a:latin typeface="Alegreya Sans SC"/>
+                <a:latin typeface="Candara" panose="020E0502030303020204" pitchFamily="34" charset="0"/>
                 <a:ea typeface="Alegreya Sans SC"/>
                 <a:cs typeface="Alegreya Sans SC"/>
                 <a:sym typeface="Alegreya Sans SC"/>
               </a:rPr>
-              <a:t>•GeeksforGeeks. (2025, July 23). RSA algorithm in cryptography. GeeksforGeeks.</a:t>
-            </a:r>
-            <a:r>
-              <a:rPr lang="en-US" sz="2400" u="sng">
+              <a:t>David Ireland, DI Management Services Pty Limited, Australia, www.di-mgt.com.au. (n.d.). RSA Algorithm. Copyright (C) 2002-25 DI Management Services Pty Limited ABN 78 083 210 584 All Rights Reserved. </a:t>
+            </a:r>
+            <a:r>
+              <a:rPr lang="en-US" sz="2400" u="sng" dirty="0">
                 <a:solidFill>
                   <a:srgbClr val="1800AD"/>
                 </a:solidFill>
-                <a:latin typeface="Alegreya Sans SC"/>
+                <a:latin typeface="Candara" panose="020E0502030303020204" pitchFamily="34" charset="0"/>
                 <a:ea typeface="Alegreya Sans SC"/>
                 <a:cs typeface="Alegreya Sans SC"/>
                 <a:sym typeface="Alegreya Sans SC"/>
-                <a:hlinkClick r:id="rId5" tooltip="https://www.geeksforgeeks.org/computer-networks/rsa-algorithm-cryptography/"/>
+                <a:hlinkClick r:id="rId4" tooltip="https://di-mgt.com.au/rsa_alg.html"/>
               </a:rPr>
-              <a:t>https://www.geeksforgeeks.org/computer-networks/rsa-algorithm-cryptography/</a:t>
-            </a:r>
-          </a:p>
-          <a:p>
-            <a:pPr algn="l">
+              <a:t>https://di-mgt.com.au/rsa_alg.html</a:t>
+            </a:r>
+          </a:p>
+          <a:p>
+            <a:pPr indent="-457200" algn="l">
               <a:lnSpc>
                 <a:spcPts val="2568"/>
               </a:lnSpc>
@@ -9111,56 +8842,19 @@
                 <a:spcPct val="0"/>
               </a:spcBef>
             </a:pPr>
-            <a:endParaRPr lang="en-US" sz="2400" u="sng">
+            <a:endParaRPr lang="en-US" sz="2400" u="sng" dirty="0">
               <a:solidFill>
                 <a:srgbClr val="1800AD"/>
               </a:solidFill>
-              <a:latin typeface="Alegreya Sans SC"/>
+              <a:latin typeface="Candara" panose="020E0502030303020204" pitchFamily="34" charset="0"/>
               <a:ea typeface="Alegreya Sans SC"/>
               <a:cs typeface="Alegreya Sans SC"/>
               <a:sym typeface="Alegreya Sans SC"/>
-              <a:hlinkClick r:id="rId5" tooltip="https://www.geeksforgeeks.org/computer-networks/rsa-algorithm-cryptography/"/>
+              <a:hlinkClick r:id="rId4" tooltip="https://di-mgt.com.au/rsa_alg.html"/>
             </a:endParaRPr>
           </a:p>
           <a:p>
-            <a:pPr marL="518160" lvl="1" indent="-259080" algn="l">
-              <a:lnSpc>
-                <a:spcPts val="2568"/>
-              </a:lnSpc>
-              <a:spcBef>
-                <a:spcPct val="0"/>
-              </a:spcBef>
-              <a:buFont typeface="Arial"/>
-              <a:buChar char="•"/>
-            </a:pPr>
-            <a:r>
-              <a:rPr lang="en-US" sz="2400">
-                <a:solidFill>
-                  <a:srgbClr val="000000"/>
-                </a:solidFill>
-                <a:latin typeface="Alegreya Sans SC"/>
-                <a:ea typeface="Alegreya Sans SC"/>
-                <a:cs typeface="Alegreya Sans SC"/>
-                <a:sym typeface="Alegreya Sans SC"/>
-              </a:rPr>
-              <a:t>•Lebeaux, B., &amp; Lebeaux, B. (2026, September 17). Setting the record straight on quantum computing and RSA encryption. RSA. </a:t>
-            </a:r>
-            <a:r>
-              <a:rPr lang="en-US" sz="2400" u="sng">
-                <a:solidFill>
-                  <a:srgbClr val="1800AD"/>
-                </a:solidFill>
-                <a:latin typeface="Alegreya Sans SC"/>
-                <a:ea typeface="Alegreya Sans SC"/>
-                <a:cs typeface="Alegreya Sans SC"/>
-                <a:sym typeface="Alegreya Sans SC"/>
-                <a:hlinkClick r:id="rId6" tooltip="https://www.rsa.com/resources/blog/zero-trust/setting-the-record-straight-on-quantum-computing-and-rsa-encryption/"/>
-              </a:rPr>
-              <a:t>https://www.rsa.com/resources/blog/zero-trust/setting-the-record-straight-on- quantum- computing-and-rsa-encryption/</a:t>
-            </a:r>
-          </a:p>
-          <a:p>
-            <a:pPr algn="l">
+            <a:pPr marL="259080" lvl="1" indent="-457200" algn="l">
               <a:lnSpc>
                 <a:spcPts val="2568"/>
               </a:lnSpc>
@@ -9168,56 +8862,71 @@
                 <a:spcPct val="0"/>
               </a:spcBef>
             </a:pPr>
-            <a:endParaRPr lang="en-US" sz="2400" u="sng">
-              <a:solidFill>
-                <a:srgbClr val="1800AD"/>
-              </a:solidFill>
-              <a:latin typeface="Alegreya Sans SC"/>
-              <a:ea typeface="Alegreya Sans SC"/>
-              <a:cs typeface="Alegreya Sans SC"/>
-              <a:sym typeface="Alegreya Sans SC"/>
-              <a:hlinkClick r:id="rId6" tooltip="https://www.rsa.com/resources/blog/zero-trust/setting-the-record-straight-on-quantum-computing-and-rsa-encryption/"/>
-            </a:endParaRPr>
-          </a:p>
-          <a:p>
-            <a:pPr marL="518160" lvl="1" indent="-259080" algn="l">
-              <a:lnSpc>
-                <a:spcPts val="2568"/>
-              </a:lnSpc>
-              <a:spcBef>
-                <a:spcPct val="0"/>
-              </a:spcBef>
-              <a:buFont typeface="Arial"/>
-              <a:buChar char="•"/>
-            </a:pPr>
-            <a:r>
-              <a:rPr lang="en-US" sz="2400">
+            <a:r>
+              <a:rPr lang="en-US" sz="2400" dirty="0" err="1">
                 <a:solidFill>
                   <a:srgbClr val="000000"/>
                 </a:solidFill>
-                <a:latin typeface="Alegreya Sans SC"/>
+                <a:latin typeface="Candara" panose="020E0502030303020204" pitchFamily="34" charset="0"/>
                 <a:ea typeface="Alegreya Sans SC"/>
                 <a:cs typeface="Alegreya Sans SC"/>
                 <a:sym typeface="Alegreya Sans SC"/>
               </a:rPr>
-              <a:t>•RSA Community. (n.d.). </a:t>
-            </a:r>
-            <a:r>
-              <a:rPr lang="en-US" sz="2400" u="sng">
-                <a:solidFill>
-                  <a:srgbClr val="1800AD"/>
-                </a:solidFill>
-                <a:latin typeface="Alegreya Sans SC"/>
+              <a:t>GeeksforGeeks</a:t>
+            </a:r>
+            <a:r>
+              <a:rPr lang="en-US" sz="2400" dirty="0">
+                <a:solidFill>
+                  <a:srgbClr val="000000"/>
+                </a:solidFill>
+                <a:latin typeface="Candara" panose="020E0502030303020204" pitchFamily="34" charset="0"/>
                 <a:ea typeface="Alegreya Sans SC"/>
                 <a:cs typeface="Alegreya Sans SC"/>
                 <a:sym typeface="Alegreya Sans SC"/>
-                <a:hlinkClick r:id="rId7" tooltip="https://community.rsa.com/s/article/RSA-cryptography-and-NIST-guidance"/>
               </a:rPr>
-              <a:t>https://community.rsa.com/s/article/RSA-cryptography-and-NIST-guidance</a:t>
-            </a:r>
-          </a:p>
-          <a:p>
-            <a:pPr algn="l">
+              <a:t>. (2025, July 23). RSA algorithm in cryptography. </a:t>
+            </a:r>
+            <a:r>
+              <a:rPr lang="en-US" sz="2400" dirty="0" err="1">
+                <a:solidFill>
+                  <a:srgbClr val="000000"/>
+                </a:solidFill>
+                <a:latin typeface="Candara" panose="020E0502030303020204" pitchFamily="34" charset="0"/>
+                <a:ea typeface="Alegreya Sans SC"/>
+                <a:cs typeface="Alegreya Sans SC"/>
+                <a:sym typeface="Alegreya Sans SC"/>
+              </a:rPr>
+              <a:t>GeeksforGeeks.</a:t>
+            </a:r>
+            <a:r>
+              <a:rPr lang="en-US" sz="2400" u="sng" dirty="0" err="1">
+                <a:solidFill>
+                  <a:srgbClr val="1800AD"/>
+                </a:solidFill>
+                <a:latin typeface="Candara" panose="020E0502030303020204" pitchFamily="34" charset="0"/>
+                <a:ea typeface="Alegreya Sans SC"/>
+                <a:cs typeface="Alegreya Sans SC"/>
+                <a:sym typeface="Alegreya Sans SC"/>
+                <a:hlinkClick r:id="rId5" tooltip="https://www.geeksforgeeks.org/computer-networks/rsa-algorithm-cryptography/"/>
+              </a:rPr>
+              <a:t>https</a:t>
+            </a:r>
+            <a:r>
+              <a:rPr lang="en-US" sz="2400" u="sng" dirty="0">
+                <a:solidFill>
+                  <a:srgbClr val="1800AD"/>
+                </a:solidFill>
+                <a:latin typeface="Candara" panose="020E0502030303020204" pitchFamily="34" charset="0"/>
+                <a:ea typeface="Alegreya Sans SC"/>
+                <a:cs typeface="Alegreya Sans SC"/>
+                <a:sym typeface="Alegreya Sans SC"/>
+                <a:hlinkClick r:id="rId5" tooltip="https://www.geeksforgeeks.org/computer-networks/rsa-algorithm-cryptography/"/>
+              </a:rPr>
+              <a:t>://www.geeksforgeeks.org/computer-networks/rsa-algorithm-cryptography/</a:t>
+            </a:r>
+          </a:p>
+          <a:p>
+            <a:pPr indent="-457200" algn="l">
               <a:lnSpc>
                 <a:spcPts val="2568"/>
               </a:lnSpc>
@@ -9225,56 +8934,19 @@
                 <a:spcPct val="0"/>
               </a:spcBef>
             </a:pPr>
-            <a:endParaRPr lang="en-US" sz="2400" u="sng">
+            <a:endParaRPr lang="en-US" sz="2400" u="sng" dirty="0">
               <a:solidFill>
                 <a:srgbClr val="1800AD"/>
               </a:solidFill>
-              <a:latin typeface="Alegreya Sans SC"/>
+              <a:latin typeface="Candara" panose="020E0502030303020204" pitchFamily="34" charset="0"/>
               <a:ea typeface="Alegreya Sans SC"/>
               <a:cs typeface="Alegreya Sans SC"/>
               <a:sym typeface="Alegreya Sans SC"/>
-              <a:hlinkClick r:id="rId7" tooltip="https://community.rsa.com/s/article/RSA-cryptography-and-NIST-guidance"/>
+              <a:hlinkClick r:id="rId5" tooltip="https://www.geeksforgeeks.org/computer-networks/rsa-algorithm-cryptography/"/>
             </a:endParaRPr>
           </a:p>
           <a:p>
-            <a:pPr marL="518160" lvl="1" indent="-259080" algn="l">
-              <a:lnSpc>
-                <a:spcPts val="2568"/>
-              </a:lnSpc>
-              <a:spcBef>
-                <a:spcPct val="0"/>
-              </a:spcBef>
-              <a:buFont typeface="Arial"/>
-              <a:buChar char="•"/>
-            </a:pPr>
-            <a:r>
-              <a:rPr lang="en-US" sz="2400">
-                <a:solidFill>
-                  <a:srgbClr val="000000"/>
-                </a:solidFill>
-                <a:latin typeface="Alegreya Sans SC"/>
-                <a:ea typeface="Alegreya Sans SC"/>
-                <a:cs typeface="Alegreya Sans SC"/>
-                <a:sym typeface="Alegreya Sans SC"/>
-              </a:rPr>
-              <a:t>•Tucker, A. (2024, September 30). RSA encryption: How the RSA algorithm works and why it matters. SecureW2. </a:t>
-            </a:r>
-            <a:r>
-              <a:rPr lang="en-US" sz="2400" u="sng">
-                <a:solidFill>
-                  <a:srgbClr val="1800AD"/>
-                </a:solidFill>
-                <a:latin typeface="Alegreya Sans SC"/>
-                <a:ea typeface="Alegreya Sans SC"/>
-                <a:cs typeface="Alegreya Sans SC"/>
-                <a:sym typeface="Alegreya Sans SC"/>
-                <a:hlinkClick r:id="rId8" tooltip="https://securew2.com/blog/what-is-rsa-asymmetric-encryption"/>
-              </a:rPr>
-              <a:t>https://securew2.com/blog/what-is-rsa-asymmetric-encryption</a:t>
-            </a:r>
-          </a:p>
-          <a:p>
-            <a:pPr algn="l">
+            <a:pPr marL="259080" lvl="1" indent="-457200" algn="l">
               <a:lnSpc>
                 <a:spcPts val="2568"/>
               </a:lnSpc>
@@ -9282,46 +8954,239 @@
                 <a:spcPct val="0"/>
               </a:spcBef>
             </a:pPr>
-            <a:endParaRPr lang="en-US" sz="2400" u="sng">
-              <a:solidFill>
-                <a:srgbClr val="1800AD"/>
-              </a:solidFill>
-              <a:latin typeface="Alegreya Sans SC"/>
-              <a:ea typeface="Alegreya Sans SC"/>
-              <a:cs typeface="Alegreya Sans SC"/>
-              <a:sym typeface="Alegreya Sans SC"/>
-              <a:hlinkClick r:id="rId8" tooltip="https://securew2.com/blog/what-is-rsa-asymmetric-encryption"/>
-            </a:endParaRPr>
-          </a:p>
-          <a:p>
-            <a:pPr marL="518160" lvl="1" indent="-259080" algn="l">
+            <a:r>
+              <a:rPr lang="en-US" sz="2400" dirty="0">
+                <a:solidFill>
+                  <a:srgbClr val="000000"/>
+                </a:solidFill>
+                <a:latin typeface="Candara" panose="020E0502030303020204" pitchFamily="34" charset="0"/>
+                <a:ea typeface="Alegreya Sans SC"/>
+                <a:cs typeface="Alegreya Sans SC"/>
+                <a:sym typeface="Alegreya Sans SC"/>
+              </a:rPr>
+              <a:t>Lebeaux, B., &amp; Lebeaux, B. (2026, September 17). Setting the record straight on quantum computing and RSA encryption. RSA. </a:t>
+            </a:r>
+            <a:r>
+              <a:rPr lang="en-US" sz="2400" u="sng" dirty="0">
+                <a:solidFill>
+                  <a:srgbClr val="1800AD"/>
+                </a:solidFill>
+                <a:latin typeface="Candara" panose="020E0502030303020204" pitchFamily="34" charset="0"/>
+                <a:ea typeface="Alegreya Sans SC"/>
+                <a:cs typeface="Alegreya Sans SC"/>
+                <a:sym typeface="Alegreya Sans SC"/>
+                <a:hlinkClick r:id="rId6" tooltip="https://www.rsa.com/resources/blog/zero-trust/setting-the-record-straight-on-quantum-computing-and-rsa-encryption/"/>
+              </a:rPr>
+              <a:t>https://www.rsa.com/resources/blog/zero-trust/setting-the-record-straight-on- quantum- computing-and-</a:t>
+            </a:r>
+            <a:r>
+              <a:rPr lang="en-US" sz="2400" u="sng" dirty="0" err="1">
+                <a:solidFill>
+                  <a:srgbClr val="1800AD"/>
+                </a:solidFill>
+                <a:latin typeface="Candara" panose="020E0502030303020204" pitchFamily="34" charset="0"/>
+                <a:ea typeface="Alegreya Sans SC"/>
+                <a:cs typeface="Alegreya Sans SC"/>
+                <a:sym typeface="Alegreya Sans SC"/>
+                <a:hlinkClick r:id="rId6" tooltip="https://www.rsa.com/resources/blog/zero-trust/setting-the-record-straight-on-quantum-computing-and-rsa-encryption/"/>
+              </a:rPr>
+              <a:t>rsa</a:t>
+            </a:r>
+            <a:r>
+              <a:rPr lang="en-US" sz="2400" u="sng" dirty="0">
+                <a:solidFill>
+                  <a:srgbClr val="1800AD"/>
+                </a:solidFill>
+                <a:latin typeface="Candara" panose="020E0502030303020204" pitchFamily="34" charset="0"/>
+                <a:ea typeface="Alegreya Sans SC"/>
+                <a:cs typeface="Alegreya Sans SC"/>
+                <a:sym typeface="Alegreya Sans SC"/>
+                <a:hlinkClick r:id="rId6" tooltip="https://www.rsa.com/resources/blog/zero-trust/setting-the-record-straight-on-quantum-computing-and-rsa-encryption/"/>
+              </a:rPr>
+              <a:t>-encryption/</a:t>
+            </a:r>
+          </a:p>
+          <a:p>
+            <a:pPr indent="-457200" algn="l">
               <a:lnSpc>
                 <a:spcPts val="2568"/>
               </a:lnSpc>
               <a:spcBef>
                 <a:spcPct val="0"/>
               </a:spcBef>
-              <a:buFont typeface="Arial"/>
-              <a:buChar char="•"/>
             </a:pPr>
-            <a:r>
-              <a:rPr lang="en-US" sz="2400">
+            <a:endParaRPr lang="en-US" sz="2400" u="sng" dirty="0">
+              <a:solidFill>
+                <a:srgbClr val="1800AD"/>
+              </a:solidFill>
+              <a:latin typeface="Candara" panose="020E0502030303020204" pitchFamily="34" charset="0"/>
+              <a:ea typeface="Alegreya Sans SC"/>
+              <a:cs typeface="Alegreya Sans SC"/>
+              <a:sym typeface="Alegreya Sans SC"/>
+              <a:hlinkClick r:id="rId6" tooltip="https://www.rsa.com/resources/blog/zero-trust/setting-the-record-straight-on-quantum-computing-and-rsa-encryption/"/>
+            </a:endParaRPr>
+          </a:p>
+          <a:p>
+            <a:pPr marL="259080" lvl="1" indent="-457200" algn="l">
+              <a:lnSpc>
+                <a:spcPts val="2568"/>
+              </a:lnSpc>
+              <a:spcBef>
+                <a:spcPct val="0"/>
+              </a:spcBef>
+            </a:pPr>
+            <a:r>
+              <a:rPr lang="en-US" sz="2400" dirty="0">
                 <a:solidFill>
                   <a:srgbClr val="000000"/>
                 </a:solidFill>
-                <a:latin typeface="Alegreya Sans SC"/>
+                <a:latin typeface="Candara" panose="020E0502030303020204" pitchFamily="34" charset="0"/>
                 <a:ea typeface="Alegreya Sans SC"/>
                 <a:cs typeface="Alegreya Sans SC"/>
                 <a:sym typeface="Alegreya Sans SC"/>
               </a:rPr>
-              <a:t>•Understanding the SSH encryption and connection process | DigitalOcean. (n.d.). </a:t>
-            </a:r>
-            <a:r>
-              <a:rPr lang="en-US" sz="2400" u="sng">
+              <a:t>RSA Community. (n.d.). </a:t>
+            </a:r>
+            <a:r>
+              <a:rPr lang="en-US" sz="2400" u="sng" dirty="0">
                 <a:solidFill>
                   <a:srgbClr val="1800AD"/>
                 </a:solidFill>
-                <a:latin typeface="Alegreya Sans SC"/>
+                <a:latin typeface="Candara" panose="020E0502030303020204" pitchFamily="34" charset="0"/>
+                <a:ea typeface="Alegreya Sans SC"/>
+                <a:cs typeface="Alegreya Sans SC"/>
+                <a:sym typeface="Alegreya Sans SC"/>
+                <a:hlinkClick r:id="rId7" tooltip="https://community.rsa.com/s/article/RSA-cryptography-and-NIST-guidance"/>
+              </a:rPr>
+              <a:t>https://community.rsa.com/s/article/RSA-cryptography-and-NIST-guidance</a:t>
+            </a:r>
+          </a:p>
+          <a:p>
+            <a:pPr indent="-457200" algn="l">
+              <a:lnSpc>
+                <a:spcPts val="2568"/>
+              </a:lnSpc>
+              <a:spcBef>
+                <a:spcPct val="0"/>
+              </a:spcBef>
+            </a:pPr>
+            <a:endParaRPr lang="en-US" sz="2400" u="sng" dirty="0">
+              <a:solidFill>
+                <a:srgbClr val="1800AD"/>
+              </a:solidFill>
+              <a:latin typeface="Candara" panose="020E0502030303020204" pitchFamily="34" charset="0"/>
+              <a:ea typeface="Alegreya Sans SC"/>
+              <a:cs typeface="Alegreya Sans SC"/>
+              <a:sym typeface="Alegreya Sans SC"/>
+              <a:hlinkClick r:id="rId7" tooltip="https://community.rsa.com/s/article/RSA-cryptography-and-NIST-guidance"/>
+            </a:endParaRPr>
+          </a:p>
+          <a:p>
+            <a:pPr marL="259080" lvl="1" indent="-457200" algn="l">
+              <a:lnSpc>
+                <a:spcPts val="2568"/>
+              </a:lnSpc>
+              <a:spcBef>
+                <a:spcPct val="0"/>
+              </a:spcBef>
+            </a:pPr>
+            <a:r>
+              <a:rPr lang="en-US" sz="2400" dirty="0">
+                <a:solidFill>
+                  <a:srgbClr val="000000"/>
+                </a:solidFill>
+                <a:latin typeface="Candara" panose="020E0502030303020204" pitchFamily="34" charset="0"/>
+                <a:ea typeface="Alegreya Sans SC"/>
+                <a:cs typeface="Alegreya Sans SC"/>
+                <a:sym typeface="Alegreya Sans SC"/>
+              </a:rPr>
+              <a:t>Tucker, A. (2024, September 30). RSA encryption: How the RSA algorithm works and why it matters. SecureW2. </a:t>
+            </a:r>
+            <a:r>
+              <a:rPr lang="en-US" sz="2400" u="sng" dirty="0">
+                <a:solidFill>
+                  <a:srgbClr val="1800AD"/>
+                </a:solidFill>
+                <a:latin typeface="Candara" panose="020E0502030303020204" pitchFamily="34" charset="0"/>
+                <a:ea typeface="Alegreya Sans SC"/>
+                <a:cs typeface="Alegreya Sans SC"/>
+                <a:sym typeface="Alegreya Sans SC"/>
+                <a:hlinkClick r:id="rId8" tooltip="https://securew2.com/blog/what-is-rsa-asymmetric-encryption"/>
+              </a:rPr>
+              <a:t>https://securew2.com/blog/what-is-rsa-asymmetric-encryption</a:t>
+            </a:r>
+          </a:p>
+          <a:p>
+            <a:pPr indent="-457200" algn="l">
+              <a:lnSpc>
+                <a:spcPts val="2568"/>
+              </a:lnSpc>
+              <a:spcBef>
+                <a:spcPct val="0"/>
+              </a:spcBef>
+            </a:pPr>
+            <a:endParaRPr lang="en-US" sz="2400" u="sng" dirty="0">
+              <a:solidFill>
+                <a:srgbClr val="1800AD"/>
+              </a:solidFill>
+              <a:latin typeface="Candara" panose="020E0502030303020204" pitchFamily="34" charset="0"/>
+              <a:ea typeface="Alegreya Sans SC"/>
+              <a:cs typeface="Alegreya Sans SC"/>
+              <a:sym typeface="Alegreya Sans SC"/>
+              <a:hlinkClick r:id="rId8" tooltip="https://securew2.com/blog/what-is-rsa-asymmetric-encryption"/>
+            </a:endParaRPr>
+          </a:p>
+          <a:p>
+            <a:pPr marL="259080" lvl="1" indent="-457200" algn="l">
+              <a:lnSpc>
+                <a:spcPts val="2568"/>
+              </a:lnSpc>
+              <a:spcBef>
+                <a:spcPct val="0"/>
+              </a:spcBef>
+            </a:pPr>
+            <a:r>
+              <a:rPr lang="en-US" sz="2400" dirty="0">
+                <a:solidFill>
+                  <a:srgbClr val="000000"/>
+                </a:solidFill>
+                <a:latin typeface="Candara" panose="020E0502030303020204" pitchFamily="34" charset="0"/>
+                <a:ea typeface="Alegreya Sans SC"/>
+                <a:cs typeface="Alegreya Sans SC"/>
+                <a:sym typeface="Alegreya Sans SC"/>
+              </a:rPr>
+              <a:t>Understanding the SSH encryption and connection process | </a:t>
+            </a:r>
+            <a:r>
+              <a:rPr lang="en-US" sz="2400" dirty="0" err="1">
+                <a:solidFill>
+                  <a:srgbClr val="000000"/>
+                </a:solidFill>
+                <a:latin typeface="Candara" panose="020E0502030303020204" pitchFamily="34" charset="0"/>
+                <a:ea typeface="Alegreya Sans SC"/>
+                <a:cs typeface="Alegreya Sans SC"/>
+                <a:sym typeface="Alegreya Sans SC"/>
+              </a:rPr>
+              <a:t>DigitalOcean</a:t>
+            </a:r>
+            <a:r>
+              <a:rPr lang="en-US" sz="2400" dirty="0">
+                <a:solidFill>
+                  <a:srgbClr val="000000"/>
+                </a:solidFill>
+                <a:latin typeface="Candara" panose="020E0502030303020204" pitchFamily="34" charset="0"/>
+                <a:ea typeface="Alegreya Sans SC"/>
+                <a:cs typeface="Alegreya Sans SC"/>
+                <a:sym typeface="Alegreya Sans SC"/>
+              </a:rPr>
+              <a:t>. (n.d.). </a:t>
+            </a:r>
+            <a:r>
+              <a:rPr lang="en-US" sz="2400" u="sng" dirty="0">
+                <a:solidFill>
+                  <a:srgbClr val="1800AD"/>
+                </a:solidFill>
+                <a:latin typeface="Candara" panose="020E0502030303020204" pitchFamily="34" charset="0"/>
                 <a:ea typeface="Alegreya Sans SC"/>
                 <a:cs typeface="Alegreya Sans SC"/>
                 <a:sym typeface="Alegreya Sans SC"/>

</xml_diff>

<commit_message>
Updated with the changes Adrian suggested
</commit_message>
<xml_diff>
--- a/RSA Encryption.pptx
+++ b/RSA Encryption.pptx
@@ -332,7 +332,7 @@
             <a:fld id="{1D8BD707-D9CF-40AE-B4C6-C98DA3205C09}" type="datetimeFigureOut">
               <a:rPr lang="en-US" smtClean="0"/>
               <a:pPr/>
-              <a:t>10/14/2026</a:t>
+              <a:t>10/15/2026</a:t>
             </a:fld>
             <a:endParaRPr lang="en-US"/>
           </a:p>
@@ -497,7 +497,7 @@
             <a:fld id="{1D8BD707-D9CF-40AE-B4C6-C98DA3205C09}" type="datetimeFigureOut">
               <a:rPr lang="en-US" smtClean="0"/>
               <a:pPr/>
-              <a:t>10/14/2026</a:t>
+              <a:t>10/15/2026</a:t>
             </a:fld>
             <a:endParaRPr lang="en-US"/>
           </a:p>
@@ -672,7 +672,7 @@
             <a:fld id="{1D8BD707-D9CF-40AE-B4C6-C98DA3205C09}" type="datetimeFigureOut">
               <a:rPr lang="en-US" smtClean="0"/>
               <a:pPr/>
-              <a:t>10/14/2026</a:t>
+              <a:t>10/15/2026</a:t>
             </a:fld>
             <a:endParaRPr lang="en-US"/>
           </a:p>
@@ -837,7 +837,7 @@
             <a:fld id="{1D8BD707-D9CF-40AE-B4C6-C98DA3205C09}" type="datetimeFigureOut">
               <a:rPr lang="en-US" smtClean="0"/>
               <a:pPr/>
-              <a:t>10/14/2026</a:t>
+              <a:t>10/15/2026</a:t>
             </a:fld>
             <a:endParaRPr lang="en-US"/>
           </a:p>
@@ -1079,7 +1079,7 @@
             <a:fld id="{1D8BD707-D9CF-40AE-B4C6-C98DA3205C09}" type="datetimeFigureOut">
               <a:rPr lang="en-US" smtClean="0"/>
               <a:pPr/>
-              <a:t>10/14/2026</a:t>
+              <a:t>10/15/2026</a:t>
             </a:fld>
             <a:endParaRPr lang="en-US"/>
           </a:p>
@@ -1361,7 +1361,7 @@
             <a:fld id="{1D8BD707-D9CF-40AE-B4C6-C98DA3205C09}" type="datetimeFigureOut">
               <a:rPr lang="en-US" smtClean="0"/>
               <a:pPr/>
-              <a:t>10/14/2026</a:t>
+              <a:t>10/15/2026</a:t>
             </a:fld>
             <a:endParaRPr lang="en-US"/>
           </a:p>
@@ -1777,7 +1777,7 @@
             <a:fld id="{1D8BD707-D9CF-40AE-B4C6-C98DA3205C09}" type="datetimeFigureOut">
               <a:rPr lang="en-US" smtClean="0"/>
               <a:pPr/>
-              <a:t>10/14/2026</a:t>
+              <a:t>10/15/2026</a:t>
             </a:fld>
             <a:endParaRPr lang="en-US"/>
           </a:p>
@@ -1891,7 +1891,7 @@
             <a:fld id="{1D8BD707-D9CF-40AE-B4C6-C98DA3205C09}" type="datetimeFigureOut">
               <a:rPr lang="en-US" smtClean="0"/>
               <a:pPr/>
-              <a:t>10/14/2026</a:t>
+              <a:t>10/15/2026</a:t>
             </a:fld>
             <a:endParaRPr lang="en-US"/>
           </a:p>
@@ -1983,7 +1983,7 @@
             <a:fld id="{1D8BD707-D9CF-40AE-B4C6-C98DA3205C09}" type="datetimeFigureOut">
               <a:rPr lang="en-US" smtClean="0"/>
               <a:pPr/>
-              <a:t>10/14/2026</a:t>
+              <a:t>10/15/2026</a:t>
             </a:fld>
             <a:endParaRPr lang="en-US"/>
           </a:p>
@@ -2255,7 +2255,7 @@
             <a:fld id="{1D8BD707-D9CF-40AE-B4C6-C98DA3205C09}" type="datetimeFigureOut">
               <a:rPr lang="en-US" smtClean="0"/>
               <a:pPr/>
-              <a:t>10/14/2026</a:t>
+              <a:t>10/15/2026</a:t>
             </a:fld>
             <a:endParaRPr lang="en-US"/>
           </a:p>
@@ -2504,7 +2504,7 @@
             <a:fld id="{1D8BD707-D9CF-40AE-B4C6-C98DA3205C09}" type="datetimeFigureOut">
               <a:rPr lang="en-US" smtClean="0"/>
               <a:pPr/>
-              <a:t>10/14/2026</a:t>
+              <a:t>10/15/2026</a:t>
             </a:fld>
             <a:endParaRPr lang="en-US"/>
           </a:p>
@@ -2712,7 +2712,7 @@
             <a:fld id="{1D8BD707-D9CF-40AE-B4C6-C98DA3205C09}" type="datetimeFigureOut">
               <a:rPr lang="en-US" smtClean="0"/>
               <a:pPr/>
-              <a:t>10/14/2026</a:t>
+              <a:t>10/15/2026</a:t>
             </a:fld>
             <a:endParaRPr lang="en-US"/>
           </a:p>
@@ -4014,7 +4014,7 @@
         <p:grpSpPr>
           <a:xfrm>
             <a:off x="271890" y="3699244"/>
-            <a:ext cx="9382528" cy="6360147"/>
+            <a:ext cx="9634110" cy="5887485"/>
             <a:chOff x="0" y="0"/>
             <a:chExt cx="2471118" cy="1675100"/>
           </a:xfrm>
@@ -4186,7 +4186,7 @@
         <p:spPr>
           <a:xfrm>
             <a:off x="578153" y="4072886"/>
-            <a:ext cx="9076264" cy="5656485"/>
+            <a:ext cx="9076264" cy="5181996"/>
           </a:xfrm>
           <a:prstGeom prst="rect">
             <a:avLst/>
@@ -4198,10 +4198,12 @@
           </a:bodyPr>
           <a:lstStyle/>
           <a:p>
-            <a:pPr algn="l">
+            <a:pPr marL="342900" indent="-342900" algn="l">
               <a:lnSpc>
                 <a:spcPts val="3696"/>
               </a:lnSpc>
+              <a:buFont typeface="Arial" panose="020B0604020202020204" pitchFamily="34" charset="0"/>
+              <a:buChar char="•"/>
             </a:pPr>
             <a:r>
               <a:rPr lang="en-US" sz="2400" dirty="0">
@@ -4217,10 +4219,12 @@
             </a:r>
           </a:p>
           <a:p>
-            <a:pPr algn="l">
+            <a:pPr marL="342900" indent="-342900" algn="l">
               <a:lnSpc>
                 <a:spcPts val="3696"/>
               </a:lnSpc>
+              <a:buFont typeface="Arial" panose="020B0604020202020204" pitchFamily="34" charset="0"/>
+              <a:buChar char="•"/>
             </a:pPr>
             <a:r>
               <a:rPr lang="en-US" sz="2400" dirty="0">
@@ -4236,10 +4240,12 @@
             </a:r>
           </a:p>
           <a:p>
-            <a:pPr algn="l">
+            <a:pPr marL="342900" indent="-342900" algn="l">
               <a:lnSpc>
                 <a:spcPts val="3696"/>
               </a:lnSpc>
+              <a:buFont typeface="Arial" panose="020B0604020202020204" pitchFamily="34" charset="0"/>
+              <a:buChar char="•"/>
             </a:pPr>
             <a:r>
               <a:rPr lang="en-US" sz="2400" dirty="0">
@@ -4260,22 +4266,6 @@
                 <a:spcPts val="3696"/>
               </a:lnSpc>
             </a:pPr>
-            <a:endParaRPr lang="en-US" sz="2400" dirty="0">
-              <a:solidFill>
-                <a:srgbClr val="000000"/>
-              </a:solidFill>
-              <a:latin typeface="Candara" panose="020E0502030303020204" pitchFamily="34" charset="0"/>
-              <a:ea typeface="Aileron"/>
-              <a:cs typeface="Aileron"/>
-              <a:sym typeface="Aileron"/>
-            </a:endParaRPr>
-          </a:p>
-          <a:p>
-            <a:pPr algn="l">
-              <a:lnSpc>
-                <a:spcPts val="3696"/>
-              </a:lnSpc>
-            </a:pPr>
             <a:r>
               <a:rPr lang="en-US" sz="2400" dirty="0">
                 <a:solidFill>
@@ -4290,7 +4280,7 @@
             </a:r>
           </a:p>
           <a:p>
-            <a:pPr algn="l">
+            <a:pPr lvl="1">
               <a:lnSpc>
                 <a:spcPts val="3696"/>
               </a:lnSpc>
@@ -4305,11 +4295,11 @@
                 <a:cs typeface="Aileron"/>
                 <a:sym typeface="Aileron"/>
               </a:rPr>
-              <a:t>1. Make a key pair</a:t>
-            </a:r>
-          </a:p>
-          <a:p>
-            <a:pPr algn="l">
+              <a:t>1.	Make a key pair</a:t>
+            </a:r>
+          </a:p>
+          <a:p>
+            <a:pPr lvl="1">
               <a:lnSpc>
                 <a:spcPts val="3696"/>
               </a:lnSpc>
@@ -4324,11 +4314,11 @@
                 <a:cs typeface="Aileron"/>
                 <a:sym typeface="Aileron"/>
               </a:rPr>
-              <a:t>2. Send our recipient the public key while keeping the private key</a:t>
-            </a:r>
-          </a:p>
-          <a:p>
-            <a:pPr algn="l">
+              <a:t>2.	Send our recipient the public key while keeping the private key</a:t>
+            </a:r>
+          </a:p>
+          <a:p>
+            <a:pPr lvl="1">
               <a:lnSpc>
                 <a:spcPts val="3696"/>
               </a:lnSpc>
@@ -4343,11 +4333,11 @@
                 <a:cs typeface="Aileron"/>
                 <a:sym typeface="Aileron"/>
               </a:rPr>
-              <a:t>3. Recipient uses the public key to encrypt and send their own public key over</a:t>
-            </a:r>
-          </a:p>
-          <a:p>
-            <a:pPr algn="l">
+              <a:t>3.	Recipient uses the public key to encrypt and send their own public key over</a:t>
+            </a:r>
+          </a:p>
+          <a:p>
+            <a:pPr lvl="1">
               <a:lnSpc>
                 <a:spcPts val="3696"/>
               </a:lnSpc>
@@ -4362,11 +4352,11 @@
                 <a:cs typeface="Aileron"/>
                 <a:sym typeface="Aileron"/>
               </a:rPr>
-              <a:t>4. Use our own private key to decrypt their public key</a:t>
-            </a:r>
-          </a:p>
-          <a:p>
-            <a:pPr algn="l">
+              <a:t>4.	Use our own private key to decrypt their public key</a:t>
+            </a:r>
+          </a:p>
+          <a:p>
+            <a:pPr lvl="1">
               <a:lnSpc>
                 <a:spcPts val="3696"/>
               </a:lnSpc>
@@ -4452,8 +4442,8 @@
         </p:blipFill>
         <p:spPr>
           <a:xfrm>
-            <a:off x="10123745" y="3554583"/>
-            <a:ext cx="9885691" cy="5538695"/>
+            <a:off x="10439400" y="3944580"/>
+            <a:ext cx="9634114" cy="5397743"/>
           </a:xfrm>
           <a:prstGeom prst="rect">
             <a:avLst/>
@@ -5056,10 +5046,10 @@
         </p:nvGrpSpPr>
         <p:grpSpPr>
           <a:xfrm>
-            <a:off x="345390" y="6302744"/>
-            <a:ext cx="6543502" cy="3594010"/>
-            <a:chOff x="0" y="0"/>
-            <a:chExt cx="1723392" cy="946571"/>
+            <a:off x="519025" y="3823088"/>
+            <a:ext cx="7151668" cy="3542925"/>
+            <a:chOff x="0" y="-38100"/>
+            <a:chExt cx="1723392" cy="984671"/>
           </a:xfrm>
         </p:grpSpPr>
         <p:sp>
@@ -5305,8 +5295,8 @@
         </p:nvGrpSpPr>
         <p:grpSpPr>
           <a:xfrm>
-            <a:off x="7086203" y="6285341"/>
-            <a:ext cx="5629018" cy="2785546"/>
+            <a:off x="7936157" y="3967749"/>
+            <a:ext cx="5494300" cy="3398264"/>
             <a:chOff x="0" y="0"/>
             <a:chExt cx="1482540" cy="733642"/>
           </a:xfrm>
@@ -5478,137 +5468,6 @@
           </a:p>
         </p:txBody>
       </p:sp>
-      <p:grpSp>
-        <p:nvGrpSpPr>
-          <p:cNvPr id="12" name="Group 12"/>
-          <p:cNvGrpSpPr/>
-          <p:nvPr/>
-        </p:nvGrpSpPr>
-        <p:grpSpPr>
-          <a:xfrm>
-            <a:off x="345390" y="3790450"/>
-            <a:ext cx="12104368" cy="2281105"/>
-            <a:chOff x="0" y="0"/>
-            <a:chExt cx="3393871" cy="600785"/>
-          </a:xfrm>
-        </p:grpSpPr>
-        <p:sp>
-          <p:nvSpPr>
-            <p:cNvPr id="13" name="Freeform 13"/>
-            <p:cNvSpPr/>
-            <p:nvPr/>
-          </p:nvSpPr>
-          <p:spPr>
-            <a:xfrm>
-              <a:off x="0" y="0"/>
-              <a:ext cx="3393870" cy="600785"/>
-            </a:xfrm>
-            <a:custGeom>
-              <a:avLst/>
-              <a:gdLst/>
-              <a:ahLst/>
-              <a:cxnLst/>
-              <a:rect l="l" t="t" r="r" b="b"/>
-              <a:pathLst>
-                <a:path w="3393870" h="600785">
-                  <a:moveTo>
-                    <a:pt x="30641" y="0"/>
-                  </a:moveTo>
-                  <a:lnTo>
-                    <a:pt x="3363230" y="0"/>
-                  </a:lnTo>
-                  <a:cubicBezTo>
-                    <a:pt x="3371356" y="0"/>
-                    <a:pt x="3379150" y="3228"/>
-                    <a:pt x="3384896" y="8974"/>
-                  </a:cubicBezTo>
-                  <a:cubicBezTo>
-                    <a:pt x="3390642" y="14721"/>
-                    <a:pt x="3393870" y="22514"/>
-                    <a:pt x="3393870" y="30641"/>
-                  </a:cubicBezTo>
-                  <a:lnTo>
-                    <a:pt x="3393870" y="570144"/>
-                  </a:lnTo>
-                  <a:cubicBezTo>
-                    <a:pt x="3393870" y="578271"/>
-                    <a:pt x="3390642" y="586064"/>
-                    <a:pt x="3384896" y="591810"/>
-                  </a:cubicBezTo>
-                  <a:cubicBezTo>
-                    <a:pt x="3379150" y="597557"/>
-                    <a:pt x="3371356" y="600785"/>
-                    <a:pt x="3363230" y="600785"/>
-                  </a:cubicBezTo>
-                  <a:lnTo>
-                    <a:pt x="30641" y="600785"/>
-                  </a:lnTo>
-                  <a:cubicBezTo>
-                    <a:pt x="13718" y="600785"/>
-                    <a:pt x="0" y="587067"/>
-                    <a:pt x="0" y="570144"/>
-                  </a:cubicBezTo>
-                  <a:lnTo>
-                    <a:pt x="0" y="30641"/>
-                  </a:lnTo>
-                  <a:cubicBezTo>
-                    <a:pt x="0" y="22514"/>
-                    <a:pt x="3228" y="14721"/>
-                    <a:pt x="8974" y="8974"/>
-                  </a:cubicBezTo>
-                  <a:cubicBezTo>
-                    <a:pt x="14721" y="3228"/>
-                    <a:pt x="22514" y="0"/>
-                    <a:pt x="30641" y="0"/>
-                  </a:cubicBezTo>
-                  <a:close/>
-                </a:path>
-              </a:pathLst>
-            </a:custGeom>
-            <a:solidFill>
-              <a:srgbClr val="DBE0ED"/>
-            </a:solidFill>
-          </p:spPr>
-          <p:txBody>
-            <a:bodyPr/>
-            <a:lstStyle/>
-            <a:p>
-              <a:endParaRPr lang="en-CA"/>
-            </a:p>
-          </p:txBody>
-        </p:sp>
-        <p:sp>
-          <p:nvSpPr>
-            <p:cNvPr id="14" name="TextBox 14"/>
-            <p:cNvSpPr txBox="1"/>
-            <p:nvPr/>
-          </p:nvSpPr>
-          <p:spPr>
-            <a:xfrm>
-              <a:off x="0" y="-38100"/>
-              <a:ext cx="3393871" cy="638885"/>
-            </a:xfrm>
-            <a:prstGeom prst="rect">
-              <a:avLst/>
-            </a:prstGeom>
-          </p:spPr>
-          <p:txBody>
-            <a:bodyPr lIns="50800" tIns="50800" rIns="50800" bIns="50800" rtlCol="0" anchor="ctr"/>
-            <a:lstStyle/>
-            <a:p>
-              <a:pPr algn="ctr">
-                <a:lnSpc>
-                  <a:spcPts val="2659"/>
-                </a:lnSpc>
-                <a:spcBef>
-                  <a:spcPct val="0"/>
-                </a:spcBef>
-              </a:pPr>
-              <a:endParaRPr/>
-            </a:p>
-          </p:txBody>
-        </p:sp>
-      </p:grpSp>
       <p:sp>
         <p:nvSpPr>
           <p:cNvPr id="16" name="TextBox 16"/>
@@ -5652,159 +5511,21 @@
       </p:sp>
       <p:sp>
         <p:nvSpPr>
-          <p:cNvPr id="17" name="TextBox 17"/>
+          <p:cNvPr id="18" name="TextBox 18"/>
           <p:cNvSpPr txBox="1"/>
           <p:nvPr/>
         </p:nvSpPr>
         <p:spPr>
           <a:xfrm>
-            <a:off x="544497" y="3958213"/>
-            <a:ext cx="12886102" cy="2335063"/>
+            <a:off x="560482" y="4840520"/>
+            <a:ext cx="6879560" cy="2152320"/>
           </a:xfrm>
           <a:prstGeom prst="rect">
             <a:avLst/>
           </a:prstGeom>
         </p:spPr>
         <p:txBody>
-          <a:bodyPr lIns="0" tIns="0" rIns="0" bIns="0" rtlCol="0" anchor="t">
-            <a:spAutoFit/>
-          </a:bodyPr>
-          <a:lstStyle/>
-          <a:p>
-            <a:pPr>
-              <a:lnSpc>
-                <a:spcPts val="3696"/>
-              </a:lnSpc>
-            </a:pPr>
-            <a:r>
-              <a:rPr lang="en-US" sz="2400" dirty="0">
-                <a:solidFill>
-                  <a:srgbClr val="000000"/>
-                </a:solidFill>
-                <a:latin typeface="Candara" panose="020E0502030303020204" pitchFamily="34" charset="0"/>
-                <a:ea typeface="Aileron"/>
-                <a:cs typeface="Aileron"/>
-                <a:sym typeface="Aileron"/>
-              </a:rPr>
-              <a:t>Generating keys involves two very large prime numbers.</a:t>
-            </a:r>
-          </a:p>
-          <a:p>
-            <a:pPr>
-              <a:lnSpc>
-                <a:spcPts val="3696"/>
-              </a:lnSpc>
-            </a:pPr>
-            <a:r>
-              <a:rPr lang="en-US" sz="2400" dirty="0">
-                <a:solidFill>
-                  <a:srgbClr val="000000"/>
-                </a:solidFill>
-                <a:latin typeface="Candara" panose="020E0502030303020204" pitchFamily="34" charset="0"/>
-                <a:ea typeface="Aileron"/>
-                <a:cs typeface="Aileron"/>
-                <a:sym typeface="Aileron"/>
-              </a:rPr>
-              <a:t>This is done in UNIX systems by converting the output into a hexadecimal.</a:t>
-            </a:r>
-          </a:p>
-          <a:p>
-            <a:pPr>
-              <a:lnSpc>
-                <a:spcPts val="3696"/>
-              </a:lnSpc>
-            </a:pPr>
-            <a:r>
-              <a:rPr lang="en-US" sz="2400" dirty="0">
-                <a:solidFill>
-                  <a:srgbClr val="000000"/>
-                </a:solidFill>
-                <a:latin typeface="Candara" panose="020E0502030303020204" pitchFamily="34" charset="0"/>
-                <a:ea typeface="Aileron"/>
-                <a:cs typeface="Aileron"/>
-                <a:sym typeface="Aileron"/>
-              </a:rPr>
-              <a:t>How big the number depends on how many bits are received from </a:t>
-            </a:r>
-            <a:r>
-              <a:rPr lang="en-US" sz="2400" dirty="0" err="1">
-                <a:solidFill>
-                  <a:srgbClr val="000000"/>
-                </a:solidFill>
-                <a:latin typeface="Candara" panose="020E0502030303020204" pitchFamily="34" charset="0"/>
-                <a:ea typeface="Aileron"/>
-                <a:cs typeface="Aileron"/>
-                <a:sym typeface="Aileron"/>
-              </a:rPr>
-              <a:t>urandom</a:t>
-            </a:r>
-            <a:r>
-              <a:rPr lang="en-US" sz="2400" dirty="0">
-                <a:solidFill>
-                  <a:srgbClr val="000000"/>
-                </a:solidFill>
-                <a:latin typeface="Candara" panose="020E0502030303020204" pitchFamily="34" charset="0"/>
-                <a:ea typeface="Aileron"/>
-                <a:cs typeface="Aileron"/>
-                <a:sym typeface="Aileron"/>
-              </a:rPr>
-              <a:t>.</a:t>
-            </a:r>
-          </a:p>
-          <a:p>
-            <a:pPr>
-              <a:lnSpc>
-                <a:spcPts val="3696"/>
-              </a:lnSpc>
-            </a:pPr>
-            <a:r>
-              <a:rPr lang="en-US" sz="2400" dirty="0">
-                <a:solidFill>
-                  <a:srgbClr val="000000"/>
-                </a:solidFill>
-                <a:latin typeface="Candara" panose="020E0502030303020204" pitchFamily="34" charset="0"/>
-                <a:ea typeface="Aileron"/>
-                <a:cs typeface="Aileron"/>
-                <a:sym typeface="Aileron"/>
-              </a:rPr>
-              <a:t>Typical length is 2028 bits.</a:t>
-            </a:r>
-          </a:p>
-          <a:p>
-            <a:pPr>
-              <a:lnSpc>
-                <a:spcPts val="3696"/>
-              </a:lnSpc>
-            </a:pPr>
-            <a:endParaRPr lang="en-US" sz="2400" dirty="0">
-              <a:solidFill>
-                <a:srgbClr val="000000"/>
-              </a:solidFill>
-              <a:latin typeface="Candara" panose="020E0502030303020204" pitchFamily="34" charset="0"/>
-              <a:ea typeface="Aileron"/>
-              <a:cs typeface="Aileron"/>
-              <a:sym typeface="Aileron"/>
-            </a:endParaRPr>
-          </a:p>
-        </p:txBody>
-      </p:sp>
-      <p:sp>
-        <p:nvSpPr>
-          <p:cNvPr id="18" name="TextBox 18"/>
-          <p:cNvSpPr txBox="1"/>
-          <p:nvPr/>
-        </p:nvSpPr>
-        <p:spPr>
-          <a:xfrm>
-            <a:off x="623191" y="7175515"/>
-            <a:ext cx="5762267" cy="2588337"/>
-          </a:xfrm>
-          <a:prstGeom prst="rect">
-            <a:avLst/>
-          </a:prstGeom>
-        </p:spPr>
-        <p:txBody>
-          <a:bodyPr lIns="0" tIns="0" rIns="0" bIns="0" rtlCol="0" anchor="t">
+          <a:bodyPr wrap="square" lIns="0" tIns="0" rIns="0" bIns="0" rtlCol="0" anchor="t">
             <a:spAutoFit/>
           </a:bodyPr>
           <a:lstStyle/>
@@ -5914,7 +5635,7 @@
         </p:nvSpPr>
         <p:spPr>
           <a:xfrm>
-            <a:off x="2015431" y="6573535"/>
+            <a:off x="2374976" y="4271601"/>
             <a:ext cx="3203420" cy="487680"/>
           </a:xfrm>
           <a:prstGeom prst="rect">
@@ -5955,8 +5676,8 @@
         </p:nvSpPr>
         <p:spPr>
           <a:xfrm>
-            <a:off x="7228099" y="7158112"/>
-            <a:ext cx="5221659" cy="1716304"/>
+            <a:off x="8078053" y="4840520"/>
+            <a:ext cx="5221659" cy="2152320"/>
           </a:xfrm>
           <a:prstGeom prst="rect">
             <a:avLst/>
@@ -5988,7 +5709,7 @@
                 <a:cs typeface="Open Sans"/>
                 <a:sym typeface="Open Sans"/>
               </a:rPr>
-              <a:t>Private exponent “d”</a:t>
+              <a:t>Different from public key</a:t>
             </a:r>
           </a:p>
           <a:p>
@@ -6012,7 +5733,7 @@
                 <a:cs typeface="Open Sans"/>
                 <a:sym typeface="Open Sans"/>
               </a:rPr>
-              <a:t>Calculate d as the modular inverse of e</a:t>
+              <a:t>Private exponent “d”</a:t>
             </a:r>
           </a:p>
           <a:p>
@@ -6036,6 +5757,30 @@
                 <a:cs typeface="Open Sans"/>
                 <a:sym typeface="Open Sans"/>
               </a:rPr>
+              <a:t>Calculate d as the modular inverse of e</a:t>
+            </a:r>
+          </a:p>
+          <a:p>
+            <a:pPr marL="518160" lvl="1" indent="-259080">
+              <a:lnSpc>
+                <a:spcPts val="3359"/>
+              </a:lnSpc>
+              <a:spcBef>
+                <a:spcPct val="0"/>
+              </a:spcBef>
+              <a:buFont typeface="Arial"/>
+              <a:buChar char="•"/>
+            </a:pPr>
+            <a:r>
+              <a:rPr lang="en-US" sz="2400" dirty="0">
+                <a:solidFill>
+                  <a:srgbClr val="000000"/>
+                </a:solidFill>
+                <a:latin typeface="Candara" panose="020E0502030303020204" pitchFamily="34" charset="0"/>
+                <a:ea typeface="Open Sans"/>
+                <a:cs typeface="Open Sans"/>
+                <a:sym typeface="Open Sans"/>
+              </a:rPr>
               <a:t>Private key is d and n (d, n)</a:t>
             </a:r>
           </a:p>
@@ -6049,7 +5794,7 @@
         </p:nvSpPr>
         <p:spPr>
           <a:xfrm>
-            <a:off x="8299003" y="6556132"/>
+            <a:off x="9148957" y="4238540"/>
             <a:ext cx="3203420" cy="487680"/>
           </a:xfrm>
           <a:prstGeom prst="rect">
@@ -6149,8 +5894,8 @@
         </p:blipFill>
         <p:spPr>
           <a:xfrm>
-            <a:off x="14068609" y="1606056"/>
-            <a:ext cx="6126232" cy="8426840"/>
+            <a:off x="14068609" y="2008846"/>
+            <a:ext cx="5833408" cy="8024050"/>
           </a:xfrm>
           <a:prstGeom prst="rect">
             <a:avLst/>
@@ -6860,8 +6605,8 @@
         </p:blipFill>
         <p:spPr>
           <a:xfrm>
-            <a:off x="9865556" y="3621309"/>
-            <a:ext cx="9882493" cy="5189510"/>
+            <a:off x="9821616" y="3710421"/>
+            <a:ext cx="9521488" cy="4999939"/>
           </a:xfrm>
           <a:prstGeom prst="rect">
             <a:avLst/>
@@ -7205,8 +6950,8 @@
         </p:nvGrpSpPr>
         <p:grpSpPr>
           <a:xfrm>
-            <a:off x="9372600" y="3800017"/>
-            <a:ext cx="10476535" cy="5451134"/>
+            <a:off x="9570250" y="4093596"/>
+            <a:ext cx="7269950" cy="3793104"/>
             <a:chOff x="0" y="0"/>
             <a:chExt cx="2759252" cy="1435690"/>
           </a:xfrm>
@@ -7415,15 +7160,15 @@
         </p:nvSpPr>
         <p:spPr>
           <a:xfrm>
-            <a:off x="9779262" y="4011310"/>
-            <a:ext cx="9894900" cy="5181996"/>
+            <a:off x="9779262" y="4304415"/>
+            <a:ext cx="6660371" cy="3284041"/>
           </a:xfrm>
           <a:prstGeom prst="rect">
             <a:avLst/>
           </a:prstGeom>
         </p:spPr>
         <p:txBody>
-          <a:bodyPr lIns="0" tIns="0" rIns="0" bIns="0" rtlCol="0" anchor="t">
+          <a:bodyPr wrap="square" lIns="0" tIns="0" rIns="0" bIns="0" rtlCol="0" anchor="t">
             <a:spAutoFit/>
           </a:bodyPr>
           <a:lstStyle/>
@@ -7573,76 +7318,6 @@
               </a:rPr>
               <a:t>Establishes a secure session</a:t>
             </a:r>
-          </a:p>
-          <a:p>
-            <a:pPr algn="l">
-              <a:lnSpc>
-                <a:spcPts val="3696"/>
-              </a:lnSpc>
-            </a:pPr>
-            <a:endParaRPr lang="en-US" sz="2400" dirty="0">
-              <a:solidFill>
-                <a:srgbClr val="000000"/>
-              </a:solidFill>
-              <a:latin typeface="Candara" panose="020E0502030303020204" pitchFamily="34" charset="0"/>
-              <a:ea typeface="Aileron"/>
-              <a:cs typeface="Aileron"/>
-              <a:sym typeface="Aileron"/>
-            </a:endParaRPr>
-          </a:p>
-          <a:p>
-            <a:pPr algn="l">
-              <a:lnSpc>
-                <a:spcPts val="3696"/>
-              </a:lnSpc>
-            </a:pPr>
-            <a:r>
-              <a:rPr lang="en-US" sz="2400" dirty="0">
-                <a:solidFill>
-                  <a:srgbClr val="000000"/>
-                </a:solidFill>
-                <a:latin typeface="Candara" panose="020E0502030303020204" pitchFamily="34" charset="0"/>
-                <a:ea typeface="Aileron"/>
-                <a:cs typeface="Aileron"/>
-                <a:sym typeface="Aileron"/>
-              </a:rPr>
-              <a:t>Another use is OpenSSH's ssh program. </a:t>
-            </a:r>
-          </a:p>
-          <a:p>
-            <a:pPr algn="l">
-              <a:lnSpc>
-                <a:spcPts val="3696"/>
-              </a:lnSpc>
-            </a:pPr>
-            <a:r>
-              <a:rPr lang="en-US" sz="2400" dirty="0">
-                <a:solidFill>
-                  <a:srgbClr val="000000"/>
-                </a:solidFill>
-                <a:latin typeface="Candara" panose="020E0502030303020204" pitchFamily="34" charset="0"/>
-                <a:ea typeface="Aileron"/>
-                <a:cs typeface="Aileron"/>
-                <a:sym typeface="Aileron"/>
-              </a:rPr>
-              <a:t>It connects to a virtual terminal. </a:t>
-            </a:r>
-          </a:p>
-          <a:p>
-            <a:pPr algn="l">
-              <a:lnSpc>
-                <a:spcPts val="3696"/>
-              </a:lnSpc>
-            </a:pPr>
-            <a:endParaRPr lang="en-US" sz="2400" dirty="0">
-              <a:solidFill>
-                <a:srgbClr val="000000"/>
-              </a:solidFill>
-              <a:latin typeface="Candara" panose="020E0502030303020204" pitchFamily="34" charset="0"/>
-              <a:ea typeface="Aileron"/>
-              <a:cs typeface="Aileron"/>
-              <a:sym typeface="Aileron"/>
-            </a:endParaRPr>
           </a:p>
         </p:txBody>
       </p:sp>

</xml_diff>